<commit_message>
Apply syukaworld style profile to PPTX renderer
</commit_message>
<xml_diff>
--- a/outputs/pptx/ai_knowledge_institution_draft.pptx
+++ b/outputs/pptx/ai_knowledge_institution_draft.pptx
@@ -537,6 +537,26 @@
           </a:p>
           <a:p>
             <a:r>
+              <a:t>style_profile_loaded: False</a:t>
+            </a:r>
+          </a:p>
+          <a:p>
+            <a:r>
+              <a:t>style_profile_path: None</a:t>
+            </a:r>
+          </a:p>
+          <a:p>
+            <a:r>
+              <a:t>applied_font_family: Malgun Gothic</a:t>
+            </a:r>
+          </a:p>
+          <a:p>
+            <a:r>
+              <a:t>applied_fallback_font: Malgun Gothic</a:t>
+            </a:r>
+          </a:p>
+          <a:p>
+            <a:r>
               <a:t>source_slide_refs: [</a:t>
             </a:r>
           </a:p>
@@ -727,6 +747,26 @@
           </a:p>
           <a:p>
             <a:r>
+              <a:t>style_profile_loaded: False</a:t>
+            </a:r>
+          </a:p>
+          <a:p>
+            <a:r>
+              <a:t>style_profile_path: None</a:t>
+            </a:r>
+          </a:p>
+          <a:p>
+            <a:r>
+              <a:t>applied_font_family: Malgun Gothic</a:t>
+            </a:r>
+          </a:p>
+          <a:p>
+            <a:r>
+              <a:t>applied_fallback_font: Malgun Gothic</a:t>
+            </a:r>
+          </a:p>
+          <a:p>
+            <a:r>
               <a:t>source_slide_refs: [</a:t>
             </a:r>
           </a:p>
@@ -942,6 +982,26 @@
           </a:p>
           <a:p>
             <a:r>
+              <a:t>style_profile_loaded: False</a:t>
+            </a:r>
+          </a:p>
+          <a:p>
+            <a:r>
+              <a:t>style_profile_path: None</a:t>
+            </a:r>
+          </a:p>
+          <a:p>
+            <a:r>
+              <a:t>applied_font_family: Malgun Gothic</a:t>
+            </a:r>
+          </a:p>
+          <a:p>
+            <a:r>
+              <a:t>applied_fallback_font: Malgun Gothic</a:t>
+            </a:r>
+          </a:p>
+          <a:p>
+            <a:r>
               <a:t>source_slide_refs: [</a:t>
             </a:r>
           </a:p>
@@ -1147,6 +1207,26 @@
           </a:p>
           <a:p>
             <a:r>
+              <a:t>style_profile_loaded: False</a:t>
+            </a:r>
+          </a:p>
+          <a:p>
+            <a:r>
+              <a:t>style_profile_path: None</a:t>
+            </a:r>
+          </a:p>
+          <a:p>
+            <a:r>
+              <a:t>applied_font_family: Malgun Gothic</a:t>
+            </a:r>
+          </a:p>
+          <a:p>
+            <a:r>
+              <a:t>applied_fallback_font: Malgun Gothic</a:t>
+            </a:r>
+          </a:p>
+          <a:p>
+            <a:r>
               <a:t>source_slide_refs: [</a:t>
             </a:r>
           </a:p>
@@ -1337,6 +1417,26 @@
           </a:p>
           <a:p>
             <a:r>
+              <a:t>style_profile_loaded: False</a:t>
+            </a:r>
+          </a:p>
+          <a:p>
+            <a:r>
+              <a:t>style_profile_path: None</a:t>
+            </a:r>
+          </a:p>
+          <a:p>
+            <a:r>
+              <a:t>applied_font_family: Malgun Gothic</a:t>
+            </a:r>
+          </a:p>
+          <a:p>
+            <a:r>
+              <a:t>applied_fallback_font: Malgun Gothic</a:t>
+            </a:r>
+          </a:p>
+          <a:p>
+            <a:r>
               <a:t>source_slide_refs: [</a:t>
             </a:r>
           </a:p>
@@ -1527,6 +1627,26 @@
           </a:p>
           <a:p>
             <a:r>
+              <a:t>style_profile_loaded: False</a:t>
+            </a:r>
+          </a:p>
+          <a:p>
+            <a:r>
+              <a:t>style_profile_path: None</a:t>
+            </a:r>
+          </a:p>
+          <a:p>
+            <a:r>
+              <a:t>applied_font_family: Malgun Gothic</a:t>
+            </a:r>
+          </a:p>
+          <a:p>
+            <a:r>
+              <a:t>applied_fallback_font: Malgun Gothic</a:t>
+            </a:r>
+          </a:p>
+          <a:p>
+            <a:r>
               <a:t>source_slide_refs: [</a:t>
             </a:r>
           </a:p>
@@ -1742,6 +1862,26 @@
           </a:p>
           <a:p>
             <a:r>
+              <a:t>style_profile_loaded: False</a:t>
+            </a:r>
+          </a:p>
+          <a:p>
+            <a:r>
+              <a:t>style_profile_path: None</a:t>
+            </a:r>
+          </a:p>
+          <a:p>
+            <a:r>
+              <a:t>applied_font_family: Malgun Gothic</a:t>
+            </a:r>
+          </a:p>
+          <a:p>
+            <a:r>
+              <a:t>applied_fallback_font: Malgun Gothic</a:t>
+            </a:r>
+          </a:p>
+          <a:p>
+            <a:r>
               <a:t>source_slide_refs: [</a:t>
             </a:r>
           </a:p>
@@ -1963,6 +2103,26 @@
           </a:p>
           <a:p>
             <a:r>
+              <a:t>style_profile_loaded: False</a:t>
+            </a:r>
+          </a:p>
+          <a:p>
+            <a:r>
+              <a:t>style_profile_path: None</a:t>
+            </a:r>
+          </a:p>
+          <a:p>
+            <a:r>
+              <a:t>applied_font_family: Malgun Gothic</a:t>
+            </a:r>
+          </a:p>
+          <a:p>
+            <a:r>
+              <a:t>applied_fallback_font: Malgun Gothic</a:t>
+            </a:r>
+          </a:p>
+          <a:p>
+            <a:r>
               <a:t>source_slide_refs: [</a:t>
             </a:r>
           </a:p>
@@ -2178,6 +2338,26 @@
           </a:p>
           <a:p>
             <a:r>
+              <a:t>style_profile_loaded: False</a:t>
+            </a:r>
+          </a:p>
+          <a:p>
+            <a:r>
+              <a:t>style_profile_path: None</a:t>
+            </a:r>
+          </a:p>
+          <a:p>
+            <a:r>
+              <a:t>applied_font_family: Malgun Gothic</a:t>
+            </a:r>
+          </a:p>
+          <a:p>
+            <a:r>
+              <a:t>applied_fallback_font: Malgun Gothic</a:t>
+            </a:r>
+          </a:p>
+          <a:p>
+            <a:r>
               <a:t>source_slide_refs: [</a:t>
             </a:r>
           </a:p>
@@ -2403,6 +2583,26 @@
           </a:p>
           <a:p>
             <a:r>
+              <a:t>style_profile_loaded: False</a:t>
+            </a:r>
+          </a:p>
+          <a:p>
+            <a:r>
+              <a:t>style_profile_path: None</a:t>
+            </a:r>
+          </a:p>
+          <a:p>
+            <a:r>
+              <a:t>applied_font_family: Malgun Gothic</a:t>
+            </a:r>
+          </a:p>
+          <a:p>
+            <a:r>
+              <a:t>applied_fallback_font: Malgun Gothic</a:t>
+            </a:r>
+          </a:p>
+          <a:p>
+            <a:r>
               <a:t>source_slide_refs: [</a:t>
             </a:r>
           </a:p>
@@ -2618,6 +2818,26 @@
           </a:p>
           <a:p>
             <a:r>
+              <a:t>style_profile_loaded: False</a:t>
+            </a:r>
+          </a:p>
+          <a:p>
+            <a:r>
+              <a:t>style_profile_path: None</a:t>
+            </a:r>
+          </a:p>
+          <a:p>
+            <a:r>
+              <a:t>applied_font_family: Malgun Gothic</a:t>
+            </a:r>
+          </a:p>
+          <a:p>
+            <a:r>
+              <a:t>applied_fallback_font: Malgun Gothic</a:t>
+            </a:r>
+          </a:p>
+          <a:p>
+            <a:r>
               <a:t>source_slide_refs: [</a:t>
             </a:r>
           </a:p>
@@ -2818,6 +3038,26 @@
           </a:p>
           <a:p>
             <a:r>
+              <a:t>style_profile_loaded: False</a:t>
+            </a:r>
+          </a:p>
+          <a:p>
+            <a:r>
+              <a:t>style_profile_path: None</a:t>
+            </a:r>
+          </a:p>
+          <a:p>
+            <a:r>
+              <a:t>applied_font_family: Malgun Gothic</a:t>
+            </a:r>
+          </a:p>
+          <a:p>
+            <a:r>
+              <a:t>applied_fallback_font: Malgun Gothic</a:t>
+            </a:r>
+          </a:p>
+          <a:p>
+            <a:r>
               <a:t>source_slide_refs: [</a:t>
             </a:r>
           </a:p>
@@ -3033,6 +3273,26 @@
           </a:p>
           <a:p>
             <a:r>
+              <a:t>style_profile_loaded: False</a:t>
+            </a:r>
+          </a:p>
+          <a:p>
+            <a:r>
+              <a:t>style_profile_path: None</a:t>
+            </a:r>
+          </a:p>
+          <a:p>
+            <a:r>
+              <a:t>applied_font_family: Malgun Gothic</a:t>
+            </a:r>
+          </a:p>
+          <a:p>
+            <a:r>
+              <a:t>applied_fallback_font: Malgun Gothic</a:t>
+            </a:r>
+          </a:p>
+          <a:p>
+            <a:r>
               <a:t>source_slide_refs: [</a:t>
             </a:r>
           </a:p>
@@ -3223,6 +3483,26 @@
           </a:p>
           <a:p>
             <a:r>
+              <a:t>style_profile_loaded: False</a:t>
+            </a:r>
+          </a:p>
+          <a:p>
+            <a:r>
+              <a:t>style_profile_path: None</a:t>
+            </a:r>
+          </a:p>
+          <a:p>
+            <a:r>
+              <a:t>applied_font_family: Malgun Gothic</a:t>
+            </a:r>
+          </a:p>
+          <a:p>
+            <a:r>
+              <a:t>applied_fallback_font: Malgun Gothic</a:t>
+            </a:r>
+          </a:p>
+          <a:p>
+            <a:r>
               <a:t>source_slide_refs: [</a:t>
             </a:r>
           </a:p>
@@ -3438,6 +3718,26 @@
           </a:p>
           <a:p>
             <a:r>
+              <a:t>style_profile_loaded: False</a:t>
+            </a:r>
+          </a:p>
+          <a:p>
+            <a:r>
+              <a:t>style_profile_path: None</a:t>
+            </a:r>
+          </a:p>
+          <a:p>
+            <a:r>
+              <a:t>applied_font_family: Malgun Gothic</a:t>
+            </a:r>
+          </a:p>
+          <a:p>
+            <a:r>
+              <a:t>applied_fallback_font: Malgun Gothic</a:t>
+            </a:r>
+          </a:p>
+          <a:p>
+            <a:r>
               <a:t>source_slide_refs: [</a:t>
             </a:r>
           </a:p>
@@ -3663,6 +3963,26 @@
           </a:p>
           <a:p>
             <a:r>
+              <a:t>style_profile_loaded: False</a:t>
+            </a:r>
+          </a:p>
+          <a:p>
+            <a:r>
+              <a:t>style_profile_path: None</a:t>
+            </a:r>
+          </a:p>
+          <a:p>
+            <a:r>
+              <a:t>applied_font_family: Malgun Gothic</a:t>
+            </a:r>
+          </a:p>
+          <a:p>
+            <a:r>
+              <a:t>applied_fallback_font: Malgun Gothic</a:t>
+            </a:r>
+          </a:p>
+          <a:p>
+            <a:r>
               <a:t>source_slide_refs: [</a:t>
             </a:r>
           </a:p>
@@ -3863,6 +4183,26 @@
           </a:p>
           <a:p>
             <a:r>
+              <a:t>style_profile_loaded: False</a:t>
+            </a:r>
+          </a:p>
+          <a:p>
+            <a:r>
+              <a:t>style_profile_path: None</a:t>
+            </a:r>
+          </a:p>
+          <a:p>
+            <a:r>
+              <a:t>applied_font_family: Malgun Gothic</a:t>
+            </a:r>
+          </a:p>
+          <a:p>
+            <a:r>
+              <a:t>applied_fallback_font: Malgun Gothic</a:t>
+            </a:r>
+          </a:p>
+          <a:p>
+            <a:r>
               <a:t>source_slide_refs: [</a:t>
             </a:r>
           </a:p>
@@ -4138,6 +4478,26 @@
           </a:p>
           <a:p>
             <a:r>
+              <a:t>style_profile_loaded: False</a:t>
+            </a:r>
+          </a:p>
+          <a:p>
+            <a:r>
+              <a:t>style_profile_path: None</a:t>
+            </a:r>
+          </a:p>
+          <a:p>
+            <a:r>
+              <a:t>applied_font_family: Malgun Gothic</a:t>
+            </a:r>
+          </a:p>
+          <a:p>
+            <a:r>
+              <a:t>applied_fallback_font: Malgun Gothic</a:t>
+            </a:r>
+          </a:p>
+          <a:p>
+            <a:r>
               <a:t>source_slide_refs: [</a:t>
             </a:r>
           </a:p>
@@ -4328,6 +4688,26 @@
           </a:p>
           <a:p>
             <a:r>
+              <a:t>style_profile_loaded: False</a:t>
+            </a:r>
+          </a:p>
+          <a:p>
+            <a:r>
+              <a:t>style_profile_path: None</a:t>
+            </a:r>
+          </a:p>
+          <a:p>
+            <a:r>
+              <a:t>applied_font_family: Malgun Gothic</a:t>
+            </a:r>
+          </a:p>
+          <a:p>
+            <a:r>
+              <a:t>applied_fallback_font: Malgun Gothic</a:t>
+            </a:r>
+          </a:p>
+          <a:p>
+            <a:r>
               <a:t>source_slide_refs: [</a:t>
             </a:r>
           </a:p>
@@ -4518,6 +4898,26 @@
           </a:p>
           <a:p>
             <a:r>
+              <a:t>style_profile_loaded: False</a:t>
+            </a:r>
+          </a:p>
+          <a:p>
+            <a:r>
+              <a:t>style_profile_path: None</a:t>
+            </a:r>
+          </a:p>
+          <a:p>
+            <a:r>
+              <a:t>applied_font_family: Malgun Gothic</a:t>
+            </a:r>
+          </a:p>
+          <a:p>
+            <a:r>
+              <a:t>applied_fallback_font: Malgun Gothic</a:t>
+            </a:r>
+          </a:p>
+          <a:p>
+            <a:r>
               <a:t>source_slide_refs: [</a:t>
             </a:r>
           </a:p>
@@ -4723,6 +5123,26 @@
           </a:p>
           <a:p>
             <a:r>
+              <a:t>style_profile_loaded: False</a:t>
+            </a:r>
+          </a:p>
+          <a:p>
+            <a:r>
+              <a:t>style_profile_path: None</a:t>
+            </a:r>
+          </a:p>
+          <a:p>
+            <a:r>
+              <a:t>applied_font_family: Malgun Gothic</a:t>
+            </a:r>
+          </a:p>
+          <a:p>
+            <a:r>
+              <a:t>applied_fallback_font: Malgun Gothic</a:t>
+            </a:r>
+          </a:p>
+          <a:p>
+            <a:r>
               <a:t>source_slide_refs: [</a:t>
             </a:r>
           </a:p>
@@ -4938,6 +5358,26 @@
           </a:p>
           <a:p>
             <a:r>
+              <a:t>style_profile_loaded: False</a:t>
+            </a:r>
+          </a:p>
+          <a:p>
+            <a:r>
+              <a:t>style_profile_path: None</a:t>
+            </a:r>
+          </a:p>
+          <a:p>
+            <a:r>
+              <a:t>applied_font_family: Malgun Gothic</a:t>
+            </a:r>
+          </a:p>
+          <a:p>
+            <a:r>
+              <a:t>applied_fallback_font: Malgun Gothic</a:t>
+            </a:r>
+          </a:p>
+          <a:p>
+            <a:r>
               <a:t>source_slide_refs: [</a:t>
             </a:r>
           </a:p>
@@ -5153,6 +5593,26 @@
           </a:p>
           <a:p>
             <a:r>
+              <a:t>style_profile_loaded: False</a:t>
+            </a:r>
+          </a:p>
+          <a:p>
+            <a:r>
+              <a:t>style_profile_path: None</a:t>
+            </a:r>
+          </a:p>
+          <a:p>
+            <a:r>
+              <a:t>applied_font_family: Malgun Gothic</a:t>
+            </a:r>
+          </a:p>
+          <a:p>
+            <a:r>
+              <a:t>applied_fallback_font: Malgun Gothic</a:t>
+            </a:r>
+          </a:p>
+          <a:p>
+            <a:r>
               <a:t>source_slide_refs: [</a:t>
             </a:r>
           </a:p>
@@ -5343,6 +5803,26 @@
           </a:p>
           <a:p>
             <a:r>
+              <a:t>style_profile_loaded: False</a:t>
+            </a:r>
+          </a:p>
+          <a:p>
+            <a:r>
+              <a:t>style_profile_path: None</a:t>
+            </a:r>
+          </a:p>
+          <a:p>
+            <a:r>
+              <a:t>applied_font_family: Malgun Gothic</a:t>
+            </a:r>
+          </a:p>
+          <a:p>
+            <a:r>
+              <a:t>applied_fallback_font: Malgun Gothic</a:t>
+            </a:r>
+          </a:p>
+          <a:p>
+            <a:r>
               <a:t>source_slide_refs: [</a:t>
             </a:r>
           </a:p>
@@ -5533,6 +6013,26 @@
           </a:p>
           <a:p>
             <a:r>
+              <a:t>style_profile_loaded: False</a:t>
+            </a:r>
+          </a:p>
+          <a:p>
+            <a:r>
+              <a:t>style_profile_path: None</a:t>
+            </a:r>
+          </a:p>
+          <a:p>
+            <a:r>
+              <a:t>applied_font_family: Malgun Gothic</a:t>
+            </a:r>
+          </a:p>
+          <a:p>
+            <a:r>
+              <a:t>applied_fallback_font: Malgun Gothic</a:t>
+            </a:r>
+          </a:p>
+          <a:p>
+            <a:r>
               <a:t>source_slide_refs: [</a:t>
             </a:r>
           </a:p>
@@ -5734,6 +6234,26 @@
           <a:p>
             <a:r>
               <a:t>layout_type: comparison</a:t>
+            </a:r>
+          </a:p>
+          <a:p>
+            <a:r>
+              <a:t>style_profile_loaded: False</a:t>
+            </a:r>
+          </a:p>
+          <a:p>
+            <a:r>
+              <a:t>style_profile_path: None</a:t>
+            </a:r>
+          </a:p>
+          <a:p>
+            <a:r>
+              <a:t>applied_font_family: Malgun Gothic</a:t>
+            </a:r>
+          </a:p>
+          <a:p>
+            <a:r>
+              <a:t>applied_fallback_font: Malgun Gothic</a:t>
             </a:r>
           </a:p>
           <a:p>
@@ -8929,8 +9449,8 @@
         </p:nvSpPr>
         <p:spPr>
           <a:xfrm>
-            <a:off x="777240" y="3154680"/>
-            <a:ext cx="9875520" cy="1280160"/>
+            <a:off x="822960" y="3154680"/>
+            <a:ext cx="9875520" cy="914400"/>
           </a:xfrm>
           <a:prstGeom prst="rect">
             <a:avLst/>
@@ -9113,8 +9633,8 @@
         </p:nvSpPr>
         <p:spPr>
           <a:xfrm>
-            <a:off x="685800" y="1600200"/>
-            <a:ext cx="6583680" cy="4297680"/>
+            <a:off x="594360" y="1600200"/>
+            <a:ext cx="7040880" cy="4297680"/>
           </a:xfrm>
           <a:prstGeom prst="rect">
             <a:avLst/>
@@ -9193,7 +9713,7 @@
           <a:solidFill>
             <a:srgbClr val="EBF1F4"/>
           </a:solidFill>
-          <a:ln w="15875">
+          <a:ln w="12700">
             <a:solidFill>
               <a:srgbClr val="A0AEB8"/>
             </a:solidFill>
@@ -9343,8 +9863,8 @@
         </p:nvSpPr>
         <p:spPr>
           <a:xfrm>
-            <a:off x="731520" y="914400"/>
-            <a:ext cx="10698480" cy="4480560"/>
+            <a:off x="731520" y="731520"/>
+            <a:ext cx="10698480" cy="6492240"/>
           </a:xfrm>
           <a:prstGeom prst="rect">
             <a:avLst/>
@@ -9388,8 +9908,8 @@
         </p:nvSpPr>
         <p:spPr>
           <a:xfrm>
-            <a:off x="1005840" y="1143000"/>
-            <a:ext cx="10058400" cy="914400"/>
+            <a:off x="731520" y="914400"/>
+            <a:ext cx="10058400" cy="868680"/>
           </a:xfrm>
           <a:prstGeom prst="rect">
             <a:avLst/>
@@ -9422,7 +9942,7 @@
         </p:nvSpPr>
         <p:spPr>
           <a:xfrm>
-            <a:off x="1078992" y="2331720"/>
+            <a:off x="731520" y="1645920"/>
             <a:ext cx="9692640" cy="2468880"/>
           </a:xfrm>
           <a:prstGeom prst="rect">
@@ -9702,7 +10222,7 @@
           <a:solidFill>
             <a:srgbClr val="EBF1F4"/>
           </a:solidFill>
-          <a:ln w="15875">
+          <a:ln w="12700">
             <a:solidFill>
               <a:srgbClr val="A0AEB8"/>
             </a:solidFill>
@@ -9929,7 +10449,7 @@
         </p:nvSpPr>
         <p:spPr>
           <a:xfrm>
-            <a:off x="822960" y="3429000"/>
+            <a:off x="777240" y="3383280"/>
             <a:ext cx="9875520" cy="914400"/>
           </a:xfrm>
           <a:prstGeom prst="rect">
@@ -10097,8 +10617,8 @@
         </p:nvSpPr>
         <p:spPr>
           <a:xfrm>
-            <a:off x="685800" y="1600200"/>
-            <a:ext cx="6583680" cy="4297680"/>
+            <a:off x="594360" y="1600200"/>
+            <a:ext cx="7040880" cy="4297680"/>
           </a:xfrm>
           <a:prstGeom prst="rect">
             <a:avLst/>
@@ -10177,7 +10697,7 @@
           <a:solidFill>
             <a:srgbClr val="EBF1F4"/>
           </a:solidFill>
-          <a:ln w="15875">
+          <a:ln w="12700">
             <a:solidFill>
               <a:srgbClr val="A0AEB8"/>
             </a:solidFill>
@@ -10361,8 +10881,8 @@
         </p:nvSpPr>
         <p:spPr>
           <a:xfrm>
-            <a:off x="685800" y="1600200"/>
-            <a:ext cx="6583680" cy="4297680"/>
+            <a:off x="594360" y="1600200"/>
+            <a:ext cx="7040880" cy="4297680"/>
           </a:xfrm>
           <a:prstGeom prst="rect">
             <a:avLst/>
@@ -10441,7 +10961,7 @@
           <a:solidFill>
             <a:srgbClr val="EBF1F4"/>
           </a:solidFill>
-          <a:ln w="15875">
+          <a:ln w="12700">
             <a:solidFill>
               <a:srgbClr val="A0AEB8"/>
             </a:solidFill>
@@ -10625,8 +11145,8 @@
         </p:nvSpPr>
         <p:spPr>
           <a:xfrm>
-            <a:off x="685800" y="1600200"/>
-            <a:ext cx="6583680" cy="4297680"/>
+            <a:off x="594360" y="1600200"/>
+            <a:ext cx="7040880" cy="4297680"/>
           </a:xfrm>
           <a:prstGeom prst="rect">
             <a:avLst/>
@@ -10705,7 +11225,7 @@
           <a:solidFill>
             <a:srgbClr val="EBF1F4"/>
           </a:solidFill>
-          <a:ln w="15875">
+          <a:ln w="12700">
             <a:solidFill>
               <a:srgbClr val="A0AEB8"/>
             </a:solidFill>
@@ -10855,8 +11375,8 @@
         </p:nvSpPr>
         <p:spPr>
           <a:xfrm>
-            <a:off x="594360" y="457200"/>
-            <a:ext cx="10972800" cy="777240"/>
+            <a:off x="1051560" y="640080"/>
+            <a:ext cx="10058400" cy="777240"/>
           </a:xfrm>
           <a:prstGeom prst="rect">
             <a:avLst/>
@@ -10898,7 +11418,7 @@
           <a:solidFill>
             <a:srgbClr val="EBF1F4"/>
           </a:solidFill>
-          <a:ln w="15875">
+          <a:ln w="12700">
             <a:solidFill>
               <a:srgbClr val="A0AEB8"/>
             </a:solidFill>
@@ -10953,7 +11473,7 @@
         </p:nvSpPr>
         <p:spPr>
           <a:xfrm>
-            <a:off x="1051560" y="4526280"/>
+            <a:off x="1051560" y="4572000"/>
             <a:ext cx="10058400" cy="1234440"/>
           </a:xfrm>
           <a:prstGeom prst="rect">
@@ -11635,7 +12155,7 @@
           <a:solidFill>
             <a:srgbClr val="EBF1F4"/>
           </a:solidFill>
-          <a:ln w="15875">
+          <a:ln w="12700">
             <a:solidFill>
               <a:srgbClr val="A0AEB8"/>
             </a:solidFill>
@@ -11862,7 +12382,7 @@
         </p:nvSpPr>
         <p:spPr>
           <a:xfrm>
-            <a:off x="822960" y="3429000"/>
+            <a:off x="777240" y="3383280"/>
             <a:ext cx="9875520" cy="914400"/>
           </a:xfrm>
           <a:prstGeom prst="rect">
@@ -12343,8 +12863,8 @@
         </p:nvSpPr>
         <p:spPr>
           <a:xfrm>
-            <a:off x="685800" y="1600200"/>
-            <a:ext cx="6583680" cy="4297680"/>
+            <a:off x="594360" y="1600200"/>
+            <a:ext cx="7040880" cy="4297680"/>
           </a:xfrm>
           <a:prstGeom prst="rect">
             <a:avLst/>
@@ -12439,7 +12959,7 @@
           <a:solidFill>
             <a:srgbClr val="EBF1F4"/>
           </a:solidFill>
-          <a:ln w="15875">
+          <a:ln w="12700">
             <a:solidFill>
               <a:srgbClr val="A0AEB8"/>
             </a:solidFill>
@@ -13321,7 +13841,7 @@
           <a:solidFill>
             <a:srgbClr val="EBF1F4"/>
           </a:solidFill>
-          <a:ln w="15875">
+          <a:ln w="12700">
             <a:solidFill>
               <a:srgbClr val="A0AEB8"/>
             </a:solidFill>
@@ -13471,8 +13991,8 @@
         </p:nvSpPr>
         <p:spPr>
           <a:xfrm>
-            <a:off x="731520" y="914400"/>
-            <a:ext cx="10698480" cy="4480560"/>
+            <a:off x="731520" y="731520"/>
+            <a:ext cx="10698480" cy="6492240"/>
           </a:xfrm>
           <a:prstGeom prst="rect">
             <a:avLst/>
@@ -13516,8 +14036,8 @@
         </p:nvSpPr>
         <p:spPr>
           <a:xfrm>
-            <a:off x="1005840" y="1143000"/>
-            <a:ext cx="10058400" cy="914400"/>
+            <a:off x="731520" y="914400"/>
+            <a:ext cx="10058400" cy="868680"/>
           </a:xfrm>
           <a:prstGeom prst="rect">
             <a:avLst/>
@@ -13550,7 +14070,7 @@
         </p:nvSpPr>
         <p:spPr>
           <a:xfrm>
-            <a:off x="1078992" y="2331720"/>
+            <a:off x="731520" y="1645920"/>
             <a:ext cx="9692640" cy="2468880"/>
           </a:xfrm>
           <a:prstGeom prst="rect">
@@ -13750,8 +14270,8 @@
         </p:nvSpPr>
         <p:spPr>
           <a:xfrm>
-            <a:off x="685800" y="1600200"/>
-            <a:ext cx="6583680" cy="4297680"/>
+            <a:off x="594360" y="1600200"/>
+            <a:ext cx="7040880" cy="4297680"/>
           </a:xfrm>
           <a:prstGeom prst="rect">
             <a:avLst/>
@@ -13830,7 +14350,7 @@
           <a:solidFill>
             <a:srgbClr val="EBF1F4"/>
           </a:solidFill>
-          <a:ln w="15875">
+          <a:ln w="12700">
             <a:solidFill>
               <a:srgbClr val="A0AEB8"/>
             </a:solidFill>
@@ -14459,7 +14979,7 @@
         </p:nvSpPr>
         <p:spPr>
           <a:xfrm>
-            <a:off x="822960" y="3429000"/>
+            <a:off x="777240" y="3383280"/>
             <a:ext cx="9875520" cy="914400"/>
           </a:xfrm>
           <a:prstGeom prst="rect">
@@ -14627,8 +15147,8 @@
         </p:nvSpPr>
         <p:spPr>
           <a:xfrm>
-            <a:off x="685800" y="1600200"/>
-            <a:ext cx="6583680" cy="4297680"/>
+            <a:off x="594360" y="1600200"/>
+            <a:ext cx="7040880" cy="4297680"/>
           </a:xfrm>
           <a:prstGeom prst="rect">
             <a:avLst/>
@@ -14707,7 +15227,7 @@
           <a:solidFill>
             <a:srgbClr val="EBF1F4"/>
           </a:solidFill>
-          <a:ln w="15875">
+          <a:ln w="12700">
             <a:solidFill>
               <a:srgbClr val="A0AEB8"/>
             </a:solidFill>

</xml_diff>

<commit_message>
Tune styled PPTX renderer layout
</commit_message>
<xml_diff>
--- a/outputs/pptx/ai_knowledge_institution_draft.pptx
+++ b/outputs/pptx/ai_knowledge_institution_draft.pptx
@@ -9745,17 +9745,7 @@
                 </a:solidFill>
                 <a:latin typeface="Malgun Gothic"/>
               </a:rPr>
-              <a:t>[수동 삽입 필요]</a:t>
-            </a:r>
-            <a:br/>
-            <a:r>
-              <a:rPr sz="1600">
-                <a:solidFill>
-                  <a:srgbClr val="566070"/>
-                </a:solidFill>
-                <a:latin typeface="Malgun Gothic"/>
-              </a:rPr>
-              <a:t>Manual visual placeholder; choose asset during later Piti/PPT work.</a:t>
+              <a:t>[수동 삽입]</a:t>
             </a:r>
           </a:p>
         </p:txBody>
@@ -10213,8 +10203,8 @@
         </p:nvSpPr>
         <p:spPr>
           <a:xfrm>
-            <a:off x="8778240" y="4389120"/>
-            <a:ext cx="2377440" cy="1097280"/>
+            <a:off x="8458200" y="4389120"/>
+            <a:ext cx="2560320" cy="1097280"/>
           </a:xfrm>
           <a:prstGeom prst="rect">
             <a:avLst/>
@@ -10254,17 +10244,7 @@
                 </a:solidFill>
                 <a:latin typeface="Malgun Gothic"/>
               </a:rPr>
-              <a:t>[수동 삽입 필요]</a:t>
-            </a:r>
-            <a:br/>
-            <a:r>
-              <a:rPr sz="1600">
-                <a:solidFill>
-                  <a:srgbClr val="566070"/>
-                </a:solidFill>
-                <a:latin typeface="Malgun Gothic"/>
-              </a:rPr>
-              <a:t>Manual visual placeholder; choose asset during later Piti/PPT work.</a:t>
+              <a:t>[수동 삽입]</a:t>
             </a:r>
           </a:p>
         </p:txBody>
@@ -10729,17 +10709,7 @@
                 </a:solidFill>
                 <a:latin typeface="Malgun Gothic"/>
               </a:rPr>
-              <a:t>[수동 삽입 필요]</a:t>
-            </a:r>
-            <a:br/>
-            <a:r>
-              <a:rPr sz="1600">
-                <a:solidFill>
-                  <a:srgbClr val="566070"/>
-                </a:solidFill>
-                <a:latin typeface="Malgun Gothic"/>
-              </a:rPr>
-              <a:t>Manual visual placeholder; choose asset during later Piti/PPT work.</a:t>
+              <a:t>[수동 삽입]</a:t>
             </a:r>
           </a:p>
         </p:txBody>
@@ -10993,17 +10963,7 @@
                 </a:solidFill>
                 <a:latin typeface="Malgun Gothic"/>
               </a:rPr>
-              <a:t>[수동 삽입 필요]</a:t>
-            </a:r>
-            <a:br/>
-            <a:r>
-              <a:rPr sz="1600">
-                <a:solidFill>
-                  <a:srgbClr val="566070"/>
-                </a:solidFill>
-                <a:latin typeface="Malgun Gothic"/>
-              </a:rPr>
-              <a:t>Manual visual placeholder; choose asset during later Piti/PPT work.</a:t>
+              <a:t>[수동 삽입]</a:t>
             </a:r>
           </a:p>
         </p:txBody>
@@ -11257,17 +11217,7 @@
                 </a:solidFill>
                 <a:latin typeface="Malgun Gothic"/>
               </a:rPr>
-              <a:t>[수동 삽입 필요]</a:t>
-            </a:r>
-            <a:br/>
-            <a:r>
-              <a:rPr sz="1600">
-                <a:solidFill>
-                  <a:srgbClr val="566070"/>
-                </a:solidFill>
-                <a:latin typeface="Malgun Gothic"/>
-              </a:rPr>
-              <a:t>Manual visual placeholder; choose asset during later Piti/PPT work.</a:t>
+              <a:t>[수동 삽입]</a:t>
             </a:r>
           </a:p>
         </p:txBody>
@@ -11452,16 +11402,6 @@
               </a:rPr>
               <a:t>[차트 후보]</a:t>
             </a:r>
-            <a:br/>
-            <a:r>
-              <a:rPr sz="1600">
-                <a:solidFill>
-                  <a:srgbClr val="566070"/>
-                </a:solidFill>
-                <a:latin typeface="Malgun Gothic"/>
-              </a:rPr>
-              <a:t>Chart or simple number card candidate; no chart is rendered yet.</a:t>
-            </a:r>
           </a:p>
         </p:txBody>
       </p:sp>
@@ -12146,8 +12086,8 @@
         </p:nvSpPr>
         <p:spPr>
           <a:xfrm>
-            <a:off x="8778240" y="4389120"/>
-            <a:ext cx="2377440" cy="1097280"/>
+            <a:off x="8458200" y="4389120"/>
+            <a:ext cx="2560320" cy="1097280"/>
           </a:xfrm>
           <a:prstGeom prst="rect">
             <a:avLst/>
@@ -12187,17 +12127,7 @@
                 </a:solidFill>
                 <a:latin typeface="Malgun Gothic"/>
               </a:rPr>
-              <a:t>[수동 삽입 필요]</a:t>
-            </a:r>
-            <a:br/>
-            <a:r>
-              <a:rPr sz="1600">
-                <a:solidFill>
-                  <a:srgbClr val="566070"/>
-                </a:solidFill>
-                <a:latin typeface="Malgun Gothic"/>
-              </a:rPr>
-              <a:t>Manual visual placeholder; choose asset during later Piti/PPT work.</a:t>
+              <a:t>[수동 삽입]</a:t>
             </a:r>
           </a:p>
         </p:txBody>
@@ -12991,17 +12921,7 @@
                 </a:solidFill>
                 <a:latin typeface="Malgun Gothic"/>
               </a:rPr>
-              <a:t>[수동 삽입 필요]</a:t>
-            </a:r>
-            <a:br/>
-            <a:r>
-              <a:rPr sz="1600">
-                <a:solidFill>
-                  <a:srgbClr val="566070"/>
-                </a:solidFill>
-                <a:latin typeface="Malgun Gothic"/>
-              </a:rPr>
-              <a:t>Manual visual placeholder; choose asset during later Piti/PPT work.</a:t>
+              <a:t>[수동 삽입]</a:t>
             </a:r>
           </a:p>
         </p:txBody>
@@ -13832,8 +13752,8 @@
         </p:nvSpPr>
         <p:spPr>
           <a:xfrm>
-            <a:off x="8778240" y="4389120"/>
-            <a:ext cx="2377440" cy="1097280"/>
+            <a:off x="8458200" y="4389120"/>
+            <a:ext cx="2560320" cy="1097280"/>
           </a:xfrm>
           <a:prstGeom prst="rect">
             <a:avLst/>
@@ -13873,17 +13793,7 @@
                 </a:solidFill>
                 <a:latin typeface="Malgun Gothic"/>
               </a:rPr>
-              <a:t>[수동 삽입 필요]</a:t>
-            </a:r>
-            <a:br/>
-            <a:r>
-              <a:rPr sz="1600">
-                <a:solidFill>
-                  <a:srgbClr val="566070"/>
-                </a:solidFill>
-                <a:latin typeface="Malgun Gothic"/>
-              </a:rPr>
-              <a:t>Manual visual placeholder; choose asset during later Piti/PPT work.</a:t>
+              <a:t>[수동 삽입]</a:t>
             </a:r>
           </a:p>
         </p:txBody>
@@ -14382,17 +14292,7 @@
                 </a:solidFill>
                 <a:latin typeface="Malgun Gothic"/>
               </a:rPr>
-              <a:t>[수동 삽입 필요]</a:t>
-            </a:r>
-            <a:br/>
-            <a:r>
-              <a:rPr sz="1600">
-                <a:solidFill>
-                  <a:srgbClr val="566070"/>
-                </a:solidFill>
-                <a:latin typeface="Malgun Gothic"/>
-              </a:rPr>
-              <a:t>Manual visual placeholder; choose asset during later Piti/PPT work.</a:t>
+              <a:t>[수동 삽입]</a:t>
             </a:r>
           </a:p>
         </p:txBody>
@@ -15259,17 +15159,7 @@
                 </a:solidFill>
                 <a:latin typeface="Malgun Gothic"/>
               </a:rPr>
-              <a:t>[수동 삽입 필요]</a:t>
-            </a:r>
-            <a:br/>
-            <a:r>
-              <a:rPr sz="1600">
-                <a:solidFill>
-                  <a:srgbClr val="566070"/>
-                </a:solidFill>
-                <a:latin typeface="Malgun Gothic"/>
-              </a:rPr>
-              <a:t>Manual visual placeholder; choose asset during later Piti/PPT work.</a:t>
+              <a:t>[수동 삽입]</a:t>
             </a:r>
           </a:p>
         </p:txBody>

</xml_diff>

<commit_message>
Apply explicit Syukaworld screen formatting rules
</commit_message>
<xml_diff>
--- a/outputs/pptx/ai_knowledge_institution_draft.pptx
+++ b/outputs/pptx/ai_knowledge_institution_draft.pptx
@@ -570,6 +570,47 @@
               <a:t>]</a:t>
             </a:r>
           </a:p>
+          <a:p>
+            <a:r>
+              <a:t>manual_placeholder_hidden: False</a:t>
+            </a:r>
+          </a:p>
+          <a:p/>
+          <a:p>
+            <a:r>
+              <a:t>screen_body_lines:</a:t>
+            </a:r>
+          </a:p>
+          <a:p>
+            <a:r>
+              <a:t>[</a:t>
+            </a:r>
+          </a:p>
+          <a:p>
+            <a:r>
+              <a:t>  "검색창이 아니라 답안지가 된 AI",</a:t>
+            </a:r>
+          </a:p>
+          <a:p>
+            <a:r>
+              <a:t>  "학교와 박물관은 이제 무엇을 가르쳐야 할까"</a:t>
+            </a:r>
+          </a:p>
+          <a:p>
+            <a:r>
+              <a:t>]</a:t>
+            </a:r>
+          </a:p>
+          <a:p>
+            <a:r>
+              <a:t>overflow_body_lines:</a:t>
+            </a:r>
+          </a:p>
+          <a:p>
+            <a:r>
+              <a:t>[]</a:t>
+            </a:r>
+          </a:p>
           <a:p/>
           <a:p>
             <a:r>
@@ -780,6 +821,52 @@
               <a:t>]</a:t>
             </a:r>
           </a:p>
+          <a:p>
+            <a:r>
+              <a:t>manual_placeholder_hidden: False</a:t>
+            </a:r>
+          </a:p>
+          <a:p/>
+          <a:p>
+            <a:r>
+              <a:t>screen_body_lines:</a:t>
+            </a:r>
+          </a:p>
+          <a:p>
+            <a:r>
+              <a:t>[</a:t>
+            </a:r>
+          </a:p>
+          <a:p>
+            <a:r>
+              <a:t>  "틀린 가설을 세워보고, 다른 자료와 부딪히고, 왜 틀렸는지 고치는 시간이 사고를 만든다",</a:t>
+            </a:r>
+          </a:p>
+          <a:p>
+            <a:r>
+              <a:t>  "AI 역량 교육은 답을 받는 법보다 질문하고 평가하고 책임 있게 쓰는 법으로 확장될 필요가 있다",</a:t>
+            </a:r>
+          </a:p>
+          <a:p>
+            <a:r>
+              <a:t>  "이 주장은 연구·프레임워크에 기대되, 인지 효과를 확정적으로 말하지 않는다"</a:t>
+            </a:r>
+          </a:p>
+          <a:p>
+            <a:r>
+              <a:t>]</a:t>
+            </a:r>
+          </a:p>
+          <a:p>
+            <a:r>
+              <a:t>overflow_body_lines:</a:t>
+            </a:r>
+          </a:p>
+          <a:p>
+            <a:r>
+              <a:t>[]</a:t>
+            </a:r>
+          </a:p>
           <a:p/>
           <a:p>
             <a:r>
@@ -1015,6 +1102,52 @@
               <a:t>]</a:t>
             </a:r>
           </a:p>
+          <a:p>
+            <a:r>
+              <a:t>manual_placeholder_hidden: False</a:t>
+            </a:r>
+          </a:p>
+          <a:p/>
+          <a:p>
+            <a:r>
+              <a:t>screen_body_lines:</a:t>
+            </a:r>
+          </a:p>
+          <a:p>
+            <a:r>
+              <a:t>[</a:t>
+            </a:r>
+          </a:p>
+          <a:p>
+            <a:r>
+              <a:t>  "Royal Observatory 관련 보도는 AI 의존 경고를 인간 지식과 배움의 가치라는 맥락에 둔다",</a:t>
+            </a:r>
+          </a:p>
+          <a:p>
+            <a:r>
+              <a:t>  "이를 AI 반대가 아니라 질문과 검증의 필요성을 상기시키는 장면으로 사용한다",</a:t>
+            </a:r>
+          </a:p>
+          <a:p>
+            <a:r>
+              <a:t>  "단일 기사 기반 맥락이므로 표현은 보수적으로 유지한다"</a:t>
+            </a:r>
+          </a:p>
+          <a:p>
+            <a:r>
+              <a:t>]</a:t>
+            </a:r>
+          </a:p>
+          <a:p>
+            <a:r>
+              <a:t>overflow_body_lines:</a:t>
+            </a:r>
+          </a:p>
+          <a:p>
+            <a:r>
+              <a:t>[]</a:t>
+            </a:r>
+          </a:p>
           <a:p/>
           <a:p>
             <a:r>
@@ -1240,6 +1373,52 @@
               <a:t>]</a:t>
             </a:r>
           </a:p>
+          <a:p>
+            <a:r>
+              <a:t>manual_placeholder_hidden: False</a:t>
+            </a:r>
+          </a:p>
+          <a:p/>
+          <a:p>
+            <a:r>
+              <a:t>screen_body_lines:</a:t>
+            </a:r>
+          </a:p>
+          <a:p>
+            <a:r>
+              <a:t>[</a:t>
+            </a:r>
+          </a:p>
+          <a:p>
+            <a:r>
+              <a:t>  "예전엔 누가 더 잘 찾느냐의 싸움이었다면",</a:t>
+            </a:r>
+          </a:p>
+          <a:p>
+            <a:r>
+              <a:t>  "이제는 누가 더 좋은 질문을 하느냐의 싸움일 수 있다",</a:t>
+            </a:r>
+          </a:p>
+          <a:p>
+            <a:r>
+              <a:t>  "AI가 정답을 말할수록, 사람은 질문을 더 잘해야 한다"</a:t>
+            </a:r>
+          </a:p>
+          <a:p>
+            <a:r>
+              <a:t>]</a:t>
+            </a:r>
+          </a:p>
+          <a:p>
+            <a:r>
+              <a:t>overflow_body_lines:</a:t>
+            </a:r>
+          </a:p>
+          <a:p>
+            <a:r>
+              <a:t>[]</a:t>
+            </a:r>
+          </a:p>
           <a:p/>
           <a:p>
             <a:r>
@@ -1450,6 +1629,42 @@
               <a:t>]</a:t>
             </a:r>
           </a:p>
+          <a:p>
+            <a:r>
+              <a:t>manual_placeholder_hidden: False</a:t>
+            </a:r>
+          </a:p>
+          <a:p/>
+          <a:p>
+            <a:r>
+              <a:t>screen_body_lines:</a:t>
+            </a:r>
+          </a:p>
+          <a:p>
+            <a:r>
+              <a:t>[</a:t>
+            </a:r>
+          </a:p>
+          <a:p>
+            <a:r>
+              <a:t>  "답을 알려주는 곳에서, 질문을 훈련하는 곳으로"</a:t>
+            </a:r>
+          </a:p>
+          <a:p>
+            <a:r>
+              <a:t>]</a:t>
+            </a:r>
+          </a:p>
+          <a:p>
+            <a:r>
+              <a:t>overflow_body_lines:</a:t>
+            </a:r>
+          </a:p>
+          <a:p>
+            <a:r>
+              <a:t>[]</a:t>
+            </a:r>
+          </a:p>
           <a:p/>
           <a:p>
             <a:r>
@@ -1660,6 +1875,52 @@
               <a:t>]</a:t>
             </a:r>
           </a:p>
+          <a:p>
+            <a:r>
+              <a:t>manual_placeholder_hidden: False</a:t>
+            </a:r>
+          </a:p>
+          <a:p/>
+          <a:p>
+            <a:r>
+              <a:t>screen_body_lines:</a:t>
+            </a:r>
+          </a:p>
+          <a:p>
+            <a:r>
+              <a:t>[</a:t>
+            </a:r>
+          </a:p>
+          <a:p>
+            <a:r>
+              <a:t>  "AI가 많은 정보를 설명할 수 있다면, 수업은 무엇을 외웠나보다 어떻게 확인했나를 더 물어야 할 수 있다",</a:t>
+            </a:r>
+          </a:p>
+          <a:p>
+            <a:r>
+              <a:t>  "OECD와 UNESCO 자료는 AI 교육을 교수 원칙과 학생 역량의 문제로 다룬다",</a:t>
+            </a:r>
+          </a:p>
+          <a:p>
+            <a:r>
+              <a:t>  "다만 교육 효과는 아직 단정하지 않고, 수업 설계의 과제로 남긴다"</a:t>
+            </a:r>
+          </a:p>
+          <a:p>
+            <a:r>
+              <a:t>]</a:t>
+            </a:r>
+          </a:p>
+          <a:p>
+            <a:r>
+              <a:t>overflow_body_lines:</a:t>
+            </a:r>
+          </a:p>
+          <a:p>
+            <a:r>
+              <a:t>[]</a:t>
+            </a:r>
+          </a:p>
           <a:p/>
           <a:p>
             <a:r>
@@ -1895,6 +2156,52 @@
               <a:t>]</a:t>
             </a:r>
           </a:p>
+          <a:p>
+            <a:r>
+              <a:t>manual_placeholder_hidden: False</a:t>
+            </a:r>
+          </a:p>
+          <a:p/>
+          <a:p>
+            <a:r>
+              <a:t>screen_body_lines:</a:t>
+            </a:r>
+          </a:p>
+          <a:p>
+            <a:r>
+              <a:t>[</a:t>
+            </a:r>
+          </a:p>
+          <a:p>
+            <a:r>
+              <a:t>  "설명 자체는 AI도 해줄 수 있다",</a:t>
+            </a:r>
+          </a:p>
+          <a:p>
+            <a:r>
+              <a:t>  "그렇다면 박물관·과학관은 맥락, 경험, 질문, 토론을 더 강조해야 할 수 있다",</a:t>
+            </a:r>
+          </a:p>
+          <a:p>
+            <a:r>
+              <a:t>  "국립과학관 AI 전시 사례는 기술을 체험형 맥락으로 보여주는 보조 사례로만 사용한다"</a:t>
+            </a:r>
+          </a:p>
+          <a:p>
+            <a:r>
+              <a:t>]</a:t>
+            </a:r>
+          </a:p>
+          <a:p>
+            <a:r>
+              <a:t>overflow_body_lines:</a:t>
+            </a:r>
+          </a:p>
+          <a:p>
+            <a:r>
+              <a:t>[]</a:t>
+            </a:r>
+          </a:p>
           <a:p/>
           <a:p>
             <a:r>
@@ -2136,6 +2443,52 @@
               <a:t>]</a:t>
             </a:r>
           </a:p>
+          <a:p>
+            <a:r>
+              <a:t>manual_placeholder_hidden: False</a:t>
+            </a:r>
+          </a:p>
+          <a:p/>
+          <a:p>
+            <a:r>
+              <a:t>screen_body_lines:</a:t>
+            </a:r>
+          </a:p>
+          <a:p>
+            <a:r>
+              <a:t>[</a:t>
+            </a:r>
+          </a:p>
+          <a:p>
+            <a:r>
+              <a:t>  "AI는 별자리 정보를 바로 줄 수 있다",</a:t>
+            </a:r>
+          </a:p>
+          <a:p>
+            <a:r>
+              <a:t>  "하지만 밤하늘을 관찰하고, 위치를 추정하고, 계절과 시간을 연결하는 경험은 다르다",</a:t>
+            </a:r>
+          </a:p>
+          <a:p>
+            <a:r>
+              <a:t>  "천문관 비유는 정보 전달보다 보는 법과 질문하는 법을 강조하기 위한 방송용 구조다"</a:t>
+            </a:r>
+          </a:p>
+          <a:p>
+            <a:r>
+              <a:t>]</a:t>
+            </a:r>
+          </a:p>
+          <a:p>
+            <a:r>
+              <a:t>overflow_body_lines:</a:t>
+            </a:r>
+          </a:p>
+          <a:p>
+            <a:r>
+              <a:t>[]</a:t>
+            </a:r>
+          </a:p>
           <a:p/>
           <a:p>
             <a:r>
@@ -2371,6 +2724,52 @@
               <a:t>]</a:t>
             </a:r>
           </a:p>
+          <a:p>
+            <a:r>
+              <a:t>manual_placeholder_hidden: False</a:t>
+            </a:r>
+          </a:p>
+          <a:p/>
+          <a:p>
+            <a:r>
+              <a:t>screen_body_lines:</a:t>
+            </a:r>
+          </a:p>
+          <a:p>
+            <a:r>
+              <a:t>[</a:t>
+            </a:r>
+          </a:p>
+          <a:p>
+            <a:r>
+              <a:t>  "방송용 완성본에는 AI 검색 사용, 학교 AI 지침, 과학관·박물관 AI 활용 사례가 더 필요하다",</a:t>
+            </a:r>
+          </a:p>
+          <a:p>
+            <a:r>
+              <a:t>  "이번 enriched dry run은 OECD·정책브리핑·과학관 사례로 1차 틀만 보강한다",</a:t>
+            </a:r>
+          </a:p>
+          <a:p>
+            <a:r>
+              <a:t>  "정량 수치가 필요한 문장은 여전히 fact check 대상으로 남긴다"</a:t>
+            </a:r>
+          </a:p>
+          <a:p>
+            <a:r>
+              <a:t>]</a:t>
+            </a:r>
+          </a:p>
+          <a:p>
+            <a:r>
+              <a:t>overflow_body_lines:</a:t>
+            </a:r>
+          </a:p>
+          <a:p>
+            <a:r>
+              <a:t>[]</a:t>
+            </a:r>
+          </a:p>
           <a:p/>
           <a:p>
             <a:r>
@@ -2616,6 +3015,52 @@
               <a:t>]</a:t>
             </a:r>
           </a:p>
+          <a:p>
+            <a:r>
+              <a:t>manual_placeholder_hidden: False</a:t>
+            </a:r>
+          </a:p>
+          <a:p/>
+          <a:p>
+            <a:r>
+              <a:t>screen_body_lines:</a:t>
+            </a:r>
+          </a:p>
+          <a:p>
+            <a:r>
+              <a:t>[</a:t>
+            </a:r>
+          </a:p>
+          <a:p>
+            <a:r>
+              <a:t>  "한국에서도 AI 디지털교과서와 AI 체험 전시가 이미 정책·기관 사례로 등장한다",</a:t>
+            </a:r>
+          </a:p>
+          <a:p>
+            <a:r>
+              <a:t>  "다만 한국 사례는 메인 논지의 증명이 아니라 후반 보조 연결로 사용한다",</a:t>
+            </a:r>
+          </a:p>
+          <a:p>
+            <a:r>
+              <a:t>  "핵심 질문은 한국도 결국 AI를 금지할지보다 어떻게 다룰지라는 쪽으로 옮겨갈 수 있다는 점이다"</a:t>
+            </a:r>
+          </a:p>
+          <a:p>
+            <a:r>
+              <a:t>]</a:t>
+            </a:r>
+          </a:p>
+          <a:p>
+            <a:r>
+              <a:t>overflow_body_lines:</a:t>
+            </a:r>
+          </a:p>
+          <a:p>
+            <a:r>
+              <a:t>[]</a:t>
+            </a:r>
+          </a:p>
           <a:p/>
           <a:p>
             <a:r>
@@ -2851,6 +3296,52 @@
               <a:t>]</a:t>
             </a:r>
           </a:p>
+          <a:p>
+            <a:r>
+              <a:t>manual_placeholder_hidden: False</a:t>
+            </a:r>
+          </a:p>
+          <a:p/>
+          <a:p>
+            <a:r>
+              <a:t>screen_body_lines:</a:t>
+            </a:r>
+          </a:p>
+          <a:p>
+            <a:r>
+              <a:t>[</a:t>
+            </a:r>
+          </a:p>
+          <a:p>
+            <a:r>
+              <a:t>  "AI가 답을 주는 건 막기 어렵다",</a:t>
+            </a:r>
+          </a:p>
+          <a:p>
+            <a:r>
+              <a:t>  "그렇다면 사람에게 남겨야 할 것은 답이 아니라 과정일 수 있다",</a:t>
+            </a:r>
+          </a:p>
+          <a:p>
+            <a:r>
+              <a:t>  "보고, 의심하고, 질문하고, 다시 확인하는 습관이 지식기관의 교육 목표가 될 수 있다"</a:t>
+            </a:r>
+          </a:p>
+          <a:p>
+            <a:r>
+              <a:t>]</a:t>
+            </a:r>
+          </a:p>
+          <a:p>
+            <a:r>
+              <a:t>overflow_body_lines:</a:t>
+            </a:r>
+          </a:p>
+          <a:p>
+            <a:r>
+              <a:t>[]</a:t>
+            </a:r>
+          </a:p>
           <a:p/>
           <a:p>
             <a:r>
@@ -3071,6 +3562,52 @@
               <a:t>]</a:t>
             </a:r>
           </a:p>
+          <a:p>
+            <a:r>
+              <a:t>manual_placeholder_hidden: False</a:t>
+            </a:r>
+          </a:p>
+          <a:p/>
+          <a:p>
+            <a:r>
+              <a:t>screen_body_lines:</a:t>
+            </a:r>
+          </a:p>
+          <a:p>
+            <a:r>
+              <a:t>[</a:t>
+            </a:r>
+          </a:p>
+          <a:p>
+            <a:r>
+              <a:t>  "모르는 것을 물으면 바로 답이 나오고, 검색 결과를 여러 개 열어보던 시간이 줄어든다",</a:t>
+            </a:r>
+          </a:p>
+          <a:p>
+            <a:r>
+              <a:t>  "AI는 접근성과 개인화 가능성도 넓힐 수 있다",</a:t>
+            </a:r>
+          </a:p>
+          <a:p>
+            <a:r>
+              <a:t>  "다만 편리함이 곧 배움이라는 뜻은 아니므로, 정보 탐색 과정의 변화로 조심스럽게 다룬다"</a:t>
+            </a:r>
+          </a:p>
+          <a:p>
+            <a:r>
+              <a:t>]</a:t>
+            </a:r>
+          </a:p>
+          <a:p>
+            <a:r>
+              <a:t>overflow_body_lines:</a:t>
+            </a:r>
+          </a:p>
+          <a:p>
+            <a:r>
+              <a:t>[]</a:t>
+            </a:r>
+          </a:p>
           <a:p/>
           <a:p>
             <a:r>
@@ -3306,6 +3843,42 @@
               <a:t>]</a:t>
             </a:r>
           </a:p>
+          <a:p>
+            <a:r>
+              <a:t>manual_placeholder_hidden: False</a:t>
+            </a:r>
+          </a:p>
+          <a:p/>
+          <a:p>
+            <a:r>
+              <a:t>screen_body_lines:</a:t>
+            </a:r>
+          </a:p>
+          <a:p>
+            <a:r>
+              <a:t>[</a:t>
+            </a:r>
+          </a:p>
+          <a:p>
+            <a:r>
+              <a:t>  "마지막 질문은 찬반이 아니라 교육의 역할"</a:t>
+            </a:r>
+          </a:p>
+          <a:p>
+            <a:r>
+              <a:t>]</a:t>
+            </a:r>
+          </a:p>
+          <a:p>
+            <a:r>
+              <a:t>overflow_body_lines:</a:t>
+            </a:r>
+          </a:p>
+          <a:p>
+            <a:r>
+              <a:t>[]</a:t>
+            </a:r>
+          </a:p>
           <a:p/>
           <a:p>
             <a:r>
@@ -3516,6 +4089,52 @@
               <a:t>]</a:t>
             </a:r>
           </a:p>
+          <a:p>
+            <a:r>
+              <a:t>manual_placeholder_hidden: False</a:t>
+            </a:r>
+          </a:p>
+          <a:p/>
+          <a:p>
+            <a:r>
+              <a:t>screen_body_lines:</a:t>
+            </a:r>
+          </a:p>
+          <a:p>
+            <a:r>
+              <a:t>[</a:t>
+            </a:r>
+          </a:p>
+          <a:p>
+            <a:r>
+              <a:t>  "학생도, 직장인도, 관람객도 이미 AI와 함께 정보를 찾는다",</a:t>
+            </a:r>
+          </a:p>
+          <a:p>
+            <a:r>
+              <a:t>  "반대로 AI는 학습 접근성과 개인화 가능성을 높일 수 있다는 주장도 있다",</a:t>
+            </a:r>
+          </a:p>
+          <a:p>
+            <a:r>
+              <a:t>  "그래서 문제는 사용 여부가 아니라, 어떤 질문을 던지고 어떤 답을 의심할지에 가깝다"</a:t>
+            </a:r>
+          </a:p>
+          <a:p>
+            <a:r>
+              <a:t>]</a:t>
+            </a:r>
+          </a:p>
+          <a:p>
+            <a:r>
+              <a:t>overflow_body_lines:</a:t>
+            </a:r>
+          </a:p>
+          <a:p>
+            <a:r>
+              <a:t>[]</a:t>
+            </a:r>
+          </a:p>
           <a:p/>
           <a:p>
             <a:r>
@@ -3751,6 +4370,62 @@
               <a:t>]</a:t>
             </a:r>
           </a:p>
+          <a:p>
+            <a:r>
+              <a:t>manual_placeholder_hidden: False</a:t>
+            </a:r>
+          </a:p>
+          <a:p/>
+          <a:p>
+            <a:r>
+              <a:t>screen_body_lines:</a:t>
+            </a:r>
+          </a:p>
+          <a:p>
+            <a:r>
+              <a:t>[</a:t>
+            </a:r>
+          </a:p>
+          <a:p>
+            <a:r>
+              <a:t>  "출처를 확인하는 법",</a:t>
+            </a:r>
+          </a:p>
+          <a:p>
+            <a:r>
+              <a:t>  "AI 답변의 빈틈을 찾는 법",</a:t>
+            </a:r>
+          </a:p>
+          <a:p>
+            <a:r>
+              <a:t>  "다른 자료와 비교하는 법"</a:t>
+            </a:r>
+          </a:p>
+          <a:p>
+            <a:r>
+              <a:t>]</a:t>
+            </a:r>
+          </a:p>
+          <a:p>
+            <a:r>
+              <a:t>overflow_body_lines:</a:t>
+            </a:r>
+          </a:p>
+          <a:p>
+            <a:r>
+              <a:t>[</a:t>
+            </a:r>
+          </a:p>
+          <a:p>
+            <a:r>
+              <a:t>  "모르는 것을 모른다고 남기는 법"</a:t>
+            </a:r>
+          </a:p>
+          <a:p>
+            <a:r>
+              <a:t>]</a:t>
+            </a:r>
+          </a:p>
           <a:p/>
           <a:p>
             <a:r>
@@ -3996,6 +4671,52 @@
               <a:t>]</a:t>
             </a:r>
           </a:p>
+          <a:p>
+            <a:r>
+              <a:t>manual_placeholder_hidden: False</a:t>
+            </a:r>
+          </a:p>
+          <a:p/>
+          <a:p>
+            <a:r>
+              <a:t>screen_body_lines:</a:t>
+            </a:r>
+          </a:p>
+          <a:p>
+            <a:r>
+              <a:t>[</a:t>
+            </a:r>
+          </a:p>
+          <a:p>
+            <a:r>
+              <a:t>  "망원경은 하늘을 대신 봐주지 않는다",</a:t>
+            </a:r>
+          </a:p>
+          <a:p>
+            <a:r>
+              <a:t>  "더 멀리 보게 해줄 뿐, 어디를 볼지는 사람이 정한다",</a:t>
+            </a:r>
+          </a:p>
+          <a:p>
+            <a:r>
+              <a:t>  "AI도 답을 대신 주는 도구로만 쓰기보다, 더 좋은 질문을 돕는 도구가 될 수 있는지 묻는다"</a:t>
+            </a:r>
+          </a:p>
+          <a:p>
+            <a:r>
+              <a:t>]</a:t>
+            </a:r>
+          </a:p>
+          <a:p>
+            <a:r>
+              <a:t>overflow_body_lines:</a:t>
+            </a:r>
+          </a:p>
+          <a:p>
+            <a:r>
+              <a:t>[]</a:t>
+            </a:r>
+          </a:p>
           <a:p/>
           <a:p>
             <a:r>
@@ -4216,6 +4937,67 @@
               <a:t>]</a:t>
             </a:r>
           </a:p>
+          <a:p>
+            <a:r>
+              <a:t>manual_placeholder_hidden: False</a:t>
+            </a:r>
+          </a:p>
+          <a:p/>
+          <a:p>
+            <a:r>
+              <a:t>screen_body_lines:</a:t>
+            </a:r>
+          </a:p>
+          <a:p>
+            <a:r>
+              <a:t>[</a:t>
+            </a:r>
+          </a:p>
+          <a:p>
+            <a:r>
+              <a:t>  "BBC/Royal Observatory 원문 맥락",</a:t>
+            </a:r>
+          </a:p>
+          <a:p>
+            <a:r>
+              <a:t>  "AI 정보탐색·교육 관련 보조 연구",</a:t>
+            </a:r>
+          </a:p>
+          <a:p>
+            <a:r>
+              <a:t>  "AI 접근성/개인화라는 counterpoint"</a:t>
+            </a:r>
+          </a:p>
+          <a:p>
+            <a:r>
+              <a:t>]</a:t>
+            </a:r>
+          </a:p>
+          <a:p>
+            <a:r>
+              <a:t>overflow_body_lines:</a:t>
+            </a:r>
+          </a:p>
+          <a:p>
+            <a:r>
+              <a:t>[</a:t>
+            </a:r>
+          </a:p>
+          <a:p>
+            <a:r>
+              <a:t>  "한국 학교·과학관 사례",</a:t>
+            </a:r>
+          </a:p>
+          <a:p>
+            <a:r>
+              <a:t>  "남은 숫자와 사례는 production 전에 추가 확인"</a:t>
+            </a:r>
+          </a:p>
+          <a:p>
+            <a:r>
+              <a:t>]</a:t>
+            </a:r>
+          </a:p>
           <a:p/>
           <a:p>
             <a:r>
@@ -4511,6 +5293,52 @@
               <a:t>]</a:t>
             </a:r>
           </a:p>
+          <a:p>
+            <a:r>
+              <a:t>manual_placeholder_hidden: False</a:t>
+            </a:r>
+          </a:p>
+          <a:p/>
+          <a:p>
+            <a:r>
+              <a:t>screen_body_lines:</a:t>
+            </a:r>
+          </a:p>
+          <a:p>
+            <a:r>
+              <a:t>[</a:t>
+            </a:r>
+          </a:p>
+          <a:p>
+            <a:r>
+              <a:t>  "좋은 질문을 만들고",</a:t>
+            </a:r>
+          </a:p>
+          <a:p>
+            <a:r>
+              <a:t>  "답의 출처를 확인하고",</a:t>
+            </a:r>
+          </a:p>
+          <a:p>
+            <a:r>
+              <a:t>  "모르는 것을 남겨두는 법을 배우는 일일지도 모른다"</a:t>
+            </a:r>
+          </a:p>
+          <a:p>
+            <a:r>
+              <a:t>]</a:t>
+            </a:r>
+          </a:p>
+          <a:p>
+            <a:r>
+              <a:t>overflow_body_lines:</a:t>
+            </a:r>
+          </a:p>
+          <a:p>
+            <a:r>
+              <a:t>[]</a:t>
+            </a:r>
+          </a:p>
           <a:p/>
           <a:p>
             <a:r>
@@ -4721,6 +5549,47 @@
               <a:t>]</a:t>
             </a:r>
           </a:p>
+          <a:p>
+            <a:r>
+              <a:t>manual_placeholder_hidden: False</a:t>
+            </a:r>
+          </a:p>
+          <a:p/>
+          <a:p>
+            <a:r>
+              <a:t>screen_body_lines:</a:t>
+            </a:r>
+          </a:p>
+          <a:p>
+            <a:r>
+              <a:t>[</a:t>
+            </a:r>
+          </a:p>
+          <a:p>
+            <a:r>
+              <a:t>  "이제 진짜 시험 문제는 이걸지도 모른다",</a:t>
+            </a:r>
+          </a:p>
+          <a:p>
+            <a:r>
+              <a:t>  "답은 AI가 했는데, 질문은 누가 했습니까?"</a:t>
+            </a:r>
+          </a:p>
+          <a:p>
+            <a:r>
+              <a:t>]</a:t>
+            </a:r>
+          </a:p>
+          <a:p>
+            <a:r>
+              <a:t>overflow_body_lines:</a:t>
+            </a:r>
+          </a:p>
+          <a:p>
+            <a:r>
+              <a:t>[]</a:t>
+            </a:r>
+          </a:p>
           <a:p/>
           <a:p>
             <a:r>
@@ -4931,6 +5800,52 @@
               <a:t>]</a:t>
             </a:r>
           </a:p>
+          <a:p>
+            <a:r>
+              <a:t>manual_placeholder_hidden: False</a:t>
+            </a:r>
+          </a:p>
+          <a:p/>
+          <a:p>
+            <a:r>
+              <a:t>screen_body_lines:</a:t>
+            </a:r>
+          </a:p>
+          <a:p>
+            <a:r>
+              <a:t>[</a:t>
+            </a:r>
+          </a:p>
+          <a:p>
+            <a:r>
+              <a:t>  "BBC 보도는 Royal Observatory 쪽 경고를 AI 의존과 인간 지식의 역할이라는 맥락에서 소개한다",</a:t>
+            </a:r>
+          </a:p>
+          <a:p>
+            <a:r>
+              <a:t>  "이 메시지는 AI 금지가 아니라, 답을 받는 사람이 무엇을 배워야 하느냐는 질문으로 읽는다",</a:t>
+            </a:r>
+          </a:p>
+          <a:p>
+            <a:r>
+              <a:t>  "단일 기관 사례이므로 모든 지식기관의 공식 입장처럼 일반화하지 않는다"</a:t>
+            </a:r>
+          </a:p>
+          <a:p>
+            <a:r>
+              <a:t>]</a:t>
+            </a:r>
+          </a:p>
+          <a:p>
+            <a:r>
+              <a:t>overflow_body_lines:</a:t>
+            </a:r>
+          </a:p>
+          <a:p>
+            <a:r>
+              <a:t>[]</a:t>
+            </a:r>
+          </a:p>
           <a:p/>
           <a:p>
             <a:r>
@@ -5156,6 +6071,52 @@
               <a:t>]</a:t>
             </a:r>
           </a:p>
+          <a:p>
+            <a:r>
+              <a:t>manual_placeholder_hidden: False</a:t>
+            </a:r>
+          </a:p>
+          <a:p/>
+          <a:p>
+            <a:r>
+              <a:t>screen_body_lines:</a:t>
+            </a:r>
+          </a:p>
+          <a:p>
+            <a:r>
+              <a:t>[</a:t>
+            </a:r>
+          </a:p>
+          <a:p>
+            <a:r>
+              <a:t>  "천문학은 답 하나보다 관찰·추론·검증의 과정이 중요한 분야다",</a:t>
+            </a:r>
+          </a:p>
+          <a:p>
+            <a:r>
+              <a:t>  "AI 즉답은 그 과정을 도와줄 수도, 일부 건너뛰게 만들 수도 있다",</a:t>
+            </a:r>
+          </a:p>
+          <a:p>
+            <a:r>
+              <a:t>  "여기서는 사실 증명보다 방송용 문제 제기: 도구가 답을 줄 때 사람의 관찰은 어디에 남는가"</a:t>
+            </a:r>
+          </a:p>
+          <a:p>
+            <a:r>
+              <a:t>]</a:t>
+            </a:r>
+          </a:p>
+          <a:p>
+            <a:r>
+              <a:t>overflow_body_lines:</a:t>
+            </a:r>
+          </a:p>
+          <a:p>
+            <a:r>
+              <a:t>[]</a:t>
+            </a:r>
+          </a:p>
           <a:p/>
           <a:p>
             <a:r>
@@ -5391,6 +6352,52 @@
               <a:t>]</a:t>
             </a:r>
           </a:p>
+          <a:p>
+            <a:r>
+              <a:t>manual_placeholder_hidden: False</a:t>
+            </a:r>
+          </a:p>
+          <a:p/>
+          <a:p>
+            <a:r>
+              <a:t>screen_body_lines:</a:t>
+            </a:r>
+          </a:p>
+          <a:p>
+            <a:r>
+              <a:t>[</a:t>
+            </a:r>
+          </a:p>
+          <a:p>
+            <a:r>
+              <a:t>  "학교, 박물관, 도서관, 과학관도 AI가 설명을 대신하는 시대의 질문을 마주한다",</a:t>
+            </a:r>
+          </a:p>
+          <a:p>
+            <a:r>
+              <a:t>  "UNESCO와 OECD 자료는 AI 교육을 단순 도구 사용이 아니라 역량·원칙의 문제로 다룬다",</a:t>
+            </a:r>
+          </a:p>
+          <a:p>
+            <a:r>
+              <a:t>  "따라서 핵심은 답 제공 경쟁이 아니라 질문·검증·맥락을 가르치는 역할 변화다"</a:t>
+            </a:r>
+          </a:p>
+          <a:p>
+            <a:r>
+              <a:t>]</a:t>
+            </a:r>
+          </a:p>
+          <a:p>
+            <a:r>
+              <a:t>overflow_body_lines:</a:t>
+            </a:r>
+          </a:p>
+          <a:p>
+            <a:r>
+              <a:t>[]</a:t>
+            </a:r>
+          </a:p>
           <a:p/>
           <a:p>
             <a:r>
@@ -5626,6 +6633,52 @@
               <a:t>]</a:t>
             </a:r>
           </a:p>
+          <a:p>
+            <a:r>
+              <a:t>manual_placeholder_hidden: False</a:t>
+            </a:r>
+          </a:p>
+          <a:p/>
+          <a:p>
+            <a:r>
+              <a:t>screen_body_lines:</a:t>
+            </a:r>
+          </a:p>
+          <a:p>
+            <a:r>
+              <a:t>[</a:t>
+            </a:r>
+          </a:p>
+          <a:p>
+            <a:r>
+              <a:t>  "답을 아는 능력인가",</a:t>
+            </a:r>
+          </a:p>
+          <a:p>
+            <a:r>
+              <a:t>  "답을 의심하고 확인하는 능력인가",</a:t>
+            </a:r>
+          </a:p>
+          <a:p>
+            <a:r>
+              <a:t>  "혹은 더 좋은 질문을 만드는 능력인가"</a:t>
+            </a:r>
+          </a:p>
+          <a:p>
+            <a:r>
+              <a:t>]</a:t>
+            </a:r>
+          </a:p>
+          <a:p>
+            <a:r>
+              <a:t>overflow_body_lines:</a:t>
+            </a:r>
+          </a:p>
+          <a:p>
+            <a:r>
+              <a:t>[]</a:t>
+            </a:r>
+          </a:p>
           <a:p/>
           <a:p>
             <a:r>
@@ -5836,6 +6889,42 @@
               <a:t>]</a:t>
             </a:r>
           </a:p>
+          <a:p>
+            <a:r>
+              <a:t>manual_placeholder_hidden: False</a:t>
+            </a:r>
+          </a:p>
+          <a:p/>
+          <a:p>
+            <a:r>
+              <a:t>screen_body_lines:</a:t>
+            </a:r>
+          </a:p>
+          <a:p>
+            <a:r>
+              <a:t>[</a:t>
+            </a:r>
+          </a:p>
+          <a:p>
+            <a:r>
+              <a:t>  "AI가 답을 주면, 사람은 무엇을 덜 하게 될까"</a:t>
+            </a:r>
+          </a:p>
+          <a:p>
+            <a:r>
+              <a:t>]</a:t>
+            </a:r>
+          </a:p>
+          <a:p>
+            <a:r>
+              <a:t>overflow_body_lines:</a:t>
+            </a:r>
+          </a:p>
+          <a:p>
+            <a:r>
+              <a:t>[]</a:t>
+            </a:r>
+          </a:p>
           <a:p/>
           <a:p>
             <a:r>
@@ -6046,6 +7135,52 @@
               <a:t>]</a:t>
             </a:r>
           </a:p>
+          <a:p>
+            <a:r>
+              <a:t>manual_placeholder_hidden: False</a:t>
+            </a:r>
+          </a:p>
+          <a:p/>
+          <a:p>
+            <a:r>
+              <a:t>screen_body_lines:</a:t>
+            </a:r>
+          </a:p>
+          <a:p>
+            <a:r>
+              <a:t>[</a:t>
+            </a:r>
+          </a:p>
+          <a:p>
+            <a:r>
+              <a:t>  "검색어를 바꿔보고, 여러 결과를 비교하고, 출처를 고르는 과정이 있었다",</a:t>
+            </a:r>
+          </a:p>
+          <a:p>
+            <a:r>
+              <a:t>  "이 과정은 느리지만 정보 탐색의 다양성과 판단 훈련을 남긴다",</a:t>
+            </a:r>
+          </a:p>
+          <a:p>
+            <a:r>
+              <a:t>  "Microsoft Research 자료는 generative AI가 정보 탐색 다양성에 어떤 영향을 줄 수 있는지 문제를 제기한다"</a:t>
+            </a:r>
+          </a:p>
+          <a:p>
+            <a:r>
+              <a:t>]</a:t>
+            </a:r>
+          </a:p>
+          <a:p>
+            <a:r>
+              <a:t>overflow_body_lines:</a:t>
+            </a:r>
+          </a:p>
+          <a:p>
+            <a:r>
+              <a:t>[]</a:t>
+            </a:r>
+          </a:p>
           <a:p/>
           <a:p>
             <a:r>
@@ -6269,6 +7404,52 @@
           <a:p>
             <a:r>
               <a:t>]</a:t>
+            </a:r>
+          </a:p>
+          <a:p>
+            <a:r>
+              <a:t>manual_placeholder_hidden: False</a:t>
+            </a:r>
+          </a:p>
+          <a:p/>
+          <a:p>
+            <a:r>
+              <a:t>screen_body_lines:</a:t>
+            </a:r>
+          </a:p>
+          <a:p>
+            <a:r>
+              <a:t>[</a:t>
+            </a:r>
+          </a:p>
+          <a:p>
+            <a:r>
+              <a:t>  "좋은 점: 빠르고, 친절하고, 맥락을 이어준다",</a:t>
+            </a:r>
+          </a:p>
+          <a:p>
+            <a:r>
+              <a:t>  "걱정되는 점: 비교·검증·실패의 경험이 줄어들 가능성이 있다",</a:t>
+            </a:r>
+          </a:p>
+          <a:p>
+            <a:r>
+              <a:t>  "중요: 이것이 곧 학습 저하라는 단정은 아니며, 설계와 교육 원칙에 따라 달라질 수 있다"</a:t>
+            </a:r>
+          </a:p>
+          <a:p>
+            <a:r>
+              <a:t>]</a:t>
+            </a:r>
+          </a:p>
+          <a:p>
+            <a:r>
+              <a:t>overflow_body_lines:</a:t>
+            </a:r>
+          </a:p>
+          <a:p>
+            <a:r>
+              <a:t>[]</a:t>
             </a:r>
           </a:p>
           <a:p/>
@@ -9430,7 +10611,7 @@
           <a:lstStyle/>
           <a:p>
             <a:r>
-              <a:rPr sz="3800" b="1">
+              <a:rPr sz="3800" b="1" u="none">
                 <a:solidFill>
                   <a:srgbClr val="FFFFFF"/>
                 </a:solidFill>
@@ -9449,8 +10630,8 @@
         </p:nvSpPr>
         <p:spPr>
           <a:xfrm>
-            <a:off x="822960" y="3154680"/>
-            <a:ext cx="9875520" cy="914400"/>
+            <a:off x="731520" y="2240280"/>
+            <a:ext cx="9875520" cy="1280160"/>
           </a:xfrm>
           <a:prstGeom prst="rect">
             <a:avLst/>
@@ -9469,7 +10650,7 @@
               </a:spcAft>
             </a:pPr>
             <a:r>
-              <a:rPr sz="2200">
+              <a:rPr sz="2200" b="0" u="none">
                 <a:solidFill>
                   <a:srgbClr val="E1E9EE"/>
                 </a:solidFill>
@@ -9485,7 +10666,7 @@
               </a:spcAft>
             </a:pPr>
             <a:r>
-              <a:rPr sz="2200">
+              <a:rPr sz="2200" b="0" u="none">
                 <a:solidFill>
                   <a:srgbClr val="E1E9EE"/>
                 </a:solidFill>
@@ -9519,7 +10700,7 @@
           <a:lstStyle/>
           <a:p>
             <a:r>
-              <a:rPr sz="800" b="0">
+              <a:rPr sz="800" b="0" u="none">
                 <a:solidFill>
                   <a:srgbClr val="566070"/>
                 </a:solidFill>
@@ -9554,7 +10735,7 @@
           <a:p>
             <a:pPr algn="r"/>
             <a:r>
-              <a:rPr sz="800" b="0">
+              <a:rPr sz="800" b="0" u="none">
                 <a:solidFill>
                   <a:srgbClr val="566070"/>
                 </a:solidFill>
@@ -9614,7 +10795,7 @@
           <a:lstStyle/>
           <a:p>
             <a:r>
-              <a:rPr sz="2800" b="1">
+              <a:rPr sz="2800" b="1" u="none">
                 <a:solidFill>
                   <a:srgbClr val="181C23"/>
                 </a:solidFill>
@@ -9653,7 +10834,7 @@
               </a:spcAft>
             </a:pPr>
             <a:r>
-              <a:rPr sz="2000">
+              <a:rPr sz="2000" b="0" u="none">
                 <a:solidFill>
                   <a:srgbClr val="181C23"/>
                 </a:solidFill>
@@ -9669,7 +10850,7 @@
               </a:spcAft>
             </a:pPr>
             <a:r>
-              <a:rPr sz="2000">
+              <a:rPr sz="2000" b="0" u="none">
                 <a:solidFill>
                   <a:srgbClr val="181C23"/>
                 </a:solidFill>
@@ -9685,7 +10866,7 @@
               </a:spcAft>
             </a:pPr>
             <a:r>
-              <a:rPr sz="2000">
+              <a:rPr sz="2000" b="0" u="none">
                 <a:solidFill>
                   <a:srgbClr val="181C23"/>
                 </a:solidFill>
@@ -9773,7 +10954,7 @@
           <a:lstStyle/>
           <a:p>
             <a:r>
-              <a:rPr sz="800" b="0">
+              <a:rPr sz="800" b="0" u="none">
                 <a:solidFill>
                   <a:srgbClr val="566070"/>
                 </a:solidFill>
@@ -9808,7 +10989,7 @@
           <a:p>
             <a:pPr algn="r"/>
             <a:r>
-              <a:rPr sz="800" b="0">
+              <a:rPr sz="800" b="0" u="none">
                 <a:solidFill>
                   <a:srgbClr val="566070"/>
                 </a:solidFill>
@@ -9913,7 +11094,7 @@
           <a:lstStyle/>
           <a:p>
             <a:r>
-              <a:rPr sz="2800" b="1">
+              <a:rPr sz="2800" b="1" u="none">
                 <a:solidFill>
                   <a:srgbClr val="181C23"/>
                 </a:solidFill>
@@ -9952,7 +11133,7 @@
               </a:spcAft>
             </a:pPr>
             <a:r>
-              <a:rPr sz="2000">
+              <a:rPr sz="2000" b="0" u="none">
                 <a:solidFill>
                   <a:srgbClr val="181C23"/>
                 </a:solidFill>
@@ -9968,7 +11149,7 @@
               </a:spcAft>
             </a:pPr>
             <a:r>
-              <a:rPr sz="2000">
+              <a:rPr sz="2000" b="0" u="none">
                 <a:solidFill>
                   <a:srgbClr val="181C23"/>
                 </a:solidFill>
@@ -9984,7 +11165,7 @@
               </a:spcAft>
             </a:pPr>
             <a:r>
-              <a:rPr sz="2000">
+              <a:rPr sz="2000" b="0" u="none">
                 <a:solidFill>
                   <a:srgbClr val="181C23"/>
                 </a:solidFill>
@@ -10018,7 +11199,7 @@
           <a:lstStyle/>
           <a:p>
             <a:r>
-              <a:rPr sz="800" b="0">
+              <a:rPr sz="800" b="0" u="none">
                 <a:solidFill>
                   <a:srgbClr val="566070"/>
                 </a:solidFill>
@@ -10053,7 +11234,7 @@
           <a:p>
             <a:pPr algn="r"/>
             <a:r>
-              <a:rPr sz="800" b="0">
+              <a:rPr sz="800" b="0" u="none">
                 <a:solidFill>
                   <a:srgbClr val="566070"/>
                 </a:solidFill>
@@ -10113,7 +11294,7 @@
           <a:lstStyle/>
           <a:p>
             <a:r>
-              <a:rPr sz="3400" b="1">
+              <a:rPr sz="3400" b="1" u="none">
                 <a:solidFill>
                   <a:srgbClr val="181C23"/>
                 </a:solidFill>
@@ -10152,7 +11333,7 @@
               </a:spcAft>
             </a:pPr>
             <a:r>
-              <a:rPr sz="2400">
+              <a:rPr sz="2400" b="0" u="none">
                 <a:solidFill>
                   <a:srgbClr val="181C23"/>
                 </a:solidFill>
@@ -10168,7 +11349,7 @@
               </a:spcAft>
             </a:pPr>
             <a:r>
-              <a:rPr sz="2400">
+              <a:rPr sz="2400" b="0" u="none">
                 <a:solidFill>
                   <a:srgbClr val="181C23"/>
                 </a:solidFill>
@@ -10184,7 +11365,7 @@
               </a:spcAft>
             </a:pPr>
             <a:r>
-              <a:rPr sz="2400">
+              <a:rPr sz="2400" b="0" u="none">
                 <a:solidFill>
                   <a:srgbClr val="181C23"/>
                 </a:solidFill>
@@ -10272,7 +11453,7 @@
           <a:lstStyle/>
           <a:p>
             <a:r>
-              <a:rPr sz="800" b="0">
+              <a:rPr sz="800" b="0" u="none">
                 <a:solidFill>
                   <a:srgbClr val="566070"/>
                 </a:solidFill>
@@ -10307,7 +11488,7 @@
           <a:p>
             <a:pPr algn="r"/>
             <a:r>
-              <a:rPr sz="800" b="0">
+              <a:rPr sz="800" b="0" u="none">
                 <a:solidFill>
                   <a:srgbClr val="566070"/>
                 </a:solidFill>
@@ -10410,7 +11591,7 @@
           <a:lstStyle/>
           <a:p>
             <a:r>
-              <a:rPr sz="3400" b="1">
+              <a:rPr sz="3400" b="1" u="none">
                 <a:solidFill>
                   <a:srgbClr val="FFFFFF"/>
                 </a:solidFill>
@@ -10449,7 +11630,7 @@
               </a:spcAft>
             </a:pPr>
             <a:r>
-              <a:rPr sz="2000">
+              <a:rPr sz="2000" b="0" u="none">
                 <a:solidFill>
                   <a:srgbClr val="E2EEF1"/>
                 </a:solidFill>
@@ -10483,7 +11664,7 @@
           <a:lstStyle/>
           <a:p>
             <a:r>
-              <a:rPr sz="800" b="0">
+              <a:rPr sz="800" b="0" u="none">
                 <a:solidFill>
                   <a:srgbClr val="566070"/>
                 </a:solidFill>
@@ -10518,7 +11699,7 @@
           <a:p>
             <a:pPr algn="r"/>
             <a:r>
-              <a:rPr sz="800" b="0">
+              <a:rPr sz="800" b="0" u="none">
                 <a:solidFill>
                   <a:srgbClr val="566070"/>
                 </a:solidFill>
@@ -10578,7 +11759,7 @@
           <a:lstStyle/>
           <a:p>
             <a:r>
-              <a:rPr sz="2800" b="1">
+              <a:rPr sz="2800" b="1" u="none">
                 <a:solidFill>
                   <a:srgbClr val="181C23"/>
                 </a:solidFill>
@@ -10617,7 +11798,7 @@
               </a:spcAft>
             </a:pPr>
             <a:r>
-              <a:rPr sz="2000">
+              <a:rPr sz="2000" b="0" u="none">
                 <a:solidFill>
                   <a:srgbClr val="181C23"/>
                 </a:solidFill>
@@ -10633,7 +11814,7 @@
               </a:spcAft>
             </a:pPr>
             <a:r>
-              <a:rPr sz="2000">
+              <a:rPr sz="2000" b="0" u="none">
                 <a:solidFill>
                   <a:srgbClr val="181C23"/>
                 </a:solidFill>
@@ -10649,7 +11830,7 @@
               </a:spcAft>
             </a:pPr>
             <a:r>
-              <a:rPr sz="2000">
+              <a:rPr sz="2000" b="0" u="none">
                 <a:solidFill>
                   <a:srgbClr val="181C23"/>
                 </a:solidFill>
@@ -10737,7 +11918,7 @@
           <a:lstStyle/>
           <a:p>
             <a:r>
-              <a:rPr sz="800" b="0">
+              <a:rPr sz="800" b="0" u="none">
                 <a:solidFill>
                   <a:srgbClr val="566070"/>
                 </a:solidFill>
@@ -10772,7 +11953,7 @@
           <a:p>
             <a:pPr algn="r"/>
             <a:r>
-              <a:rPr sz="800" b="0">
+              <a:rPr sz="800" b="0" u="none">
                 <a:solidFill>
                   <a:srgbClr val="566070"/>
                 </a:solidFill>
@@ -10832,7 +12013,7 @@
           <a:lstStyle/>
           <a:p>
             <a:r>
-              <a:rPr sz="2800" b="1">
+              <a:rPr sz="2800" b="1" u="none">
                 <a:solidFill>
                   <a:srgbClr val="181C23"/>
                 </a:solidFill>
@@ -10871,7 +12052,7 @@
               </a:spcAft>
             </a:pPr>
             <a:r>
-              <a:rPr sz="2000">
+              <a:rPr sz="2000" b="0" u="none">
                 <a:solidFill>
                   <a:srgbClr val="181C23"/>
                 </a:solidFill>
@@ -10887,7 +12068,7 @@
               </a:spcAft>
             </a:pPr>
             <a:r>
-              <a:rPr sz="2000">
+              <a:rPr sz="2000" b="0" u="none">
                 <a:solidFill>
                   <a:srgbClr val="181C23"/>
                 </a:solidFill>
@@ -10903,7 +12084,7 @@
               </a:spcAft>
             </a:pPr>
             <a:r>
-              <a:rPr sz="2000">
+              <a:rPr sz="2000" b="0" u="none">
                 <a:solidFill>
                   <a:srgbClr val="181C23"/>
                 </a:solidFill>
@@ -10991,7 +12172,7 @@
           <a:lstStyle/>
           <a:p>
             <a:r>
-              <a:rPr sz="800" b="0">
+              <a:rPr sz="800" b="0" u="none">
                 <a:solidFill>
                   <a:srgbClr val="566070"/>
                 </a:solidFill>
@@ -11026,7 +12207,7 @@
           <a:p>
             <a:pPr algn="r"/>
             <a:r>
-              <a:rPr sz="800" b="0">
+              <a:rPr sz="800" b="0" u="none">
                 <a:solidFill>
                   <a:srgbClr val="566070"/>
                 </a:solidFill>
@@ -11086,7 +12267,7 @@
           <a:lstStyle/>
           <a:p>
             <a:r>
-              <a:rPr sz="2800" b="1">
+              <a:rPr sz="2800" b="1" u="none">
                 <a:solidFill>
                   <a:srgbClr val="181C23"/>
                 </a:solidFill>
@@ -11125,7 +12306,7 @@
               </a:spcAft>
             </a:pPr>
             <a:r>
-              <a:rPr sz="2000">
+              <a:rPr sz="2000" b="0" u="none">
                 <a:solidFill>
                   <a:srgbClr val="181C23"/>
                 </a:solidFill>
@@ -11141,7 +12322,7 @@
               </a:spcAft>
             </a:pPr>
             <a:r>
-              <a:rPr sz="2000">
+              <a:rPr sz="2000" b="0" u="none">
                 <a:solidFill>
                   <a:srgbClr val="181C23"/>
                 </a:solidFill>
@@ -11157,7 +12338,7 @@
               </a:spcAft>
             </a:pPr>
             <a:r>
-              <a:rPr sz="2000">
+              <a:rPr sz="2000" b="0" u="none">
                 <a:solidFill>
                   <a:srgbClr val="181C23"/>
                 </a:solidFill>
@@ -11245,7 +12426,7 @@
           <a:lstStyle/>
           <a:p>
             <a:r>
-              <a:rPr sz="800" b="0">
+              <a:rPr sz="800" b="0" u="none">
                 <a:solidFill>
                   <a:srgbClr val="566070"/>
                 </a:solidFill>
@@ -11280,7 +12461,7 @@
           <a:p>
             <a:pPr algn="r"/>
             <a:r>
-              <a:rPr sz="800" b="0">
+              <a:rPr sz="800" b="0" u="none">
                 <a:solidFill>
                   <a:srgbClr val="566070"/>
                 </a:solidFill>
@@ -11340,7 +12521,7 @@
           <a:lstStyle/>
           <a:p>
             <a:r>
-              <a:rPr sz="2700" b="1">
+              <a:rPr sz="2700" b="1" u="none">
                 <a:solidFill>
                   <a:srgbClr val="181C23"/>
                 </a:solidFill>
@@ -11433,7 +12614,7 @@
               </a:spcAft>
             </a:pPr>
             <a:r>
-              <a:rPr sz="1700">
+              <a:rPr sz="1700" b="0" u="none">
                 <a:solidFill>
                   <a:srgbClr val="181C23"/>
                 </a:solidFill>
@@ -11449,7 +12630,7 @@
               </a:spcAft>
             </a:pPr>
             <a:r>
-              <a:rPr sz="1700">
+              <a:rPr sz="1700" b="0" u="none">
                 <a:solidFill>
                   <a:srgbClr val="181C23"/>
                 </a:solidFill>
@@ -11465,7 +12646,7 @@
               </a:spcAft>
             </a:pPr>
             <a:r>
-              <a:rPr sz="1700">
+              <a:rPr sz="1700" b="0" u="none">
                 <a:solidFill>
                   <a:srgbClr val="181C23"/>
                 </a:solidFill>
@@ -11499,7 +12680,7 @@
           <a:lstStyle/>
           <a:p>
             <a:r>
-              <a:rPr sz="800" b="0">
+              <a:rPr sz="800" b="0" u="none">
                 <a:solidFill>
                   <a:srgbClr val="566070"/>
                 </a:solidFill>
@@ -11534,7 +12715,7 @@
           <a:p>
             <a:pPr algn="r"/>
             <a:r>
-              <a:rPr sz="800" b="0">
+              <a:rPr sz="800" b="0" u="none">
                 <a:solidFill>
                   <a:srgbClr val="566070"/>
                 </a:solidFill>
@@ -11595,7 +12776,7 @@
           <a:p>
             <a:pPr algn="ctr"/>
             <a:r>
-              <a:rPr sz="3200" b="1">
+              <a:rPr sz="3200" b="1" u="none">
                 <a:solidFill>
                   <a:srgbClr val="181C23"/>
                 </a:solidFill>
@@ -11634,7 +12815,7 @@
               </a:spcAft>
             </a:pPr>
             <a:r>
-              <a:rPr sz="2300">
+              <a:rPr sz="2300" b="0" u="none">
                 <a:solidFill>
                   <a:srgbClr val="181C23"/>
                 </a:solidFill>
@@ -11650,7 +12831,7 @@
               </a:spcAft>
             </a:pPr>
             <a:r>
-              <a:rPr sz="2300">
+              <a:rPr sz="2300" b="0" u="none">
                 <a:solidFill>
                   <a:srgbClr val="181C23"/>
                 </a:solidFill>
@@ -11666,7 +12847,7 @@
               </a:spcAft>
             </a:pPr>
             <a:r>
-              <a:rPr sz="2300">
+              <a:rPr sz="2300" b="0" u="none">
                 <a:solidFill>
                   <a:srgbClr val="181C23"/>
                 </a:solidFill>
@@ -11700,7 +12881,7 @@
           <a:lstStyle/>
           <a:p>
             <a:r>
-              <a:rPr sz="800" b="0">
+              <a:rPr sz="800" b="0" u="none">
                 <a:solidFill>
                   <a:srgbClr val="566070"/>
                 </a:solidFill>
@@ -11735,7 +12916,7 @@
           <a:p>
             <a:pPr algn="r"/>
             <a:r>
-              <a:rPr sz="800" b="0">
+              <a:rPr sz="800" b="0" u="none">
                 <a:solidFill>
                   <a:srgbClr val="566070"/>
                 </a:solidFill>
@@ -11796,7 +12977,7 @@
           <a:p>
             <a:pPr algn="ctr"/>
             <a:r>
-              <a:rPr sz="3200" b="1">
+              <a:rPr sz="3200" b="1" u="none">
                 <a:solidFill>
                   <a:srgbClr val="181C23"/>
                 </a:solidFill>
@@ -11835,7 +13016,7 @@
               </a:spcAft>
             </a:pPr>
             <a:r>
-              <a:rPr sz="2300">
+              <a:rPr sz="2300" b="0" u="none">
                 <a:solidFill>
                   <a:srgbClr val="181C23"/>
                 </a:solidFill>
@@ -11851,7 +13032,7 @@
               </a:spcAft>
             </a:pPr>
             <a:r>
-              <a:rPr sz="2300">
+              <a:rPr sz="2300" b="0" u="none">
                 <a:solidFill>
                   <a:srgbClr val="181C23"/>
                 </a:solidFill>
@@ -11867,7 +13048,7 @@
               </a:spcAft>
             </a:pPr>
             <a:r>
-              <a:rPr sz="2300">
+              <a:rPr sz="2300" b="0" u="none">
                 <a:solidFill>
                   <a:srgbClr val="181C23"/>
                 </a:solidFill>
@@ -11901,7 +13082,7 @@
           <a:lstStyle/>
           <a:p>
             <a:r>
-              <a:rPr sz="800" b="0">
+              <a:rPr sz="800" b="0" u="none">
                 <a:solidFill>
                   <a:srgbClr val="566070"/>
                 </a:solidFill>
@@ -11936,7 +13117,7 @@
           <a:p>
             <a:pPr algn="r"/>
             <a:r>
-              <a:rPr sz="800" b="0">
+              <a:rPr sz="800" b="0" u="none">
                 <a:solidFill>
                   <a:srgbClr val="566070"/>
                 </a:solidFill>
@@ -11996,7 +13177,7 @@
           <a:lstStyle/>
           <a:p>
             <a:r>
-              <a:rPr sz="3400" b="1">
+              <a:rPr sz="3400" b="1" u="none">
                 <a:solidFill>
                   <a:srgbClr val="181C23"/>
                 </a:solidFill>
@@ -12035,7 +13216,7 @@
               </a:spcAft>
             </a:pPr>
             <a:r>
-              <a:rPr sz="2400">
+              <a:rPr sz="2400" b="0" u="none">
                 <a:solidFill>
                   <a:srgbClr val="181C23"/>
                 </a:solidFill>
@@ -12051,7 +13232,7 @@
               </a:spcAft>
             </a:pPr>
             <a:r>
-              <a:rPr sz="2400">
+              <a:rPr sz="2400" b="0" u="none">
                 <a:solidFill>
                   <a:srgbClr val="181C23"/>
                 </a:solidFill>
@@ -12067,7 +13248,7 @@
               </a:spcAft>
             </a:pPr>
             <a:r>
-              <a:rPr sz="2400">
+              <a:rPr sz="2400" b="0" u="none">
                 <a:solidFill>
                   <a:srgbClr val="181C23"/>
                 </a:solidFill>
@@ -12155,7 +13336,7 @@
           <a:lstStyle/>
           <a:p>
             <a:r>
-              <a:rPr sz="800" b="0">
+              <a:rPr sz="800" b="0" u="none">
                 <a:solidFill>
                   <a:srgbClr val="566070"/>
                 </a:solidFill>
@@ -12190,7 +13371,7 @@
           <a:p>
             <a:pPr algn="r"/>
             <a:r>
-              <a:rPr sz="800" b="0">
+              <a:rPr sz="800" b="0" u="none">
                 <a:solidFill>
                   <a:srgbClr val="566070"/>
                 </a:solidFill>
@@ -12293,7 +13474,7 @@
           <a:lstStyle/>
           <a:p>
             <a:r>
-              <a:rPr sz="3400" b="1">
+              <a:rPr sz="3400" b="1" u="none">
                 <a:solidFill>
                   <a:srgbClr val="FFFFFF"/>
                 </a:solidFill>
@@ -12332,7 +13513,7 @@
               </a:spcAft>
             </a:pPr>
             <a:r>
-              <a:rPr sz="2000">
+              <a:rPr sz="2000" b="0" u="none">
                 <a:solidFill>
                   <a:srgbClr val="E2EEF1"/>
                 </a:solidFill>
@@ -12366,7 +13547,7 @@
           <a:lstStyle/>
           <a:p>
             <a:r>
-              <a:rPr sz="800" b="0">
+              <a:rPr sz="800" b="0" u="none">
                 <a:solidFill>
                   <a:srgbClr val="566070"/>
                 </a:solidFill>
@@ -12401,7 +13582,7 @@
           <a:p>
             <a:pPr algn="r"/>
             <a:r>
-              <a:rPr sz="800" b="0">
+              <a:rPr sz="800" b="0" u="none">
                 <a:solidFill>
                   <a:srgbClr val="566070"/>
                 </a:solidFill>
@@ -12461,7 +13642,7 @@
           <a:lstStyle/>
           <a:p>
             <a:r>
-              <a:rPr sz="2700" b="1">
+              <a:rPr sz="2700" b="1" u="none">
                 <a:solidFill>
                   <a:srgbClr val="181C23"/>
                 </a:solidFill>
@@ -12590,7 +13771,7 @@
               </a:spcAft>
             </a:pPr>
             <a:r>
-              <a:rPr sz="1900">
+              <a:rPr sz="1900" b="0" u="none">
                 <a:solidFill>
                   <a:srgbClr val="181C23"/>
                 </a:solidFill>
@@ -12606,7 +13787,7 @@
               </a:spcAft>
             </a:pPr>
             <a:r>
-              <a:rPr sz="1900">
+              <a:rPr sz="1900" b="0" u="none">
                 <a:solidFill>
                   <a:srgbClr val="181C23"/>
                 </a:solidFill>
@@ -12645,7 +13826,7 @@
               </a:spcAft>
             </a:pPr>
             <a:r>
-              <a:rPr sz="1900">
+              <a:rPr sz="1900" b="0" u="none">
                 <a:solidFill>
                   <a:srgbClr val="181C23"/>
                 </a:solidFill>
@@ -12679,7 +13860,7 @@
           <a:lstStyle/>
           <a:p>
             <a:r>
-              <a:rPr sz="800" b="0">
+              <a:rPr sz="800" b="0" u="none">
                 <a:solidFill>
                   <a:srgbClr val="566070"/>
                 </a:solidFill>
@@ -12714,7 +13895,7 @@
           <a:p>
             <a:pPr algn="r"/>
             <a:r>
-              <a:rPr sz="800" b="0">
+              <a:rPr sz="800" b="0" u="none">
                 <a:solidFill>
                   <a:srgbClr val="566070"/>
                 </a:solidFill>
@@ -12774,7 +13955,7 @@
           <a:lstStyle/>
           <a:p>
             <a:r>
-              <a:rPr sz="2800" b="1">
+              <a:rPr sz="2800" b="1" u="none">
                 <a:solidFill>
                   <a:srgbClr val="181C23"/>
                 </a:solidFill>
@@ -12813,7 +13994,7 @@
               </a:spcAft>
             </a:pPr>
             <a:r>
-              <a:rPr sz="2000">
+              <a:rPr sz="2000" b="0" u="none">
                 <a:solidFill>
                   <a:srgbClr val="181C23"/>
                 </a:solidFill>
@@ -12829,7 +14010,7 @@
               </a:spcAft>
             </a:pPr>
             <a:r>
-              <a:rPr sz="2000">
+              <a:rPr sz="2000" b="0" u="none">
                 <a:solidFill>
                   <a:srgbClr val="181C23"/>
                 </a:solidFill>
@@ -12845,29 +14026,13 @@
               </a:spcAft>
             </a:pPr>
             <a:r>
-              <a:rPr sz="2000">
+              <a:rPr sz="2000" b="0" u="none">
                 <a:solidFill>
                   <a:srgbClr val="181C23"/>
                 </a:solidFill>
                 <a:latin typeface="Malgun Gothic"/>
               </a:rPr>
               <a:t>다른 자료와 비교하는 법</a:t>
-            </a:r>
-          </a:p>
-          <a:p>
-            <a:pPr>
-              <a:spcAft>
-                <a:spcPts val="800"/>
-              </a:spcAft>
-            </a:pPr>
-            <a:r>
-              <a:rPr sz="2000">
-                <a:solidFill>
-                  <a:srgbClr val="181C23"/>
-                </a:solidFill>
-                <a:latin typeface="Malgun Gothic"/>
-              </a:rPr>
-              <a:t>모르는 것을 모른다고 남기는 법</a:t>
             </a:r>
           </a:p>
         </p:txBody>
@@ -12949,7 +14114,7 @@
           <a:lstStyle/>
           <a:p>
             <a:r>
-              <a:rPr sz="800" b="0">
+              <a:rPr sz="800" b="0" u="none">
                 <a:solidFill>
                   <a:srgbClr val="566070"/>
                 </a:solidFill>
@@ -12984,7 +14149,7 @@
           <a:p>
             <a:pPr algn="r"/>
             <a:r>
-              <a:rPr sz="800" b="0">
+              <a:rPr sz="800" b="0" u="none">
                 <a:solidFill>
                   <a:srgbClr val="566070"/>
                 </a:solidFill>
@@ -13045,7 +14210,7 @@
           <a:p>
             <a:pPr algn="ctr"/>
             <a:r>
-              <a:rPr sz="3200" b="1">
+              <a:rPr sz="3200" b="1" u="none">
                 <a:solidFill>
                   <a:srgbClr val="181C23"/>
                 </a:solidFill>
@@ -13084,7 +14249,7 @@
               </a:spcAft>
             </a:pPr>
             <a:r>
-              <a:rPr sz="2300">
+              <a:rPr sz="2300" b="0" u="none">
                 <a:solidFill>
                   <a:srgbClr val="181C23"/>
                 </a:solidFill>
@@ -13100,7 +14265,7 @@
               </a:spcAft>
             </a:pPr>
             <a:r>
-              <a:rPr sz="2300">
+              <a:rPr sz="2300" b="0" u="none">
                 <a:solidFill>
                   <a:srgbClr val="181C23"/>
                 </a:solidFill>
@@ -13116,7 +14281,7 @@
               </a:spcAft>
             </a:pPr>
             <a:r>
-              <a:rPr sz="2300">
+              <a:rPr sz="2300" b="0" u="none">
                 <a:solidFill>
                   <a:srgbClr val="181C23"/>
                 </a:solidFill>
@@ -13150,7 +14315,7 @@
           <a:lstStyle/>
           <a:p>
             <a:r>
-              <a:rPr sz="800" b="0">
+              <a:rPr sz="800" b="0" u="none">
                 <a:solidFill>
                   <a:srgbClr val="566070"/>
                 </a:solidFill>
@@ -13185,7 +14350,7 @@
           <a:p>
             <a:pPr algn="r"/>
             <a:r>
-              <a:rPr sz="800" b="0">
+              <a:rPr sz="800" b="0" u="none">
                 <a:solidFill>
                   <a:srgbClr val="566070"/>
                 </a:solidFill>
@@ -13245,7 +14410,7 @@
           <a:lstStyle/>
           <a:p>
             <a:r>
-              <a:rPr sz="2600" b="1">
+              <a:rPr sz="2600" b="1" u="none">
                 <a:solidFill>
                   <a:srgbClr val="181C23"/>
                 </a:solidFill>
@@ -13284,7 +14449,7 @@
               </a:spcAft>
             </a:pPr>
             <a:r>
-              <a:rPr sz="1800">
+              <a:rPr sz="1800" b="0" u="none">
                 <a:solidFill>
                   <a:srgbClr val="181C23"/>
                 </a:solidFill>
@@ -13300,7 +14465,7 @@
               </a:spcAft>
             </a:pPr>
             <a:r>
-              <a:rPr sz="1800">
+              <a:rPr sz="1800" b="0" u="none">
                 <a:solidFill>
                   <a:srgbClr val="181C23"/>
                 </a:solidFill>
@@ -13316,45 +14481,13 @@
               </a:spcAft>
             </a:pPr>
             <a:r>
-              <a:rPr sz="1800">
+              <a:rPr sz="1800" b="0" u="none">
                 <a:solidFill>
                   <a:srgbClr val="181C23"/>
                 </a:solidFill>
                 <a:latin typeface="Malgun Gothic"/>
               </a:rPr>
               <a:t>AI 접근성/개인화라는 counterpoint</a:t>
-            </a:r>
-          </a:p>
-          <a:p>
-            <a:pPr>
-              <a:spcAft>
-                <a:spcPts val="800"/>
-              </a:spcAft>
-            </a:pPr>
-            <a:r>
-              <a:rPr sz="1800">
-                <a:solidFill>
-                  <a:srgbClr val="181C23"/>
-                </a:solidFill>
-                <a:latin typeface="Malgun Gothic"/>
-              </a:rPr>
-              <a:t>한국 학교·과학관 사례</a:t>
-            </a:r>
-          </a:p>
-          <a:p>
-            <a:pPr>
-              <a:spcAft>
-                <a:spcPts val="800"/>
-              </a:spcAft>
-            </a:pPr>
-            <a:r>
-              <a:rPr sz="1800">
-                <a:solidFill>
-                  <a:srgbClr val="181C23"/>
-                </a:solidFill>
-                <a:latin typeface="Malgun Gothic"/>
-              </a:rPr>
-              <a:t>남은 숫자와 사례는 production 전에 추가 확인</a:t>
             </a:r>
           </a:p>
         </p:txBody>
@@ -13382,7 +14515,7 @@
           <a:lstStyle/>
           <a:p>
             <a:r>
-              <a:rPr sz="800" b="0">
+              <a:rPr sz="800" b="0" u="none">
                 <a:solidFill>
                   <a:srgbClr val="566070"/>
                 </a:solidFill>
@@ -13417,7 +14550,7 @@
           <a:p>
             <a:pPr algn="r"/>
             <a:r>
-              <a:rPr sz="800" b="0">
+              <a:rPr sz="800" b="0" u="none">
                 <a:solidFill>
                   <a:srgbClr val="566070"/>
                 </a:solidFill>
@@ -13478,7 +14611,7 @@
           <a:p>
             <a:pPr algn="ctr"/>
             <a:r>
-              <a:rPr sz="3200" b="1">
+              <a:rPr sz="3200" b="1" u="none">
                 <a:solidFill>
                   <a:srgbClr val="181C23"/>
                 </a:solidFill>
@@ -13517,7 +14650,7 @@
               </a:spcAft>
             </a:pPr>
             <a:r>
-              <a:rPr sz="2300">
+              <a:rPr sz="2300" b="0" u="none">
                 <a:solidFill>
                   <a:srgbClr val="181C23"/>
                 </a:solidFill>
@@ -13533,7 +14666,7 @@
               </a:spcAft>
             </a:pPr>
             <a:r>
-              <a:rPr sz="2300">
+              <a:rPr sz="2300" b="0" u="none">
                 <a:solidFill>
                   <a:srgbClr val="181C23"/>
                 </a:solidFill>
@@ -13549,7 +14682,7 @@
               </a:spcAft>
             </a:pPr>
             <a:r>
-              <a:rPr sz="2300">
+              <a:rPr sz="2300" b="0" u="none">
                 <a:solidFill>
                   <a:srgbClr val="181C23"/>
                 </a:solidFill>
@@ -13583,7 +14716,7 @@
           <a:lstStyle/>
           <a:p>
             <a:r>
-              <a:rPr sz="800" b="0">
+              <a:rPr sz="800" b="0" u="none">
                 <a:solidFill>
                   <a:srgbClr val="566070"/>
                 </a:solidFill>
@@ -13618,7 +14751,7 @@
           <a:p>
             <a:pPr algn="r"/>
             <a:r>
-              <a:rPr sz="800" b="0">
+              <a:rPr sz="800" b="0" u="none">
                 <a:solidFill>
                   <a:srgbClr val="566070"/>
                 </a:solidFill>
@@ -13678,7 +14811,7 @@
           <a:lstStyle/>
           <a:p>
             <a:r>
-              <a:rPr sz="3400" b="1">
+              <a:rPr sz="3400" b="1" u="none">
                 <a:solidFill>
                   <a:srgbClr val="181C23"/>
                 </a:solidFill>
@@ -13717,7 +14850,7 @@
               </a:spcAft>
             </a:pPr>
             <a:r>
-              <a:rPr sz="2400">
+              <a:rPr sz="2400" b="0" u="none">
                 <a:solidFill>
                   <a:srgbClr val="181C23"/>
                 </a:solidFill>
@@ -13733,7 +14866,7 @@
               </a:spcAft>
             </a:pPr>
             <a:r>
-              <a:rPr sz="2400">
+              <a:rPr sz="2400" b="0" u="none">
                 <a:solidFill>
                   <a:srgbClr val="181C23"/>
                 </a:solidFill>
@@ -13821,7 +14954,7 @@
           <a:lstStyle/>
           <a:p>
             <a:r>
-              <a:rPr sz="800" b="0">
+              <a:rPr sz="800" b="0" u="none">
                 <a:solidFill>
                   <a:srgbClr val="566070"/>
                 </a:solidFill>
@@ -13856,7 +14989,7 @@
           <a:p>
             <a:pPr algn="r"/>
             <a:r>
-              <a:rPr sz="800" b="0">
+              <a:rPr sz="800" b="0" u="none">
                 <a:solidFill>
                   <a:srgbClr val="566070"/>
                 </a:solidFill>
@@ -13961,7 +15094,7 @@
           <a:lstStyle/>
           <a:p>
             <a:r>
-              <a:rPr sz="2800" b="1">
+              <a:rPr sz="2800" b="1" u="none">
                 <a:solidFill>
                   <a:srgbClr val="181C23"/>
                 </a:solidFill>
@@ -14000,7 +15133,7 @@
               </a:spcAft>
             </a:pPr>
             <a:r>
-              <a:rPr sz="2000">
+              <a:rPr sz="2000" b="0" u="none">
                 <a:solidFill>
                   <a:srgbClr val="181C23"/>
                 </a:solidFill>
@@ -14016,7 +15149,7 @@
               </a:spcAft>
             </a:pPr>
             <a:r>
-              <a:rPr sz="2000">
+              <a:rPr sz="2000" b="0" u="none">
                 <a:solidFill>
                   <a:srgbClr val="181C23"/>
                 </a:solidFill>
@@ -14032,7 +15165,7 @@
               </a:spcAft>
             </a:pPr>
             <a:r>
-              <a:rPr sz="2000">
+              <a:rPr sz="2000" b="0" u="none">
                 <a:solidFill>
                   <a:srgbClr val="181C23"/>
                 </a:solidFill>
@@ -14066,7 +15199,7 @@
           <a:lstStyle/>
           <a:p>
             <a:r>
-              <a:rPr sz="800" b="0">
+              <a:rPr sz="800" b="0" u="none">
                 <a:solidFill>
                   <a:srgbClr val="566070"/>
                 </a:solidFill>
@@ -14101,7 +15234,7 @@
           <a:p>
             <a:pPr algn="r"/>
             <a:r>
-              <a:rPr sz="800" b="0">
+              <a:rPr sz="800" b="0" u="none">
                 <a:solidFill>
                   <a:srgbClr val="566070"/>
                 </a:solidFill>
@@ -14161,7 +15294,7 @@
           <a:lstStyle/>
           <a:p>
             <a:r>
-              <a:rPr sz="2800" b="1">
+              <a:rPr sz="2800" b="1" u="none">
                 <a:solidFill>
                   <a:srgbClr val="181C23"/>
                 </a:solidFill>
@@ -14200,7 +15333,7 @@
               </a:spcAft>
             </a:pPr>
             <a:r>
-              <a:rPr sz="2000">
+              <a:rPr sz="2000" b="0" u="none">
                 <a:solidFill>
                   <a:srgbClr val="181C23"/>
                 </a:solidFill>
@@ -14216,7 +15349,7 @@
               </a:spcAft>
             </a:pPr>
             <a:r>
-              <a:rPr sz="2000">
+              <a:rPr sz="2000" b="0" u="none">
                 <a:solidFill>
                   <a:srgbClr val="181C23"/>
                 </a:solidFill>
@@ -14232,7 +15365,7 @@
               </a:spcAft>
             </a:pPr>
             <a:r>
-              <a:rPr sz="2000">
+              <a:rPr sz="2000" b="0" u="none">
                 <a:solidFill>
                   <a:srgbClr val="181C23"/>
                 </a:solidFill>
@@ -14320,7 +15453,7 @@
           <a:lstStyle/>
           <a:p>
             <a:r>
-              <a:rPr sz="800" b="0">
+              <a:rPr sz="800" b="0" u="none">
                 <a:solidFill>
                   <a:srgbClr val="566070"/>
                 </a:solidFill>
@@ -14355,7 +15488,7 @@
           <a:p>
             <a:pPr algn="r"/>
             <a:r>
-              <a:rPr sz="800" b="0">
+              <a:rPr sz="800" b="0" u="none">
                 <a:solidFill>
                   <a:srgbClr val="566070"/>
                 </a:solidFill>
@@ -14416,7 +15549,7 @@
           <a:p>
             <a:pPr algn="ctr"/>
             <a:r>
-              <a:rPr sz="3200" b="1">
+              <a:rPr sz="3200" b="1" u="none">
                 <a:solidFill>
                   <a:srgbClr val="181C23"/>
                 </a:solidFill>
@@ -14455,7 +15588,7 @@
               </a:spcAft>
             </a:pPr>
             <a:r>
-              <a:rPr sz="2300">
+              <a:rPr sz="2300" b="0" u="none">
                 <a:solidFill>
                   <a:srgbClr val="181C23"/>
                 </a:solidFill>
@@ -14471,7 +15604,7 @@
               </a:spcAft>
             </a:pPr>
             <a:r>
-              <a:rPr sz="2300">
+              <a:rPr sz="2300" b="0" u="none">
                 <a:solidFill>
                   <a:srgbClr val="181C23"/>
                 </a:solidFill>
@@ -14487,7 +15620,7 @@
               </a:spcAft>
             </a:pPr>
             <a:r>
-              <a:rPr sz="2300">
+              <a:rPr sz="2300" b="0" u="none">
                 <a:solidFill>
                   <a:srgbClr val="181C23"/>
                 </a:solidFill>
@@ -14521,7 +15654,7 @@
           <a:lstStyle/>
           <a:p>
             <a:r>
-              <a:rPr sz="800" b="0">
+              <a:rPr sz="800" b="0" u="none">
                 <a:solidFill>
                   <a:srgbClr val="566070"/>
                 </a:solidFill>
@@ -14556,7 +15689,7 @@
           <a:p>
             <a:pPr algn="r"/>
             <a:r>
-              <a:rPr sz="800" b="0">
+              <a:rPr sz="800" b="0" u="none">
                 <a:solidFill>
                   <a:srgbClr val="566070"/>
                 </a:solidFill>
@@ -14617,7 +15750,7 @@
           <a:p>
             <a:pPr algn="ctr"/>
             <a:r>
-              <a:rPr sz="3200" b="1">
+              <a:rPr sz="3200" b="1" u="none">
                 <a:solidFill>
                   <a:srgbClr val="181C23"/>
                 </a:solidFill>
@@ -14656,7 +15789,7 @@
               </a:spcAft>
             </a:pPr>
             <a:r>
-              <a:rPr sz="2300">
+              <a:rPr sz="2300" b="0" u="none">
                 <a:solidFill>
                   <a:srgbClr val="181C23"/>
                 </a:solidFill>
@@ -14672,7 +15805,7 @@
               </a:spcAft>
             </a:pPr>
             <a:r>
-              <a:rPr sz="2300">
+              <a:rPr sz="2300" b="0" u="none">
                 <a:solidFill>
                   <a:srgbClr val="181C23"/>
                 </a:solidFill>
@@ -14688,7 +15821,7 @@
               </a:spcAft>
             </a:pPr>
             <a:r>
-              <a:rPr sz="2300">
+              <a:rPr sz="2300" b="0" u="none">
                 <a:solidFill>
                   <a:srgbClr val="181C23"/>
                 </a:solidFill>
@@ -14722,7 +15855,7 @@
           <a:lstStyle/>
           <a:p>
             <a:r>
-              <a:rPr sz="800" b="0">
+              <a:rPr sz="800" b="0" u="none">
                 <a:solidFill>
                   <a:srgbClr val="566070"/>
                 </a:solidFill>
@@ -14757,7 +15890,7 @@
           <a:p>
             <a:pPr algn="r"/>
             <a:r>
-              <a:rPr sz="800" b="0">
+              <a:rPr sz="800" b="0" u="none">
                 <a:solidFill>
                   <a:srgbClr val="566070"/>
                 </a:solidFill>
@@ -14860,7 +15993,7 @@
           <a:lstStyle/>
           <a:p>
             <a:r>
-              <a:rPr sz="3400" b="1">
+              <a:rPr sz="3400" b="1" u="none">
                 <a:solidFill>
                   <a:srgbClr val="FFFFFF"/>
                 </a:solidFill>
@@ -14899,7 +16032,7 @@
               </a:spcAft>
             </a:pPr>
             <a:r>
-              <a:rPr sz="2000">
+              <a:rPr sz="2000" b="0" u="none">
                 <a:solidFill>
                   <a:srgbClr val="E2EEF1"/>
                 </a:solidFill>
@@ -14933,7 +16066,7 @@
           <a:lstStyle/>
           <a:p>
             <a:r>
-              <a:rPr sz="800" b="0">
+              <a:rPr sz="800" b="0" u="none">
                 <a:solidFill>
                   <a:srgbClr val="566070"/>
                 </a:solidFill>
@@ -14968,7 +16101,7 @@
           <a:p>
             <a:pPr algn="r"/>
             <a:r>
-              <a:rPr sz="800" b="0">
+              <a:rPr sz="800" b="0" u="none">
                 <a:solidFill>
                   <a:srgbClr val="566070"/>
                 </a:solidFill>
@@ -15028,7 +16161,7 @@
           <a:lstStyle/>
           <a:p>
             <a:r>
-              <a:rPr sz="2800" b="1">
+              <a:rPr sz="2800" b="1" u="none">
                 <a:solidFill>
                   <a:srgbClr val="181C23"/>
                 </a:solidFill>
@@ -15067,7 +16200,7 @@
               </a:spcAft>
             </a:pPr>
             <a:r>
-              <a:rPr sz="2000">
+              <a:rPr sz="2000" b="0" u="none">
                 <a:solidFill>
                   <a:srgbClr val="181C23"/>
                 </a:solidFill>
@@ -15083,7 +16216,7 @@
               </a:spcAft>
             </a:pPr>
             <a:r>
-              <a:rPr sz="2000">
+              <a:rPr sz="2000" b="0" u="none">
                 <a:solidFill>
                   <a:srgbClr val="181C23"/>
                 </a:solidFill>
@@ -15099,7 +16232,7 @@
               </a:spcAft>
             </a:pPr>
             <a:r>
-              <a:rPr sz="2000">
+              <a:rPr sz="2000" b="0" u="none">
                 <a:solidFill>
                   <a:srgbClr val="181C23"/>
                 </a:solidFill>
@@ -15187,7 +16320,7 @@
           <a:lstStyle/>
           <a:p>
             <a:r>
-              <a:rPr sz="800" b="0">
+              <a:rPr sz="800" b="0" u="none">
                 <a:solidFill>
                   <a:srgbClr val="566070"/>
                 </a:solidFill>
@@ -15222,7 +16355,7 @@
           <a:p>
             <a:pPr algn="r"/>
             <a:r>
-              <a:rPr sz="800" b="0">
+              <a:rPr sz="800" b="0" u="none">
                 <a:solidFill>
                   <a:srgbClr val="566070"/>
                 </a:solidFill>
@@ -15282,7 +16415,7 @@
           <a:lstStyle/>
           <a:p>
             <a:r>
-              <a:rPr sz="2700" b="1">
+              <a:rPr sz="2700" b="1" u="none">
                 <a:solidFill>
                   <a:srgbClr val="181C23"/>
                 </a:solidFill>
@@ -15411,7 +16544,7 @@
               </a:spcAft>
             </a:pPr>
             <a:r>
-              <a:rPr sz="1900">
+              <a:rPr sz="1900" b="0" u="none">
                 <a:solidFill>
                   <a:srgbClr val="181C23"/>
                 </a:solidFill>
@@ -15427,7 +16560,7 @@
               </a:spcAft>
             </a:pPr>
             <a:r>
-              <a:rPr sz="1900">
+              <a:rPr sz="1900" b="0" u="none">
                 <a:solidFill>
                   <a:srgbClr val="181C23"/>
                 </a:solidFill>
@@ -15466,7 +16599,7 @@
               </a:spcAft>
             </a:pPr>
             <a:r>
-              <a:rPr sz="1900">
+              <a:rPr sz="1900" b="0" u="none">
                 <a:solidFill>
                   <a:srgbClr val="181C23"/>
                 </a:solidFill>
@@ -15500,7 +16633,7 @@
           <a:lstStyle/>
           <a:p>
             <a:r>
-              <a:rPr sz="800" b="0">
+              <a:rPr sz="800" b="0" u="none">
                 <a:solidFill>
                   <a:srgbClr val="566070"/>
                 </a:solidFill>
@@ -15535,7 +16668,7 @@
           <a:p>
             <a:pPr algn="r"/>
             <a:r>
-              <a:rPr sz="800" b="0">
+              <a:rPr sz="800" b="0" u="none">
                 <a:solidFill>
                   <a:srgbClr val="566070"/>
                 </a:solidFill>

</xml_diff>

<commit_message>
Patch Piti reference layout grammar
</commit_message>
<xml_diff>
--- a/outputs/pptx/ai_knowledge_institution_draft.pptx
+++ b/outputs/pptx/ai_knowledge_institution_draft.pptx
@@ -10630,8 +10630,8 @@
         </p:nvSpPr>
         <p:spPr>
           <a:xfrm>
-            <a:off x="731520" y="2240280"/>
-            <a:ext cx="9875520" cy="1280160"/>
+            <a:off x="822960" y="3154680"/>
+            <a:ext cx="9875520" cy="914400"/>
           </a:xfrm>
           <a:prstGeom prst="rect">
             <a:avLst/>
@@ -12774,7 +12774,6 @@
           </a:bodyPr>
           <a:lstStyle/>
           <a:p>
-            <a:pPr algn="ctr"/>
             <a:r>
               <a:rPr sz="3200" b="1" u="none">
                 <a:solidFill>
@@ -12975,7 +12974,6 @@
           </a:bodyPr>
           <a:lstStyle/>
           <a:p>
-            <a:pPr algn="ctr"/>
             <a:r>
               <a:rPr sz="3200" b="1" u="none">
                 <a:solidFill>
@@ -14208,7 +14206,6 @@
           </a:bodyPr>
           <a:lstStyle/>
           <a:p>
-            <a:pPr algn="ctr"/>
             <a:r>
               <a:rPr sz="3200" b="1" u="none">
                 <a:solidFill>
@@ -14609,7 +14606,6 @@
           </a:bodyPr>
           <a:lstStyle/>
           <a:p>
-            <a:pPr algn="ctr"/>
             <a:r>
               <a:rPr sz="3200" b="1" u="none">
                 <a:solidFill>
@@ -15547,7 +15543,6 @@
           </a:bodyPr>
           <a:lstStyle/>
           <a:p>
-            <a:pPr algn="ctr"/>
             <a:r>
               <a:rPr sz="3200" b="1" u="none">
                 <a:solidFill>
@@ -15748,7 +15743,6 @@
           </a:bodyPr>
           <a:lstStyle/>
           <a:p>
-            <a:pPr algn="ctr"/>
             <a:r>
               <a:rPr sz="3200" b="1" u="none">
                 <a:solidFill>

</xml_diff>

<commit_message>
Add Piti proof object layout scaffold
</commit_message>
<xml_diff>
--- a/outputs/pptx/ai_knowledge_institution_draft.pptx
+++ b/outputs/pptx/ai_knowledge_institution_draft.pptx
@@ -572,6 +572,21 @@
           </a:p>
           <a:p>
             <a:r>
+              <a:t>proof_object_type: none</a:t>
+            </a:r>
+          </a:p>
+          <a:p>
+            <a:r>
+              <a:t>proof_object_required: False</a:t>
+            </a:r>
+          </a:p>
+          <a:p>
+            <a:r>
+              <a:t>proof_object_screen_position: none</a:t>
+            </a:r>
+          </a:p>
+          <a:p>
+            <a:r>
               <a:t>manual_placeholder_hidden: False</a:t>
             </a:r>
           </a:p>
@@ -687,6 +702,62 @@
           <a:p>
             <a:r>
               <a:t>  "prompt_if_ai_image": null</a:t>
+            </a:r>
+          </a:p>
+          <a:p>
+            <a:r>
+              <a:t>}</a:t>
+            </a:r>
+          </a:p>
+          <a:p/>
+          <a:p>
+            <a:r>
+              <a:t>proof_object:</a:t>
+            </a:r>
+          </a:p>
+          <a:p>
+            <a:r>
+              <a:t>{</a:t>
+            </a:r>
+          </a:p>
+          <a:p>
+            <a:r>
+              <a:t>  "type": "none",</a:t>
+            </a:r>
+          </a:p>
+          <a:p>
+            <a:r>
+              <a:t>  "required": false,</a:t>
+            </a:r>
+          </a:p>
+          <a:p>
+            <a:r>
+              <a:t>  "screen_position": "none",</a:t>
+            </a:r>
+          </a:p>
+          <a:p>
+            <a:r>
+              <a:t>  "display_label": "",</a:t>
+            </a:r>
+          </a:p>
+          <a:p>
+            <a:r>
+              <a:t>  "source_url": null,</a:t>
+            </a:r>
+          </a:p>
+          <a:p>
+            <a:r>
+              <a:t>  "image_url": null,</a:t>
+            </a:r>
+          </a:p>
+          <a:p>
+            <a:r>
+              <a:t>  "copyright_risk": false,</a:t>
+            </a:r>
+          </a:p>
+          <a:p>
+            <a:r>
+              <a:t>  "manual_insert_required": false</a:t>
             </a:r>
           </a:p>
           <a:p>
@@ -823,6 +894,21 @@
           </a:p>
           <a:p>
             <a:r>
+              <a:t>proof_object_type: none</a:t>
+            </a:r>
+          </a:p>
+          <a:p>
+            <a:r>
+              <a:t>proof_object_required: False</a:t>
+            </a:r>
+          </a:p>
+          <a:p>
+            <a:r>
+              <a:t>proof_object_screen_position: none</a:t>
+            </a:r>
+          </a:p>
+          <a:p>
+            <a:r>
               <a:t>manual_placeholder_hidden: False</a:t>
             </a:r>
           </a:p>
@@ -953,6 +1039,62 @@
           <a:p>
             <a:r>
               <a:t>  "prompt_if_ai_image": null</a:t>
+            </a:r>
+          </a:p>
+          <a:p>
+            <a:r>
+              <a:t>}</a:t>
+            </a:r>
+          </a:p>
+          <a:p/>
+          <a:p>
+            <a:r>
+              <a:t>proof_object:</a:t>
+            </a:r>
+          </a:p>
+          <a:p>
+            <a:r>
+              <a:t>{</a:t>
+            </a:r>
+          </a:p>
+          <a:p>
+            <a:r>
+              <a:t>  "type": "none",</a:t>
+            </a:r>
+          </a:p>
+          <a:p>
+            <a:r>
+              <a:t>  "required": false,</a:t>
+            </a:r>
+          </a:p>
+          <a:p>
+            <a:r>
+              <a:t>  "screen_position": "none",</a:t>
+            </a:r>
+          </a:p>
+          <a:p>
+            <a:r>
+              <a:t>  "display_label": "",</a:t>
+            </a:r>
+          </a:p>
+          <a:p>
+            <a:r>
+              <a:t>  "source_url": "https://www.microsoft.com/en-us/research/publication/from-searchable-to-non-searchable-generative-ai-and-information-diversity-in-online-information-seeking/",</a:t>
+            </a:r>
+          </a:p>
+          <a:p>
+            <a:r>
+              <a:t>  "image_url": null,</a:t>
+            </a:r>
+          </a:p>
+          <a:p>
+            <a:r>
+              <a:t>  "copyright_risk": false,</a:t>
+            </a:r>
+          </a:p>
+          <a:p>
+            <a:r>
+              <a:t>  "manual_insert_required": false</a:t>
             </a:r>
           </a:p>
           <a:p>
@@ -1104,6 +1246,21 @@
           </a:p>
           <a:p>
             <a:r>
+              <a:t>proof_object_type: article_quote</a:t>
+            </a:r>
+          </a:p>
+          <a:p>
+            <a:r>
+              <a:t>proof_object_required: True</a:t>
+            </a:r>
+          </a:p>
+          <a:p>
+            <a:r>
+              <a:t>proof_object_screen_position: left_half</a:t>
+            </a:r>
+          </a:p>
+          <a:p>
+            <a:r>
               <a:t>manual_placeholder_hidden: False</a:t>
             </a:r>
           </a:p>
@@ -1229,6 +1386,62 @@
           <a:p>
             <a:r>
               <a:t>  "prompt_if_ai_image": null</a:t>
+            </a:r>
+          </a:p>
+          <a:p>
+            <a:r>
+              <a:t>}</a:t>
+            </a:r>
+          </a:p>
+          <a:p/>
+          <a:p>
+            <a:r>
+              <a:t>proof_object:</a:t>
+            </a:r>
+          </a:p>
+          <a:p>
+            <a:r>
+              <a:t>{</a:t>
+            </a:r>
+          </a:p>
+          <a:p>
+            <a:r>
+              <a:t>  "type": "article_quote",</a:t>
+            </a:r>
+          </a:p>
+          <a:p>
+            <a:r>
+              <a:t>  "required": true,</a:t>
+            </a:r>
+          </a:p>
+          <a:p>
+            <a:r>
+              <a:t>  "screen_position": "left_half",</a:t>
+            </a:r>
+          </a:p>
+          <a:p>
+            <a:r>
+              <a:t>  "display_label": "[기사 인용]",</a:t>
+            </a:r>
+          </a:p>
+          <a:p>
+            <a:r>
+              <a:t>  "source_url": "https://www.bbc.com/news/articles/c2023l60370o?at_medium=RSS&amp;at_campaign=rss",</a:t>
+            </a:r>
+          </a:p>
+          <a:p>
+            <a:r>
+              <a:t>  "image_url": null,</a:t>
+            </a:r>
+          </a:p>
+          <a:p>
+            <a:r>
+              <a:t>  "copyright_risk": false,</a:t>
+            </a:r>
+          </a:p>
+          <a:p>
+            <a:r>
+              <a:t>  "manual_insert_required": true</a:t>
             </a:r>
           </a:p>
           <a:p>
@@ -1375,6 +1588,21 @@
           </a:p>
           <a:p>
             <a:r>
+              <a:t>proof_object_type: none</a:t>
+            </a:r>
+          </a:p>
+          <a:p>
+            <a:r>
+              <a:t>proof_object_required: False</a:t>
+            </a:r>
+          </a:p>
+          <a:p>
+            <a:r>
+              <a:t>proof_object_screen_position: none</a:t>
+            </a:r>
+          </a:p>
+          <a:p>
+            <a:r>
               <a:t>manual_placeholder_hidden: False</a:t>
             </a:r>
           </a:p>
@@ -1495,6 +1723,62 @@
           <a:p>
             <a:r>
               <a:t>  "prompt_if_ai_image": null</a:t>
+            </a:r>
+          </a:p>
+          <a:p>
+            <a:r>
+              <a:t>}</a:t>
+            </a:r>
+          </a:p>
+          <a:p/>
+          <a:p>
+            <a:r>
+              <a:t>proof_object:</a:t>
+            </a:r>
+          </a:p>
+          <a:p>
+            <a:r>
+              <a:t>{</a:t>
+            </a:r>
+          </a:p>
+          <a:p>
+            <a:r>
+              <a:t>  "type": "none",</a:t>
+            </a:r>
+          </a:p>
+          <a:p>
+            <a:r>
+              <a:t>  "required": false,</a:t>
+            </a:r>
+          </a:p>
+          <a:p>
+            <a:r>
+              <a:t>  "screen_position": "none",</a:t>
+            </a:r>
+          </a:p>
+          <a:p>
+            <a:r>
+              <a:t>  "display_label": "",</a:t>
+            </a:r>
+          </a:p>
+          <a:p>
+            <a:r>
+              <a:t>  "source_url": null,</a:t>
+            </a:r>
+          </a:p>
+          <a:p>
+            <a:r>
+              <a:t>  "image_url": null,</a:t>
+            </a:r>
+          </a:p>
+          <a:p>
+            <a:r>
+              <a:t>  "copyright_risk": false,</a:t>
+            </a:r>
+          </a:p>
+          <a:p>
+            <a:r>
+              <a:t>  "manual_insert_required": false</a:t>
             </a:r>
           </a:p>
           <a:p>
@@ -1631,6 +1915,21 @@
           </a:p>
           <a:p>
             <a:r>
+              <a:t>proof_object_type: none</a:t>
+            </a:r>
+          </a:p>
+          <a:p>
+            <a:r>
+              <a:t>proof_object_required: False</a:t>
+            </a:r>
+          </a:p>
+          <a:p>
+            <a:r>
+              <a:t>proof_object_screen_position: none</a:t>
+            </a:r>
+          </a:p>
+          <a:p>
+            <a:r>
               <a:t>manual_placeholder_hidden: False</a:t>
             </a:r>
           </a:p>
@@ -1741,6 +2040,62 @@
           <a:p>
             <a:r>
               <a:t>  "prompt_if_ai_image": null</a:t>
+            </a:r>
+          </a:p>
+          <a:p>
+            <a:r>
+              <a:t>}</a:t>
+            </a:r>
+          </a:p>
+          <a:p/>
+          <a:p>
+            <a:r>
+              <a:t>proof_object:</a:t>
+            </a:r>
+          </a:p>
+          <a:p>
+            <a:r>
+              <a:t>{</a:t>
+            </a:r>
+          </a:p>
+          <a:p>
+            <a:r>
+              <a:t>  "type": "none",</a:t>
+            </a:r>
+          </a:p>
+          <a:p>
+            <a:r>
+              <a:t>  "required": false,</a:t>
+            </a:r>
+          </a:p>
+          <a:p>
+            <a:r>
+              <a:t>  "screen_position": "none",</a:t>
+            </a:r>
+          </a:p>
+          <a:p>
+            <a:r>
+              <a:t>  "display_label": "",</a:t>
+            </a:r>
+          </a:p>
+          <a:p>
+            <a:r>
+              <a:t>  "source_url": null,</a:t>
+            </a:r>
+          </a:p>
+          <a:p>
+            <a:r>
+              <a:t>  "image_url": null,</a:t>
+            </a:r>
+          </a:p>
+          <a:p>
+            <a:r>
+              <a:t>  "copyright_risk": false,</a:t>
+            </a:r>
+          </a:p>
+          <a:p>
+            <a:r>
+              <a:t>  "manual_insert_required": false</a:t>
             </a:r>
           </a:p>
           <a:p>
@@ -1877,6 +2232,21 @@
           </a:p>
           <a:p>
             <a:r>
+              <a:t>proof_object_type: none</a:t>
+            </a:r>
+          </a:p>
+          <a:p>
+            <a:r>
+              <a:t>proof_object_required: False</a:t>
+            </a:r>
+          </a:p>
+          <a:p>
+            <a:r>
+              <a:t>proof_object_screen_position: none</a:t>
+            </a:r>
+          </a:p>
+          <a:p>
+            <a:r>
               <a:t>manual_placeholder_hidden: False</a:t>
             </a:r>
           </a:p>
@@ -2007,6 +2377,62 @@
           <a:p>
             <a:r>
               <a:t>  "prompt_if_ai_image": null</a:t>
+            </a:r>
+          </a:p>
+          <a:p>
+            <a:r>
+              <a:t>}</a:t>
+            </a:r>
+          </a:p>
+          <a:p/>
+          <a:p>
+            <a:r>
+              <a:t>proof_object:</a:t>
+            </a:r>
+          </a:p>
+          <a:p>
+            <a:r>
+              <a:t>{</a:t>
+            </a:r>
+          </a:p>
+          <a:p>
+            <a:r>
+              <a:t>  "type": "none",</a:t>
+            </a:r>
+          </a:p>
+          <a:p>
+            <a:r>
+              <a:t>  "required": false,</a:t>
+            </a:r>
+          </a:p>
+          <a:p>
+            <a:r>
+              <a:t>  "screen_position": "none",</a:t>
+            </a:r>
+          </a:p>
+          <a:p>
+            <a:r>
+              <a:t>  "display_label": "",</a:t>
+            </a:r>
+          </a:p>
+          <a:p>
+            <a:r>
+              <a:t>  "source_url": "https://www.oecd.org/en/publications/oecd-digital-education-outlook-2026_062a7394-en.html",</a:t>
+            </a:r>
+          </a:p>
+          <a:p>
+            <a:r>
+              <a:t>  "image_url": null,</a:t>
+            </a:r>
+          </a:p>
+          <a:p>
+            <a:r>
+              <a:t>  "copyright_risk": false,</a:t>
+            </a:r>
+          </a:p>
+          <a:p>
+            <a:r>
+              <a:t>  "manual_insert_required": false</a:t>
             </a:r>
           </a:p>
           <a:p>
@@ -2158,6 +2584,21 @@
           </a:p>
           <a:p>
             <a:r>
+              <a:t>proof_object_type: none</a:t>
+            </a:r>
+          </a:p>
+          <a:p>
+            <a:r>
+              <a:t>proof_object_required: False</a:t>
+            </a:r>
+          </a:p>
+          <a:p>
+            <a:r>
+              <a:t>proof_object_screen_position: none</a:t>
+            </a:r>
+          </a:p>
+          <a:p>
+            <a:r>
               <a:t>manual_placeholder_hidden: False</a:t>
             </a:r>
           </a:p>
@@ -2288,6 +2729,62 @@
           <a:p>
             <a:r>
               <a:t>  "prompt_if_ai_image": null</a:t>
+            </a:r>
+          </a:p>
+          <a:p>
+            <a:r>
+              <a:t>}</a:t>
+            </a:r>
+          </a:p>
+          <a:p/>
+          <a:p>
+            <a:r>
+              <a:t>proof_object:</a:t>
+            </a:r>
+          </a:p>
+          <a:p>
+            <a:r>
+              <a:t>{</a:t>
+            </a:r>
+          </a:p>
+          <a:p>
+            <a:r>
+              <a:t>  "type": "none",</a:t>
+            </a:r>
+          </a:p>
+          <a:p>
+            <a:r>
+              <a:t>  "required": false,</a:t>
+            </a:r>
+          </a:p>
+          <a:p>
+            <a:r>
+              <a:t>  "screen_position": "none",</a:t>
+            </a:r>
+          </a:p>
+          <a:p>
+            <a:r>
+              <a:t>  "display_label": "",</a:t>
+            </a:r>
+          </a:p>
+          <a:p>
+            <a:r>
+              <a:t>  "source_url": "https://www.unesco.org/en/articles/ai-competency-framework-students",</a:t>
+            </a:r>
+          </a:p>
+          <a:p>
+            <a:r>
+              <a:t>  "image_url": null,</a:t>
+            </a:r>
+          </a:p>
+          <a:p>
+            <a:r>
+              <a:t>  "copyright_risk": true,</a:t>
+            </a:r>
+          </a:p>
+          <a:p>
+            <a:r>
+              <a:t>  "manual_insert_required": false</a:t>
             </a:r>
           </a:p>
           <a:p>
@@ -2445,6 +2942,21 @@
           </a:p>
           <a:p>
             <a:r>
+              <a:t>proof_object_type: none</a:t>
+            </a:r>
+          </a:p>
+          <a:p>
+            <a:r>
+              <a:t>proof_object_required: False</a:t>
+            </a:r>
+          </a:p>
+          <a:p>
+            <a:r>
+              <a:t>proof_object_screen_position: none</a:t>
+            </a:r>
+          </a:p>
+          <a:p>
+            <a:r>
               <a:t>manual_placeholder_hidden: False</a:t>
             </a:r>
           </a:p>
@@ -2575,6 +3087,62 @@
           <a:p>
             <a:r>
               <a:t>  "prompt_if_ai_image": null</a:t>
+            </a:r>
+          </a:p>
+          <a:p>
+            <a:r>
+              <a:t>}</a:t>
+            </a:r>
+          </a:p>
+          <a:p/>
+          <a:p>
+            <a:r>
+              <a:t>proof_object:</a:t>
+            </a:r>
+          </a:p>
+          <a:p>
+            <a:r>
+              <a:t>{</a:t>
+            </a:r>
+          </a:p>
+          <a:p>
+            <a:r>
+              <a:t>  "type": "none",</a:t>
+            </a:r>
+          </a:p>
+          <a:p>
+            <a:r>
+              <a:t>  "required": false,</a:t>
+            </a:r>
+          </a:p>
+          <a:p>
+            <a:r>
+              <a:t>  "screen_position": "none",</a:t>
+            </a:r>
+          </a:p>
+          <a:p>
+            <a:r>
+              <a:t>  "display_label": "",</a:t>
+            </a:r>
+          </a:p>
+          <a:p>
+            <a:r>
+              <a:t>  "source_url": "https://www.bbc.com/news/articles/c2023l60370o?at_medium=RSS&amp;at_campaign=rss",</a:t>
+            </a:r>
+          </a:p>
+          <a:p>
+            <a:r>
+              <a:t>  "image_url": null,</a:t>
+            </a:r>
+          </a:p>
+          <a:p>
+            <a:r>
+              <a:t>  "copyright_risk": false,</a:t>
+            </a:r>
+          </a:p>
+          <a:p>
+            <a:r>
+              <a:t>  "manual_insert_required": false</a:t>
             </a:r>
           </a:p>
           <a:p>
@@ -2726,6 +3294,21 @@
           </a:p>
           <a:p>
             <a:r>
+              <a:t>proof_object_type: chart</a:t>
+            </a:r>
+          </a:p>
+          <a:p>
+            <a:r>
+              <a:t>proof_object_required: True</a:t>
+            </a:r>
+          </a:p>
+          <a:p>
+            <a:r>
+              <a:t>proof_object_screen_position: full_width_chart</a:t>
+            </a:r>
+          </a:p>
+          <a:p>
+            <a:r>
               <a:t>manual_placeholder_hidden: False</a:t>
             </a:r>
           </a:p>
@@ -2861,6 +3444,62 @@
           <a:p>
             <a:r>
               <a:t>  "prompt_if_ai_image": null</a:t>
+            </a:r>
+          </a:p>
+          <a:p>
+            <a:r>
+              <a:t>}</a:t>
+            </a:r>
+          </a:p>
+          <a:p/>
+          <a:p>
+            <a:r>
+              <a:t>proof_object:</a:t>
+            </a:r>
+          </a:p>
+          <a:p>
+            <a:r>
+              <a:t>{</a:t>
+            </a:r>
+          </a:p>
+          <a:p>
+            <a:r>
+              <a:t>  "type": "chart",</a:t>
+            </a:r>
+          </a:p>
+          <a:p>
+            <a:r>
+              <a:t>  "required": true,</a:t>
+            </a:r>
+          </a:p>
+          <a:p>
+            <a:r>
+              <a:t>  "screen_position": "full_width_chart",</a:t>
+            </a:r>
+          </a:p>
+          <a:p>
+            <a:r>
+              <a:t>  "display_label": "[차트]",</a:t>
+            </a:r>
+          </a:p>
+          <a:p>
+            <a:r>
+              <a:t>  "source_url": "https://www.oecd.org/en/publications/oecd-digital-education-outlook-2026_062a7394-en.html",</a:t>
+            </a:r>
+          </a:p>
+          <a:p>
+            <a:r>
+              <a:t>  "image_url": null,</a:t>
+            </a:r>
+          </a:p>
+          <a:p>
+            <a:r>
+              <a:t>  "copyright_risk": false,</a:t>
+            </a:r>
+          </a:p>
+          <a:p>
+            <a:r>
+              <a:t>  "manual_insert_required": true</a:t>
             </a:r>
           </a:p>
           <a:p>
@@ -3017,6 +3656,21 @@
           </a:p>
           <a:p>
             <a:r>
+              <a:t>proof_object_type: diagram</a:t>
+            </a:r>
+          </a:p>
+          <a:p>
+            <a:r>
+              <a:t>proof_object_required: True</a:t>
+            </a:r>
+          </a:p>
+          <a:p>
+            <a:r>
+              <a:t>proof_object_screen_position: left_half</a:t>
+            </a:r>
+          </a:p>
+          <a:p>
+            <a:r>
               <a:t>manual_placeholder_hidden: False</a:t>
             </a:r>
           </a:p>
@@ -3147,6 +3801,62 @@
           <a:p>
             <a:r>
               <a:t>  "prompt_if_ai_image": null</a:t>
+            </a:r>
+          </a:p>
+          <a:p>
+            <a:r>
+              <a:t>}</a:t>
+            </a:r>
+          </a:p>
+          <a:p/>
+          <a:p>
+            <a:r>
+              <a:t>proof_object:</a:t>
+            </a:r>
+          </a:p>
+          <a:p>
+            <a:r>
+              <a:t>{</a:t>
+            </a:r>
+          </a:p>
+          <a:p>
+            <a:r>
+              <a:t>  "type": "diagram",</a:t>
+            </a:r>
+          </a:p>
+          <a:p>
+            <a:r>
+              <a:t>  "required": true,</a:t>
+            </a:r>
+          </a:p>
+          <a:p>
+            <a:r>
+              <a:t>  "screen_position": "left_half",</a:t>
+            </a:r>
+          </a:p>
+          <a:p>
+            <a:r>
+              <a:t>  "display_label": "[도식]",</a:t>
+            </a:r>
+          </a:p>
+          <a:p>
+            <a:r>
+              <a:t>  "source_url": "https://www.korea.kr/news/policyNewsView.do?newsId=148912089",</a:t>
+            </a:r>
+          </a:p>
+          <a:p>
+            <a:r>
+              <a:t>  "image_url": null,</a:t>
+            </a:r>
+          </a:p>
+          <a:p>
+            <a:r>
+              <a:t>  "copyright_risk": false,</a:t>
+            </a:r>
+          </a:p>
+          <a:p>
+            <a:r>
+              <a:t>  "manual_insert_required": true</a:t>
             </a:r>
           </a:p>
           <a:p>
@@ -3298,6 +4008,21 @@
           </a:p>
           <a:p>
             <a:r>
+              <a:t>proof_object_type: none</a:t>
+            </a:r>
+          </a:p>
+          <a:p>
+            <a:r>
+              <a:t>proof_object_required: False</a:t>
+            </a:r>
+          </a:p>
+          <a:p>
+            <a:r>
+              <a:t>proof_object_screen_position: none</a:t>
+            </a:r>
+          </a:p>
+          <a:p>
+            <a:r>
               <a:t>manual_placeholder_hidden: False</a:t>
             </a:r>
           </a:p>
@@ -3423,6 +4148,62 @@
           <a:p>
             <a:r>
               <a:t>  "prompt_if_ai_image": null</a:t>
+            </a:r>
+          </a:p>
+          <a:p>
+            <a:r>
+              <a:t>}</a:t>
+            </a:r>
+          </a:p>
+          <a:p/>
+          <a:p>
+            <a:r>
+              <a:t>proof_object:</a:t>
+            </a:r>
+          </a:p>
+          <a:p>
+            <a:r>
+              <a:t>{</a:t>
+            </a:r>
+          </a:p>
+          <a:p>
+            <a:r>
+              <a:t>  "type": "none",</a:t>
+            </a:r>
+          </a:p>
+          <a:p>
+            <a:r>
+              <a:t>  "required": false,</a:t>
+            </a:r>
+          </a:p>
+          <a:p>
+            <a:r>
+              <a:t>  "screen_position": "none",</a:t>
+            </a:r>
+          </a:p>
+          <a:p>
+            <a:r>
+              <a:t>  "display_label": "",</a:t>
+            </a:r>
+          </a:p>
+          <a:p>
+            <a:r>
+              <a:t>  "source_url": "https://www.microsoft.com/en-us/research/publication/from-searchable-to-non-searchable-generative-ai-and-information-diversity-in-online-information-seeking/",</a:t>
+            </a:r>
+          </a:p>
+          <a:p>
+            <a:r>
+              <a:t>  "image_url": null,</a:t>
+            </a:r>
+          </a:p>
+          <a:p>
+            <a:r>
+              <a:t>  "copyright_risk": false,</a:t>
+            </a:r>
+          </a:p>
+          <a:p>
+            <a:r>
+              <a:t>  "manual_insert_required": false</a:t>
             </a:r>
           </a:p>
           <a:p>
@@ -3564,6 +4345,21 @@
           </a:p>
           <a:p>
             <a:r>
+              <a:t>proof_object_type: none</a:t>
+            </a:r>
+          </a:p>
+          <a:p>
+            <a:r>
+              <a:t>proof_object_required: False</a:t>
+            </a:r>
+          </a:p>
+          <a:p>
+            <a:r>
+              <a:t>proof_object_screen_position: none</a:t>
+            </a:r>
+          </a:p>
+          <a:p>
+            <a:r>
               <a:t>manual_placeholder_hidden: False</a:t>
             </a:r>
           </a:p>
@@ -3694,6 +4490,62 @@
           <a:p>
             <a:r>
               <a:t>  "prompt_if_ai_image": null</a:t>
+            </a:r>
+          </a:p>
+          <a:p>
+            <a:r>
+              <a:t>}</a:t>
+            </a:r>
+          </a:p>
+          <a:p/>
+          <a:p>
+            <a:r>
+              <a:t>proof_object:</a:t>
+            </a:r>
+          </a:p>
+          <a:p>
+            <a:r>
+              <a:t>{</a:t>
+            </a:r>
+          </a:p>
+          <a:p>
+            <a:r>
+              <a:t>  "type": "none",</a:t>
+            </a:r>
+          </a:p>
+          <a:p>
+            <a:r>
+              <a:t>  "required": false,</a:t>
+            </a:r>
+          </a:p>
+          <a:p>
+            <a:r>
+              <a:t>  "screen_position": "none",</a:t>
+            </a:r>
+          </a:p>
+          <a:p>
+            <a:r>
+              <a:t>  "display_label": "",</a:t>
+            </a:r>
+          </a:p>
+          <a:p>
+            <a:r>
+              <a:t>  "source_url": "https://www.microsoft.com/en-us/research/publication/from-searchable-to-non-searchable-generative-ai-and-information-diversity-in-online-information-seeking/",</a:t>
+            </a:r>
+          </a:p>
+          <a:p>
+            <a:r>
+              <a:t>  "image_url": null,</a:t>
+            </a:r>
+          </a:p>
+          <a:p>
+            <a:r>
+              <a:t>  "copyright_risk": false,</a:t>
+            </a:r>
+          </a:p>
+          <a:p>
+            <a:r>
+              <a:t>  "manual_insert_required": false</a:t>
             </a:r>
           </a:p>
           <a:p>
@@ -3845,6 +4697,21 @@
           </a:p>
           <a:p>
             <a:r>
+              <a:t>proof_object_type: none</a:t>
+            </a:r>
+          </a:p>
+          <a:p>
+            <a:r>
+              <a:t>proof_object_required: False</a:t>
+            </a:r>
+          </a:p>
+          <a:p>
+            <a:r>
+              <a:t>proof_object_screen_position: none</a:t>
+            </a:r>
+          </a:p>
+          <a:p>
+            <a:r>
               <a:t>manual_placeholder_hidden: False</a:t>
             </a:r>
           </a:p>
@@ -3955,6 +4822,62 @@
           <a:p>
             <a:r>
               <a:t>  "prompt_if_ai_image": null</a:t>
+            </a:r>
+          </a:p>
+          <a:p>
+            <a:r>
+              <a:t>}</a:t>
+            </a:r>
+          </a:p>
+          <a:p/>
+          <a:p>
+            <a:r>
+              <a:t>proof_object:</a:t>
+            </a:r>
+          </a:p>
+          <a:p>
+            <a:r>
+              <a:t>{</a:t>
+            </a:r>
+          </a:p>
+          <a:p>
+            <a:r>
+              <a:t>  "type": "none",</a:t>
+            </a:r>
+          </a:p>
+          <a:p>
+            <a:r>
+              <a:t>  "required": false,</a:t>
+            </a:r>
+          </a:p>
+          <a:p>
+            <a:r>
+              <a:t>  "screen_position": "none",</a:t>
+            </a:r>
+          </a:p>
+          <a:p>
+            <a:r>
+              <a:t>  "display_label": "",</a:t>
+            </a:r>
+          </a:p>
+          <a:p>
+            <a:r>
+              <a:t>  "source_url": null,</a:t>
+            </a:r>
+          </a:p>
+          <a:p>
+            <a:r>
+              <a:t>  "image_url": null,</a:t>
+            </a:r>
+          </a:p>
+          <a:p>
+            <a:r>
+              <a:t>  "copyright_risk": false,</a:t>
+            </a:r>
+          </a:p>
+          <a:p>
+            <a:r>
+              <a:t>  "manual_insert_required": false</a:t>
             </a:r>
           </a:p>
           <a:p>
@@ -4091,6 +5014,21 @@
           </a:p>
           <a:p>
             <a:r>
+              <a:t>proof_object_type: diagram</a:t>
+            </a:r>
+          </a:p>
+          <a:p>
+            <a:r>
+              <a:t>proof_object_required: True</a:t>
+            </a:r>
+          </a:p>
+          <a:p>
+            <a:r>
+              <a:t>proof_object_screen_position: left_half</a:t>
+            </a:r>
+          </a:p>
+          <a:p>
+            <a:r>
               <a:t>manual_placeholder_hidden: False</a:t>
             </a:r>
           </a:p>
@@ -4221,6 +5159,62 @@
           <a:p>
             <a:r>
               <a:t>  "prompt_if_ai_image": null</a:t>
+            </a:r>
+          </a:p>
+          <a:p>
+            <a:r>
+              <a:t>}</a:t>
+            </a:r>
+          </a:p>
+          <a:p/>
+          <a:p>
+            <a:r>
+              <a:t>proof_object:</a:t>
+            </a:r>
+          </a:p>
+          <a:p>
+            <a:r>
+              <a:t>{</a:t>
+            </a:r>
+          </a:p>
+          <a:p>
+            <a:r>
+              <a:t>  "type": "diagram",</a:t>
+            </a:r>
+          </a:p>
+          <a:p>
+            <a:r>
+              <a:t>  "required": true,</a:t>
+            </a:r>
+          </a:p>
+          <a:p>
+            <a:r>
+              <a:t>  "screen_position": "left_half",</a:t>
+            </a:r>
+          </a:p>
+          <a:p>
+            <a:r>
+              <a:t>  "display_label": "[도식]",</a:t>
+            </a:r>
+          </a:p>
+          <a:p>
+            <a:r>
+              <a:t>  "source_url": "https://www.unesco.org/en/articles/ai-and-education-protecting-rights-learners",</a:t>
+            </a:r>
+          </a:p>
+          <a:p>
+            <a:r>
+              <a:t>  "image_url": null,</a:t>
+            </a:r>
+          </a:p>
+          <a:p>
+            <a:r>
+              <a:t>  "copyright_risk": false,</a:t>
+            </a:r>
+          </a:p>
+          <a:p>
+            <a:r>
+              <a:t>  "manual_insert_required": true</a:t>
             </a:r>
           </a:p>
           <a:p>
@@ -4372,6 +5366,21 @@
           </a:p>
           <a:p>
             <a:r>
+              <a:t>proof_object_type: none</a:t>
+            </a:r>
+          </a:p>
+          <a:p>
+            <a:r>
+              <a:t>proof_object_required: False</a:t>
+            </a:r>
+          </a:p>
+          <a:p>
+            <a:r>
+              <a:t>proof_object_screen_position: none</a:t>
+            </a:r>
+          </a:p>
+          <a:p>
+            <a:r>
               <a:t>manual_placeholder_hidden: False</a:t>
             </a:r>
           </a:p>
@@ -4512,6 +5521,62 @@
           <a:p>
             <a:r>
               <a:t>  "prompt_if_ai_image": null</a:t>
+            </a:r>
+          </a:p>
+          <a:p>
+            <a:r>
+              <a:t>}</a:t>
+            </a:r>
+          </a:p>
+          <a:p/>
+          <a:p>
+            <a:r>
+              <a:t>proof_object:</a:t>
+            </a:r>
+          </a:p>
+          <a:p>
+            <a:r>
+              <a:t>{</a:t>
+            </a:r>
+          </a:p>
+          <a:p>
+            <a:r>
+              <a:t>  "type": "none",</a:t>
+            </a:r>
+          </a:p>
+          <a:p>
+            <a:r>
+              <a:t>  "required": false,</a:t>
+            </a:r>
+          </a:p>
+          <a:p>
+            <a:r>
+              <a:t>  "screen_position": "none",</a:t>
+            </a:r>
+          </a:p>
+          <a:p>
+            <a:r>
+              <a:t>  "display_label": "",</a:t>
+            </a:r>
+          </a:p>
+          <a:p>
+            <a:r>
+              <a:t>  "source_url": "https://www.unesco.org/en/articles/ai-competency-framework-students",</a:t>
+            </a:r>
+          </a:p>
+          <a:p>
+            <a:r>
+              <a:t>  "image_url": null,</a:t>
+            </a:r>
+          </a:p>
+          <a:p>
+            <a:r>
+              <a:t>  "copyright_risk": false,</a:t>
+            </a:r>
+          </a:p>
+          <a:p>
+            <a:r>
+              <a:t>  "manual_insert_required": false</a:t>
             </a:r>
           </a:p>
           <a:p>
@@ -4673,6 +5738,21 @@
           </a:p>
           <a:p>
             <a:r>
+              <a:t>proof_object_type: diagram</a:t>
+            </a:r>
+          </a:p>
+          <a:p>
+            <a:r>
+              <a:t>proof_object_required: True</a:t>
+            </a:r>
+          </a:p>
+          <a:p>
+            <a:r>
+              <a:t>proof_object_screen_position: left_half</a:t>
+            </a:r>
+          </a:p>
+          <a:p>
+            <a:r>
               <a:t>manual_placeholder_hidden: False</a:t>
             </a:r>
           </a:p>
@@ -4798,6 +5878,62 @@
           <a:p>
             <a:r>
               <a:t>  "prompt_if_ai_image": null</a:t>
+            </a:r>
+          </a:p>
+          <a:p>
+            <a:r>
+              <a:t>}</a:t>
+            </a:r>
+          </a:p>
+          <a:p/>
+          <a:p>
+            <a:r>
+              <a:t>proof_object:</a:t>
+            </a:r>
+          </a:p>
+          <a:p>
+            <a:r>
+              <a:t>{</a:t>
+            </a:r>
+          </a:p>
+          <a:p>
+            <a:r>
+              <a:t>  "type": "diagram",</a:t>
+            </a:r>
+          </a:p>
+          <a:p>
+            <a:r>
+              <a:t>  "required": true,</a:t>
+            </a:r>
+          </a:p>
+          <a:p>
+            <a:r>
+              <a:t>  "screen_position": "left_half",</a:t>
+            </a:r>
+          </a:p>
+          <a:p>
+            <a:r>
+              <a:t>  "display_label": "[도식]",</a:t>
+            </a:r>
+          </a:p>
+          <a:p>
+            <a:r>
+              <a:t>  "source_url": "https://www.bbc.com/news/articles/c2023l60370o?at_medium=RSS&amp;at_campaign=rss",</a:t>
+            </a:r>
+          </a:p>
+          <a:p>
+            <a:r>
+              <a:t>  "image_url": null,</a:t>
+            </a:r>
+          </a:p>
+          <a:p>
+            <a:r>
+              <a:t>  "copyright_risk": false,</a:t>
+            </a:r>
+          </a:p>
+          <a:p>
+            <a:r>
+              <a:t>  "manual_insert_required": true</a:t>
             </a:r>
           </a:p>
           <a:p>
@@ -4939,6 +6075,21 @@
           </a:p>
           <a:p>
             <a:r>
+              <a:t>proof_object_type: none</a:t>
+            </a:r>
+          </a:p>
+          <a:p>
+            <a:r>
+              <a:t>proof_object_required: False</a:t>
+            </a:r>
+          </a:p>
+          <a:p>
+            <a:r>
+              <a:t>proof_object_screen_position: none</a:t>
+            </a:r>
+          </a:p>
+          <a:p>
+            <a:r>
               <a:t>manual_placeholder_hidden: False</a:t>
             </a:r>
           </a:p>
@@ -5114,6 +6265,62 @@
           <a:p>
             <a:r>
               <a:t>  "prompt_if_ai_image": null</a:t>
+            </a:r>
+          </a:p>
+          <a:p>
+            <a:r>
+              <a:t>}</a:t>
+            </a:r>
+          </a:p>
+          <a:p/>
+          <a:p>
+            <a:r>
+              <a:t>proof_object:</a:t>
+            </a:r>
+          </a:p>
+          <a:p>
+            <a:r>
+              <a:t>{</a:t>
+            </a:r>
+          </a:p>
+          <a:p>
+            <a:r>
+              <a:t>  "type": "none",</a:t>
+            </a:r>
+          </a:p>
+          <a:p>
+            <a:r>
+              <a:t>  "required": false,</a:t>
+            </a:r>
+          </a:p>
+          <a:p>
+            <a:r>
+              <a:t>  "screen_position": "none",</a:t>
+            </a:r>
+          </a:p>
+          <a:p>
+            <a:r>
+              <a:t>  "display_label": "",</a:t>
+            </a:r>
+          </a:p>
+          <a:p>
+            <a:r>
+              <a:t>  "source_url": "https://www.bbc.com/news/articles/c2023l60370o?at_medium=RSS&amp;at_campaign=rss",</a:t>
+            </a:r>
+          </a:p>
+          <a:p>
+            <a:r>
+              <a:t>  "image_url": null,</a:t>
+            </a:r>
+          </a:p>
+          <a:p>
+            <a:r>
+              <a:t>  "copyright_risk": false,</a:t>
+            </a:r>
+          </a:p>
+          <a:p>
+            <a:r>
+              <a:t>  "manual_insert_required": false</a:t>
             </a:r>
           </a:p>
           <a:p>
@@ -5295,6 +6502,21 @@
           </a:p>
           <a:p>
             <a:r>
+              <a:t>proof_object_type: none</a:t>
+            </a:r>
+          </a:p>
+          <a:p>
+            <a:r>
+              <a:t>proof_object_required: False</a:t>
+            </a:r>
+          </a:p>
+          <a:p>
+            <a:r>
+              <a:t>proof_object_screen_position: none</a:t>
+            </a:r>
+          </a:p>
+          <a:p>
+            <a:r>
               <a:t>manual_placeholder_hidden: False</a:t>
             </a:r>
           </a:p>
@@ -5415,6 +6637,62 @@
           <a:p>
             <a:r>
               <a:t>  "prompt_if_ai_image": null</a:t>
+            </a:r>
+          </a:p>
+          <a:p>
+            <a:r>
+              <a:t>}</a:t>
+            </a:r>
+          </a:p>
+          <a:p/>
+          <a:p>
+            <a:r>
+              <a:t>proof_object:</a:t>
+            </a:r>
+          </a:p>
+          <a:p>
+            <a:r>
+              <a:t>{</a:t>
+            </a:r>
+          </a:p>
+          <a:p>
+            <a:r>
+              <a:t>  "type": "none",</a:t>
+            </a:r>
+          </a:p>
+          <a:p>
+            <a:r>
+              <a:t>  "required": false,</a:t>
+            </a:r>
+          </a:p>
+          <a:p>
+            <a:r>
+              <a:t>  "screen_position": "none",</a:t>
+            </a:r>
+          </a:p>
+          <a:p>
+            <a:r>
+              <a:t>  "display_label": "",</a:t>
+            </a:r>
+          </a:p>
+          <a:p>
+            <a:r>
+              <a:t>  "source_url": null,</a:t>
+            </a:r>
+          </a:p>
+          <a:p>
+            <a:r>
+              <a:t>  "image_url": null,</a:t>
+            </a:r>
+          </a:p>
+          <a:p>
+            <a:r>
+              <a:t>  "copyright_risk": false,</a:t>
+            </a:r>
+          </a:p>
+          <a:p>
+            <a:r>
+              <a:t>  "manual_insert_required": false</a:t>
             </a:r>
           </a:p>
           <a:p>
@@ -5551,6 +6829,21 @@
           </a:p>
           <a:p>
             <a:r>
+              <a:t>proof_object_type: none</a:t>
+            </a:r>
+          </a:p>
+          <a:p>
+            <a:r>
+              <a:t>proof_object_required: False</a:t>
+            </a:r>
+          </a:p>
+          <a:p>
+            <a:r>
+              <a:t>proof_object_screen_position: none</a:t>
+            </a:r>
+          </a:p>
+          <a:p>
+            <a:r>
               <a:t>manual_placeholder_hidden: False</a:t>
             </a:r>
           </a:p>
@@ -5666,6 +6959,62 @@
           <a:p>
             <a:r>
               <a:t>  "prompt_if_ai_image": null</a:t>
+            </a:r>
+          </a:p>
+          <a:p>
+            <a:r>
+              <a:t>}</a:t>
+            </a:r>
+          </a:p>
+          <a:p/>
+          <a:p>
+            <a:r>
+              <a:t>proof_object:</a:t>
+            </a:r>
+          </a:p>
+          <a:p>
+            <a:r>
+              <a:t>{</a:t>
+            </a:r>
+          </a:p>
+          <a:p>
+            <a:r>
+              <a:t>  "type": "none",</a:t>
+            </a:r>
+          </a:p>
+          <a:p>
+            <a:r>
+              <a:t>  "required": false,</a:t>
+            </a:r>
+          </a:p>
+          <a:p>
+            <a:r>
+              <a:t>  "screen_position": "none",</a:t>
+            </a:r>
+          </a:p>
+          <a:p>
+            <a:r>
+              <a:t>  "display_label": "",</a:t>
+            </a:r>
+          </a:p>
+          <a:p>
+            <a:r>
+              <a:t>  "source_url": null,</a:t>
+            </a:r>
+          </a:p>
+          <a:p>
+            <a:r>
+              <a:t>  "image_url": null,</a:t>
+            </a:r>
+          </a:p>
+          <a:p>
+            <a:r>
+              <a:t>  "copyright_risk": false,</a:t>
+            </a:r>
+          </a:p>
+          <a:p>
+            <a:r>
+              <a:t>  "manual_insert_required": false</a:t>
             </a:r>
           </a:p>
           <a:p>
@@ -5802,6 +7151,21 @@
           </a:p>
           <a:p>
             <a:r>
+              <a:t>proof_object_type: article_quote</a:t>
+            </a:r>
+          </a:p>
+          <a:p>
+            <a:r>
+              <a:t>proof_object_required: True</a:t>
+            </a:r>
+          </a:p>
+          <a:p>
+            <a:r>
+              <a:t>proof_object_screen_position: left_half</a:t>
+            </a:r>
+          </a:p>
+          <a:p>
+            <a:r>
               <a:t>manual_placeholder_hidden: False</a:t>
             </a:r>
           </a:p>
@@ -5927,6 +7291,62 @@
           <a:p>
             <a:r>
               <a:t>  "prompt_if_ai_image": null</a:t>
+            </a:r>
+          </a:p>
+          <a:p>
+            <a:r>
+              <a:t>}</a:t>
+            </a:r>
+          </a:p>
+          <a:p/>
+          <a:p>
+            <a:r>
+              <a:t>proof_object:</a:t>
+            </a:r>
+          </a:p>
+          <a:p>
+            <a:r>
+              <a:t>{</a:t>
+            </a:r>
+          </a:p>
+          <a:p>
+            <a:r>
+              <a:t>  "type": "article_quote",</a:t>
+            </a:r>
+          </a:p>
+          <a:p>
+            <a:r>
+              <a:t>  "required": true,</a:t>
+            </a:r>
+          </a:p>
+          <a:p>
+            <a:r>
+              <a:t>  "screen_position": "left_half",</a:t>
+            </a:r>
+          </a:p>
+          <a:p>
+            <a:r>
+              <a:t>  "display_label": "[기사 인용]",</a:t>
+            </a:r>
+          </a:p>
+          <a:p>
+            <a:r>
+              <a:t>  "source_url": "https://www.bbc.com/news/articles/c2023l60370o?at_medium=RSS&amp;at_campaign=rss",</a:t>
+            </a:r>
+          </a:p>
+          <a:p>
+            <a:r>
+              <a:t>  "image_url": null,</a:t>
+            </a:r>
+          </a:p>
+          <a:p>
+            <a:r>
+              <a:t>  "copyright_risk": false,</a:t>
+            </a:r>
+          </a:p>
+          <a:p>
+            <a:r>
+              <a:t>  "manual_insert_required": true</a:t>
             </a:r>
           </a:p>
           <a:p>
@@ -6073,6 +7493,21 @@
           </a:p>
           <a:p>
             <a:r>
+              <a:t>proof_object_type: none</a:t>
+            </a:r>
+          </a:p>
+          <a:p>
+            <a:r>
+              <a:t>proof_object_required: False</a:t>
+            </a:r>
+          </a:p>
+          <a:p>
+            <a:r>
+              <a:t>proof_object_screen_position: none</a:t>
+            </a:r>
+          </a:p>
+          <a:p>
+            <a:r>
               <a:t>manual_placeholder_hidden: False</a:t>
             </a:r>
           </a:p>
@@ -6203,6 +7638,62 @@
           <a:p>
             <a:r>
               <a:t>  "prompt_if_ai_image": null</a:t>
+            </a:r>
+          </a:p>
+          <a:p>
+            <a:r>
+              <a:t>}</a:t>
+            </a:r>
+          </a:p>
+          <a:p/>
+          <a:p>
+            <a:r>
+              <a:t>proof_object:</a:t>
+            </a:r>
+          </a:p>
+          <a:p>
+            <a:r>
+              <a:t>{</a:t>
+            </a:r>
+          </a:p>
+          <a:p>
+            <a:r>
+              <a:t>  "type": "none",</a:t>
+            </a:r>
+          </a:p>
+          <a:p>
+            <a:r>
+              <a:t>  "required": false,</a:t>
+            </a:r>
+          </a:p>
+          <a:p>
+            <a:r>
+              <a:t>  "screen_position": "none",</a:t>
+            </a:r>
+          </a:p>
+          <a:p>
+            <a:r>
+              <a:t>  "display_label": "",</a:t>
+            </a:r>
+          </a:p>
+          <a:p>
+            <a:r>
+              <a:t>  "source_url": "https://www.bbc.com/news/articles/c2023l60370o?at_medium=RSS&amp;at_campaign=rss",</a:t>
+            </a:r>
+          </a:p>
+          <a:p>
+            <a:r>
+              <a:t>  "image_url": null,</a:t>
+            </a:r>
+          </a:p>
+          <a:p>
+            <a:r>
+              <a:t>  "copyright_risk": false,</a:t>
+            </a:r>
+          </a:p>
+          <a:p>
+            <a:r>
+              <a:t>  "manual_insert_required": false</a:t>
             </a:r>
           </a:p>
           <a:p>
@@ -6354,6 +7845,21 @@
           </a:p>
           <a:p>
             <a:r>
+              <a:t>proof_object_type: diagram</a:t>
+            </a:r>
+          </a:p>
+          <a:p>
+            <a:r>
+              <a:t>proof_object_required: True</a:t>
+            </a:r>
+          </a:p>
+          <a:p>
+            <a:r>
+              <a:t>proof_object_screen_position: left_half</a:t>
+            </a:r>
+          </a:p>
+          <a:p>
+            <a:r>
               <a:t>manual_placeholder_hidden: False</a:t>
             </a:r>
           </a:p>
@@ -6484,6 +7990,62 @@
           <a:p>
             <a:r>
               <a:t>  "prompt_if_ai_image": null</a:t>
+            </a:r>
+          </a:p>
+          <a:p>
+            <a:r>
+              <a:t>}</a:t>
+            </a:r>
+          </a:p>
+          <a:p/>
+          <a:p>
+            <a:r>
+              <a:t>proof_object:</a:t>
+            </a:r>
+          </a:p>
+          <a:p>
+            <a:r>
+              <a:t>{</a:t>
+            </a:r>
+          </a:p>
+          <a:p>
+            <a:r>
+              <a:t>  "type": "diagram",</a:t>
+            </a:r>
+          </a:p>
+          <a:p>
+            <a:r>
+              <a:t>  "required": true,</a:t>
+            </a:r>
+          </a:p>
+          <a:p>
+            <a:r>
+              <a:t>  "screen_position": "left_half",</a:t>
+            </a:r>
+          </a:p>
+          <a:p>
+            <a:r>
+              <a:t>  "display_label": "[도식]",</a:t>
+            </a:r>
+          </a:p>
+          <a:p>
+            <a:r>
+              <a:t>  "source_url": "https://www.unesco.org/en/articles/ai-competency-framework-students",</a:t>
+            </a:r>
+          </a:p>
+          <a:p>
+            <a:r>
+              <a:t>  "image_url": null,</a:t>
+            </a:r>
+          </a:p>
+          <a:p>
+            <a:r>
+              <a:t>  "copyright_risk": false,</a:t>
+            </a:r>
+          </a:p>
+          <a:p>
+            <a:r>
+              <a:t>  "manual_insert_required": true</a:t>
             </a:r>
           </a:p>
           <a:p>
@@ -6635,6 +8197,21 @@
           </a:p>
           <a:p>
             <a:r>
+              <a:t>proof_object_type: none</a:t>
+            </a:r>
+          </a:p>
+          <a:p>
+            <a:r>
+              <a:t>proof_object_required: False</a:t>
+            </a:r>
+          </a:p>
+          <a:p>
+            <a:r>
+              <a:t>proof_object_screen_position: none</a:t>
+            </a:r>
+          </a:p>
+          <a:p>
+            <a:r>
               <a:t>manual_placeholder_hidden: False</a:t>
             </a:r>
           </a:p>
@@ -6755,6 +8332,62 @@
           <a:p>
             <a:r>
               <a:t>  "prompt_if_ai_image": null</a:t>
+            </a:r>
+          </a:p>
+          <a:p>
+            <a:r>
+              <a:t>}</a:t>
+            </a:r>
+          </a:p>
+          <a:p/>
+          <a:p>
+            <a:r>
+              <a:t>proof_object:</a:t>
+            </a:r>
+          </a:p>
+          <a:p>
+            <a:r>
+              <a:t>{</a:t>
+            </a:r>
+          </a:p>
+          <a:p>
+            <a:r>
+              <a:t>  "type": "none",</a:t>
+            </a:r>
+          </a:p>
+          <a:p>
+            <a:r>
+              <a:t>  "required": false,</a:t>
+            </a:r>
+          </a:p>
+          <a:p>
+            <a:r>
+              <a:t>  "screen_position": "none",</a:t>
+            </a:r>
+          </a:p>
+          <a:p>
+            <a:r>
+              <a:t>  "display_label": "",</a:t>
+            </a:r>
+          </a:p>
+          <a:p>
+            <a:r>
+              <a:t>  "source_url": null,</a:t>
+            </a:r>
+          </a:p>
+          <a:p>
+            <a:r>
+              <a:t>  "image_url": null,</a:t>
+            </a:r>
+          </a:p>
+          <a:p>
+            <a:r>
+              <a:t>  "copyright_risk": false,</a:t>
+            </a:r>
+          </a:p>
+          <a:p>
+            <a:r>
+              <a:t>  "manual_insert_required": false</a:t>
             </a:r>
           </a:p>
           <a:p>
@@ -6891,6 +8524,21 @@
           </a:p>
           <a:p>
             <a:r>
+              <a:t>proof_object_type: none</a:t>
+            </a:r>
+          </a:p>
+          <a:p>
+            <a:r>
+              <a:t>proof_object_required: False</a:t>
+            </a:r>
+          </a:p>
+          <a:p>
+            <a:r>
+              <a:t>proof_object_screen_position: none</a:t>
+            </a:r>
+          </a:p>
+          <a:p>
+            <a:r>
               <a:t>manual_placeholder_hidden: False</a:t>
             </a:r>
           </a:p>
@@ -7001,6 +8649,62 @@
           <a:p>
             <a:r>
               <a:t>  "prompt_if_ai_image": null</a:t>
+            </a:r>
+          </a:p>
+          <a:p>
+            <a:r>
+              <a:t>}</a:t>
+            </a:r>
+          </a:p>
+          <a:p/>
+          <a:p>
+            <a:r>
+              <a:t>proof_object:</a:t>
+            </a:r>
+          </a:p>
+          <a:p>
+            <a:r>
+              <a:t>{</a:t>
+            </a:r>
+          </a:p>
+          <a:p>
+            <a:r>
+              <a:t>  "type": "none",</a:t>
+            </a:r>
+          </a:p>
+          <a:p>
+            <a:r>
+              <a:t>  "required": false,</a:t>
+            </a:r>
+          </a:p>
+          <a:p>
+            <a:r>
+              <a:t>  "screen_position": "none",</a:t>
+            </a:r>
+          </a:p>
+          <a:p>
+            <a:r>
+              <a:t>  "display_label": "",</a:t>
+            </a:r>
+          </a:p>
+          <a:p>
+            <a:r>
+              <a:t>  "source_url": null,</a:t>
+            </a:r>
+          </a:p>
+          <a:p>
+            <a:r>
+              <a:t>  "image_url": null,</a:t>
+            </a:r>
+          </a:p>
+          <a:p>
+            <a:r>
+              <a:t>  "copyright_risk": false,</a:t>
+            </a:r>
+          </a:p>
+          <a:p>
+            <a:r>
+              <a:t>  "manual_insert_required": false</a:t>
             </a:r>
           </a:p>
           <a:p>
@@ -7137,6 +8841,21 @@
           </a:p>
           <a:p>
             <a:r>
+              <a:t>proof_object_type: none</a:t>
+            </a:r>
+          </a:p>
+          <a:p>
+            <a:r>
+              <a:t>proof_object_required: False</a:t>
+            </a:r>
+          </a:p>
+          <a:p>
+            <a:r>
+              <a:t>proof_object_screen_position: none</a:t>
+            </a:r>
+          </a:p>
+          <a:p>
+            <a:r>
               <a:t>manual_placeholder_hidden: False</a:t>
             </a:r>
           </a:p>
@@ -7262,6 +8981,62 @@
           <a:p>
             <a:r>
               <a:t>  "prompt_if_ai_image": null</a:t>
+            </a:r>
+          </a:p>
+          <a:p>
+            <a:r>
+              <a:t>}</a:t>
+            </a:r>
+          </a:p>
+          <a:p/>
+          <a:p>
+            <a:r>
+              <a:t>proof_object:</a:t>
+            </a:r>
+          </a:p>
+          <a:p>
+            <a:r>
+              <a:t>{</a:t>
+            </a:r>
+          </a:p>
+          <a:p>
+            <a:r>
+              <a:t>  "type": "none",</a:t>
+            </a:r>
+          </a:p>
+          <a:p>
+            <a:r>
+              <a:t>  "required": false,</a:t>
+            </a:r>
+          </a:p>
+          <a:p>
+            <a:r>
+              <a:t>  "screen_position": "none",</a:t>
+            </a:r>
+          </a:p>
+          <a:p>
+            <a:r>
+              <a:t>  "display_label": "",</a:t>
+            </a:r>
+          </a:p>
+          <a:p>
+            <a:r>
+              <a:t>  "source_url": "https://www.microsoft.com/en-us/research/publication/from-searchable-to-non-searchable-generative-ai-and-information-diversity-in-online-information-seeking/",</a:t>
+            </a:r>
+          </a:p>
+          <a:p>
+            <a:r>
+              <a:t>  "image_url": null,</a:t>
+            </a:r>
+          </a:p>
+          <a:p>
+            <a:r>
+              <a:t>  "copyright_risk": false,</a:t>
+            </a:r>
+          </a:p>
+          <a:p>
+            <a:r>
+              <a:t>  "manual_insert_required": false</a:t>
             </a:r>
           </a:p>
           <a:p>
@@ -7408,6 +9183,21 @@
           </a:p>
           <a:p>
             <a:r>
+              <a:t>proof_object_type: diagram</a:t>
+            </a:r>
+          </a:p>
+          <a:p>
+            <a:r>
+              <a:t>proof_object_required: True</a:t>
+            </a:r>
+          </a:p>
+          <a:p>
+            <a:r>
+              <a:t>proof_object_screen_position: left_half</a:t>
+            </a:r>
+          </a:p>
+          <a:p>
+            <a:r>
               <a:t>manual_placeholder_hidden: False</a:t>
             </a:r>
           </a:p>
@@ -7538,6 +9328,62 @@
           <a:p>
             <a:r>
               <a:t>  "prompt_if_ai_image": null</a:t>
+            </a:r>
+          </a:p>
+          <a:p>
+            <a:r>
+              <a:t>}</a:t>
+            </a:r>
+          </a:p>
+          <a:p/>
+          <a:p>
+            <a:r>
+              <a:t>proof_object:</a:t>
+            </a:r>
+          </a:p>
+          <a:p>
+            <a:r>
+              <a:t>{</a:t>
+            </a:r>
+          </a:p>
+          <a:p>
+            <a:r>
+              <a:t>  "type": "diagram",</a:t>
+            </a:r>
+          </a:p>
+          <a:p>
+            <a:r>
+              <a:t>  "required": true,</a:t>
+            </a:r>
+          </a:p>
+          <a:p>
+            <a:r>
+              <a:t>  "screen_position": "left_half",</a:t>
+            </a:r>
+          </a:p>
+          <a:p>
+            <a:r>
+              <a:t>  "display_label": "[도식]",</a:t>
+            </a:r>
+          </a:p>
+          <a:p>
+            <a:r>
+              <a:t>  "source_url": "https://www.microsoft.com/en-us/research/publication/from-searchable-to-non-searchable-generative-ai-and-information-diversity-in-online-information-seeking/",</a:t>
+            </a:r>
+          </a:p>
+          <a:p>
+            <a:r>
+              <a:t>  "image_url": null,</a:t>
+            </a:r>
+          </a:p>
+          <a:p>
+            <a:r>
+              <a:t>  "copyright_risk": false,</a:t>
+            </a:r>
+          </a:p>
+          <a:p>
+            <a:r>
+              <a:t>  "manual_insert_required": true</a:t>
             </a:r>
           </a:p>
           <a:p>
@@ -10879,61 +12725,7 @@
       </p:sp>
       <p:sp>
         <p:nvSpPr>
-          <p:cNvPr id="4" name="Rectangle 3"/>
-          <p:cNvSpPr/>
-          <p:nvPr/>
-        </p:nvSpPr>
-        <p:spPr>
-          <a:xfrm>
-            <a:off x="7818120" y="1417320"/>
-            <a:ext cx="3703320" cy="4251960"/>
-          </a:xfrm>
-          <a:prstGeom prst="rect">
-            <a:avLst/>
-          </a:prstGeom>
-          <a:solidFill>
-            <a:srgbClr val="EBF1F4"/>
-          </a:solidFill>
-          <a:ln w="12700">
-            <a:solidFill>
-              <a:srgbClr val="A0AEB8"/>
-            </a:solidFill>
-          </a:ln>
-        </p:spPr>
-        <p:style>
-          <a:lnRef idx="1">
-            <a:schemeClr val="accent1"/>
-          </a:lnRef>
-          <a:fillRef idx="3">
-            <a:schemeClr val="accent1"/>
-          </a:fillRef>
-          <a:effectRef idx="2">
-            <a:schemeClr val="accent1"/>
-          </a:effectRef>
-          <a:fontRef idx="minor">
-            <a:schemeClr val="lt1"/>
-          </a:fontRef>
-        </p:style>
-        <p:txBody>
-          <a:bodyPr rtlCol="0" anchor="ctr" wrap="square"/>
-          <a:lstStyle/>
-          <a:p>
-            <a:pPr algn="ctr"/>
-            <a:r>
-              <a:rPr sz="1600">
-                <a:solidFill>
-                  <a:srgbClr val="566070"/>
-                </a:solidFill>
-                <a:latin typeface="Malgun Gothic"/>
-              </a:rPr>
-              <a:t>[수동 삽입]</a:t>
-            </a:r>
-          </a:p>
-        </p:txBody>
-      </p:sp>
-      <p:sp>
-        <p:nvSpPr>
-          <p:cNvPr id="5" name="TextBox 4"/>
+          <p:cNvPr id="4" name="TextBox 3"/>
           <p:cNvSpPr txBox="1"/>
           <p:nvPr/>
         </p:nvSpPr>
@@ -10967,7 +12759,7 @@
       </p:sp>
       <p:sp>
         <p:nvSpPr>
-          <p:cNvPr id="6" name="TextBox 5"/>
+          <p:cNvPr id="5" name="TextBox 4"/>
           <p:cNvSpPr txBox="1"/>
           <p:nvPr/>
         </p:nvSpPr>
@@ -11378,61 +13170,7 @@
       </p:sp>
       <p:sp>
         <p:nvSpPr>
-          <p:cNvPr id="4" name="Rectangle 3"/>
-          <p:cNvSpPr/>
-          <p:nvPr/>
-        </p:nvSpPr>
-        <p:spPr>
-          <a:xfrm>
-            <a:off x="8458200" y="4389120"/>
-            <a:ext cx="2560320" cy="1097280"/>
-          </a:xfrm>
-          <a:prstGeom prst="rect">
-            <a:avLst/>
-          </a:prstGeom>
-          <a:solidFill>
-            <a:srgbClr val="EBF1F4"/>
-          </a:solidFill>
-          <a:ln w="12700">
-            <a:solidFill>
-              <a:srgbClr val="A0AEB8"/>
-            </a:solidFill>
-          </a:ln>
-        </p:spPr>
-        <p:style>
-          <a:lnRef idx="1">
-            <a:schemeClr val="accent1"/>
-          </a:lnRef>
-          <a:fillRef idx="3">
-            <a:schemeClr val="accent1"/>
-          </a:fillRef>
-          <a:effectRef idx="2">
-            <a:schemeClr val="accent1"/>
-          </a:effectRef>
-          <a:fontRef idx="minor">
-            <a:schemeClr val="lt1"/>
-          </a:fontRef>
-        </p:style>
-        <p:txBody>
-          <a:bodyPr rtlCol="0" anchor="ctr" wrap="square"/>
-          <a:lstStyle/>
-          <a:p>
-            <a:pPr algn="ctr"/>
-            <a:r>
-              <a:rPr sz="1600">
-                <a:solidFill>
-                  <a:srgbClr val="566070"/>
-                </a:solidFill>
-                <a:latin typeface="Malgun Gothic"/>
-              </a:rPr>
-              <a:t>[수동 삽입]</a:t>
-            </a:r>
-          </a:p>
-        </p:txBody>
-      </p:sp>
-      <p:sp>
-        <p:nvSpPr>
-          <p:cNvPr id="5" name="TextBox 4"/>
+          <p:cNvPr id="4" name="TextBox 3"/>
           <p:cNvSpPr txBox="1"/>
           <p:nvPr/>
         </p:nvSpPr>
@@ -11466,7 +13204,7 @@
       </p:sp>
       <p:sp>
         <p:nvSpPr>
-          <p:cNvPr id="6" name="TextBox 5"/>
+          <p:cNvPr id="5" name="TextBox 4"/>
           <p:cNvSpPr txBox="1"/>
           <p:nvPr/>
         </p:nvSpPr>
@@ -11843,61 +13581,7 @@
       </p:sp>
       <p:sp>
         <p:nvSpPr>
-          <p:cNvPr id="4" name="Rectangle 3"/>
-          <p:cNvSpPr/>
-          <p:nvPr/>
-        </p:nvSpPr>
-        <p:spPr>
-          <a:xfrm>
-            <a:off x="7818120" y="1417320"/>
-            <a:ext cx="3703320" cy="4251960"/>
-          </a:xfrm>
-          <a:prstGeom prst="rect">
-            <a:avLst/>
-          </a:prstGeom>
-          <a:solidFill>
-            <a:srgbClr val="EBF1F4"/>
-          </a:solidFill>
-          <a:ln w="12700">
-            <a:solidFill>
-              <a:srgbClr val="A0AEB8"/>
-            </a:solidFill>
-          </a:ln>
-        </p:spPr>
-        <p:style>
-          <a:lnRef idx="1">
-            <a:schemeClr val="accent1"/>
-          </a:lnRef>
-          <a:fillRef idx="3">
-            <a:schemeClr val="accent1"/>
-          </a:fillRef>
-          <a:effectRef idx="2">
-            <a:schemeClr val="accent1"/>
-          </a:effectRef>
-          <a:fontRef idx="minor">
-            <a:schemeClr val="lt1"/>
-          </a:fontRef>
-        </p:style>
-        <p:txBody>
-          <a:bodyPr rtlCol="0" anchor="ctr" wrap="square"/>
-          <a:lstStyle/>
-          <a:p>
-            <a:pPr algn="ctr"/>
-            <a:r>
-              <a:rPr sz="1600">
-                <a:solidFill>
-                  <a:srgbClr val="566070"/>
-                </a:solidFill>
-                <a:latin typeface="Malgun Gothic"/>
-              </a:rPr>
-              <a:t>[수동 삽입]</a:t>
-            </a:r>
-          </a:p>
-        </p:txBody>
-      </p:sp>
-      <p:sp>
-        <p:nvSpPr>
-          <p:cNvPr id="5" name="TextBox 4"/>
+          <p:cNvPr id="4" name="TextBox 3"/>
           <p:cNvSpPr txBox="1"/>
           <p:nvPr/>
         </p:nvSpPr>
@@ -11931,7 +13615,7 @@
       </p:sp>
       <p:sp>
         <p:nvSpPr>
-          <p:cNvPr id="6" name="TextBox 5"/>
+          <p:cNvPr id="5" name="TextBox 4"/>
           <p:cNvSpPr txBox="1"/>
           <p:nvPr/>
         </p:nvSpPr>
@@ -12097,61 +13781,7 @@
       </p:sp>
       <p:sp>
         <p:nvSpPr>
-          <p:cNvPr id="4" name="Rectangle 3"/>
-          <p:cNvSpPr/>
-          <p:nvPr/>
-        </p:nvSpPr>
-        <p:spPr>
-          <a:xfrm>
-            <a:off x="7818120" y="1417320"/>
-            <a:ext cx="3703320" cy="4251960"/>
-          </a:xfrm>
-          <a:prstGeom prst="rect">
-            <a:avLst/>
-          </a:prstGeom>
-          <a:solidFill>
-            <a:srgbClr val="EBF1F4"/>
-          </a:solidFill>
-          <a:ln w="12700">
-            <a:solidFill>
-              <a:srgbClr val="A0AEB8"/>
-            </a:solidFill>
-          </a:ln>
-        </p:spPr>
-        <p:style>
-          <a:lnRef idx="1">
-            <a:schemeClr val="accent1"/>
-          </a:lnRef>
-          <a:fillRef idx="3">
-            <a:schemeClr val="accent1"/>
-          </a:fillRef>
-          <a:effectRef idx="2">
-            <a:schemeClr val="accent1"/>
-          </a:effectRef>
-          <a:fontRef idx="minor">
-            <a:schemeClr val="lt1"/>
-          </a:fontRef>
-        </p:style>
-        <p:txBody>
-          <a:bodyPr rtlCol="0" anchor="ctr" wrap="square"/>
-          <a:lstStyle/>
-          <a:p>
-            <a:pPr algn="ctr"/>
-            <a:r>
-              <a:rPr sz="1600">
-                <a:solidFill>
-                  <a:srgbClr val="566070"/>
-                </a:solidFill>
-                <a:latin typeface="Malgun Gothic"/>
-              </a:rPr>
-              <a:t>[수동 삽입]</a:t>
-            </a:r>
-          </a:p>
-        </p:txBody>
-      </p:sp>
-      <p:sp>
-        <p:nvSpPr>
-          <p:cNvPr id="5" name="TextBox 4"/>
+          <p:cNvPr id="4" name="TextBox 3"/>
           <p:cNvSpPr txBox="1"/>
           <p:nvPr/>
         </p:nvSpPr>
@@ -12185,7 +13815,7 @@
       </p:sp>
       <p:sp>
         <p:nvSpPr>
-          <p:cNvPr id="6" name="TextBox 5"/>
+          <p:cNvPr id="5" name="TextBox 4"/>
           <p:cNvSpPr txBox="1"/>
           <p:nvPr/>
         </p:nvSpPr>
@@ -12351,61 +13981,7 @@
       </p:sp>
       <p:sp>
         <p:nvSpPr>
-          <p:cNvPr id="4" name="Rectangle 3"/>
-          <p:cNvSpPr/>
-          <p:nvPr/>
-        </p:nvSpPr>
-        <p:spPr>
-          <a:xfrm>
-            <a:off x="7818120" y="1417320"/>
-            <a:ext cx="3703320" cy="4251960"/>
-          </a:xfrm>
-          <a:prstGeom prst="rect">
-            <a:avLst/>
-          </a:prstGeom>
-          <a:solidFill>
-            <a:srgbClr val="EBF1F4"/>
-          </a:solidFill>
-          <a:ln w="12700">
-            <a:solidFill>
-              <a:srgbClr val="A0AEB8"/>
-            </a:solidFill>
-          </a:ln>
-        </p:spPr>
-        <p:style>
-          <a:lnRef idx="1">
-            <a:schemeClr val="accent1"/>
-          </a:lnRef>
-          <a:fillRef idx="3">
-            <a:schemeClr val="accent1"/>
-          </a:fillRef>
-          <a:effectRef idx="2">
-            <a:schemeClr val="accent1"/>
-          </a:effectRef>
-          <a:fontRef idx="minor">
-            <a:schemeClr val="lt1"/>
-          </a:fontRef>
-        </p:style>
-        <p:txBody>
-          <a:bodyPr rtlCol="0" anchor="ctr" wrap="square"/>
-          <a:lstStyle/>
-          <a:p>
-            <a:pPr algn="ctr"/>
-            <a:r>
-              <a:rPr sz="1600">
-                <a:solidFill>
-                  <a:srgbClr val="566070"/>
-                </a:solidFill>
-                <a:latin typeface="Malgun Gothic"/>
-              </a:rPr>
-              <a:t>[수동 삽입]</a:t>
-            </a:r>
-          </a:p>
-        </p:txBody>
-      </p:sp>
-      <p:sp>
-        <p:nvSpPr>
-          <p:cNvPr id="5" name="TextBox 4"/>
+          <p:cNvPr id="4" name="TextBox 3"/>
           <p:cNvSpPr txBox="1"/>
           <p:nvPr/>
         </p:nvSpPr>
@@ -12439,7 +14015,7 @@
       </p:sp>
       <p:sp>
         <p:nvSpPr>
-          <p:cNvPr id="6" name="TextBox 5"/>
+          <p:cNvPr id="5" name="TextBox 4"/>
           <p:cNvSpPr txBox="1"/>
           <p:nvPr/>
         </p:nvSpPr>
@@ -12581,7 +14157,7 @@
                 </a:solidFill>
                 <a:latin typeface="Malgun Gothic"/>
               </a:rPr>
-              <a:t>[차트 후보]</a:t>
+              <a:t>[차트]</a:t>
             </a:r>
           </a:p>
         </p:txBody>
@@ -13259,61 +14835,7 @@
       </p:sp>
       <p:sp>
         <p:nvSpPr>
-          <p:cNvPr id="4" name="Rectangle 3"/>
-          <p:cNvSpPr/>
-          <p:nvPr/>
-        </p:nvSpPr>
-        <p:spPr>
-          <a:xfrm>
-            <a:off x="8458200" y="4389120"/>
-            <a:ext cx="2560320" cy="1097280"/>
-          </a:xfrm>
-          <a:prstGeom prst="rect">
-            <a:avLst/>
-          </a:prstGeom>
-          <a:solidFill>
-            <a:srgbClr val="EBF1F4"/>
-          </a:solidFill>
-          <a:ln w="12700">
-            <a:solidFill>
-              <a:srgbClr val="A0AEB8"/>
-            </a:solidFill>
-          </a:ln>
-        </p:spPr>
-        <p:style>
-          <a:lnRef idx="1">
-            <a:schemeClr val="accent1"/>
-          </a:lnRef>
-          <a:fillRef idx="3">
-            <a:schemeClr val="accent1"/>
-          </a:fillRef>
-          <a:effectRef idx="2">
-            <a:schemeClr val="accent1"/>
-          </a:effectRef>
-          <a:fontRef idx="minor">
-            <a:schemeClr val="lt1"/>
-          </a:fontRef>
-        </p:style>
-        <p:txBody>
-          <a:bodyPr rtlCol="0" anchor="ctr" wrap="square"/>
-          <a:lstStyle/>
-          <a:p>
-            <a:pPr algn="ctr"/>
-            <a:r>
-              <a:rPr sz="1600">
-                <a:solidFill>
-                  <a:srgbClr val="566070"/>
-                </a:solidFill>
-                <a:latin typeface="Malgun Gothic"/>
-              </a:rPr>
-              <a:t>[수동 삽입]</a:t>
-            </a:r>
-          </a:p>
-        </p:txBody>
-      </p:sp>
-      <p:sp>
-        <p:nvSpPr>
-          <p:cNvPr id="5" name="TextBox 4"/>
+          <p:cNvPr id="4" name="TextBox 3"/>
           <p:cNvSpPr txBox="1"/>
           <p:nvPr/>
         </p:nvSpPr>
@@ -13347,7 +14869,7 @@
       </p:sp>
       <p:sp>
         <p:nvSpPr>
-          <p:cNvPr id="6" name="TextBox 5"/>
+          <p:cNvPr id="5" name="TextBox 4"/>
           <p:cNvSpPr txBox="1"/>
           <p:nvPr/>
         </p:nvSpPr>
@@ -14037,61 +15559,7 @@
       </p:sp>
       <p:sp>
         <p:nvSpPr>
-          <p:cNvPr id="4" name="Rectangle 3"/>
-          <p:cNvSpPr/>
-          <p:nvPr/>
-        </p:nvSpPr>
-        <p:spPr>
-          <a:xfrm>
-            <a:off x="7818120" y="1417320"/>
-            <a:ext cx="3703320" cy="4251960"/>
-          </a:xfrm>
-          <a:prstGeom prst="rect">
-            <a:avLst/>
-          </a:prstGeom>
-          <a:solidFill>
-            <a:srgbClr val="EBF1F4"/>
-          </a:solidFill>
-          <a:ln w="12700">
-            <a:solidFill>
-              <a:srgbClr val="A0AEB8"/>
-            </a:solidFill>
-          </a:ln>
-        </p:spPr>
-        <p:style>
-          <a:lnRef idx="1">
-            <a:schemeClr val="accent1"/>
-          </a:lnRef>
-          <a:fillRef idx="3">
-            <a:schemeClr val="accent1"/>
-          </a:fillRef>
-          <a:effectRef idx="2">
-            <a:schemeClr val="accent1"/>
-          </a:effectRef>
-          <a:fontRef idx="minor">
-            <a:schemeClr val="lt1"/>
-          </a:fontRef>
-        </p:style>
-        <p:txBody>
-          <a:bodyPr rtlCol="0" anchor="ctr" wrap="square"/>
-          <a:lstStyle/>
-          <a:p>
-            <a:pPr algn="ctr"/>
-            <a:r>
-              <a:rPr sz="1600">
-                <a:solidFill>
-                  <a:srgbClr val="566070"/>
-                </a:solidFill>
-                <a:latin typeface="Malgun Gothic"/>
-              </a:rPr>
-              <a:t>[수동 삽입]</a:t>
-            </a:r>
-          </a:p>
-        </p:txBody>
-      </p:sp>
-      <p:sp>
-        <p:nvSpPr>
-          <p:cNvPr id="5" name="TextBox 4"/>
+          <p:cNvPr id="4" name="TextBox 3"/>
           <p:cNvSpPr txBox="1"/>
           <p:nvPr/>
         </p:nvSpPr>
@@ -14125,7 +15593,7 @@
       </p:sp>
       <p:sp>
         <p:nvSpPr>
-          <p:cNvPr id="6" name="TextBox 5"/>
+          <p:cNvPr id="5" name="TextBox 4"/>
           <p:cNvSpPr txBox="1"/>
           <p:nvPr/>
         </p:nvSpPr>
@@ -14875,61 +16343,7 @@
       </p:sp>
       <p:sp>
         <p:nvSpPr>
-          <p:cNvPr id="4" name="Rectangle 3"/>
-          <p:cNvSpPr/>
-          <p:nvPr/>
-        </p:nvSpPr>
-        <p:spPr>
-          <a:xfrm>
-            <a:off x="8458200" y="4389120"/>
-            <a:ext cx="2560320" cy="1097280"/>
-          </a:xfrm>
-          <a:prstGeom prst="rect">
-            <a:avLst/>
-          </a:prstGeom>
-          <a:solidFill>
-            <a:srgbClr val="EBF1F4"/>
-          </a:solidFill>
-          <a:ln w="12700">
-            <a:solidFill>
-              <a:srgbClr val="A0AEB8"/>
-            </a:solidFill>
-          </a:ln>
-        </p:spPr>
-        <p:style>
-          <a:lnRef idx="1">
-            <a:schemeClr val="accent1"/>
-          </a:lnRef>
-          <a:fillRef idx="3">
-            <a:schemeClr val="accent1"/>
-          </a:fillRef>
-          <a:effectRef idx="2">
-            <a:schemeClr val="accent1"/>
-          </a:effectRef>
-          <a:fontRef idx="minor">
-            <a:schemeClr val="lt1"/>
-          </a:fontRef>
-        </p:style>
-        <p:txBody>
-          <a:bodyPr rtlCol="0" anchor="ctr" wrap="square"/>
-          <a:lstStyle/>
-          <a:p>
-            <a:pPr algn="ctr"/>
-            <a:r>
-              <a:rPr sz="1600">
-                <a:solidFill>
-                  <a:srgbClr val="566070"/>
-                </a:solidFill>
-                <a:latin typeface="Malgun Gothic"/>
-              </a:rPr>
-              <a:t>[수동 삽입]</a:t>
-            </a:r>
-          </a:p>
-        </p:txBody>
-      </p:sp>
-      <p:sp>
-        <p:nvSpPr>
-          <p:cNvPr id="5" name="TextBox 4"/>
+          <p:cNvPr id="4" name="TextBox 3"/>
           <p:cNvSpPr txBox="1"/>
           <p:nvPr/>
         </p:nvSpPr>
@@ -14963,7 +16377,7 @@
       </p:sp>
       <p:sp>
         <p:nvSpPr>
-          <p:cNvPr id="6" name="TextBox 5"/>
+          <p:cNvPr id="5" name="TextBox 4"/>
           <p:cNvSpPr txBox="1"/>
           <p:nvPr/>
         </p:nvSpPr>
@@ -15374,61 +16788,7 @@
       </p:sp>
       <p:sp>
         <p:nvSpPr>
-          <p:cNvPr id="4" name="Rectangle 3"/>
-          <p:cNvSpPr/>
-          <p:nvPr/>
-        </p:nvSpPr>
-        <p:spPr>
-          <a:xfrm>
-            <a:off x="7818120" y="1417320"/>
-            <a:ext cx="3703320" cy="4251960"/>
-          </a:xfrm>
-          <a:prstGeom prst="rect">
-            <a:avLst/>
-          </a:prstGeom>
-          <a:solidFill>
-            <a:srgbClr val="EBF1F4"/>
-          </a:solidFill>
-          <a:ln w="12700">
-            <a:solidFill>
-              <a:srgbClr val="A0AEB8"/>
-            </a:solidFill>
-          </a:ln>
-        </p:spPr>
-        <p:style>
-          <a:lnRef idx="1">
-            <a:schemeClr val="accent1"/>
-          </a:lnRef>
-          <a:fillRef idx="3">
-            <a:schemeClr val="accent1"/>
-          </a:fillRef>
-          <a:effectRef idx="2">
-            <a:schemeClr val="accent1"/>
-          </a:effectRef>
-          <a:fontRef idx="minor">
-            <a:schemeClr val="lt1"/>
-          </a:fontRef>
-        </p:style>
-        <p:txBody>
-          <a:bodyPr rtlCol="0" anchor="ctr" wrap="square"/>
-          <a:lstStyle/>
-          <a:p>
-            <a:pPr algn="ctr"/>
-            <a:r>
-              <a:rPr sz="1600">
-                <a:solidFill>
-                  <a:srgbClr val="566070"/>
-                </a:solidFill>
-                <a:latin typeface="Malgun Gothic"/>
-              </a:rPr>
-              <a:t>[수동 삽입]</a:t>
-            </a:r>
-          </a:p>
-        </p:txBody>
-      </p:sp>
-      <p:sp>
-        <p:nvSpPr>
-          <p:cNvPr id="5" name="TextBox 4"/>
+          <p:cNvPr id="4" name="TextBox 3"/>
           <p:cNvSpPr txBox="1"/>
           <p:nvPr/>
         </p:nvSpPr>
@@ -15462,7 +16822,7 @@
       </p:sp>
       <p:sp>
         <p:nvSpPr>
-          <p:cNvPr id="6" name="TextBox 5"/>
+          <p:cNvPr id="5" name="TextBox 4"/>
           <p:cNvSpPr txBox="1"/>
           <p:nvPr/>
         </p:nvSpPr>
@@ -16239,61 +17599,7 @@
       </p:sp>
       <p:sp>
         <p:nvSpPr>
-          <p:cNvPr id="4" name="Rectangle 3"/>
-          <p:cNvSpPr/>
-          <p:nvPr/>
-        </p:nvSpPr>
-        <p:spPr>
-          <a:xfrm>
-            <a:off x="7818120" y="1417320"/>
-            <a:ext cx="3703320" cy="4251960"/>
-          </a:xfrm>
-          <a:prstGeom prst="rect">
-            <a:avLst/>
-          </a:prstGeom>
-          <a:solidFill>
-            <a:srgbClr val="EBF1F4"/>
-          </a:solidFill>
-          <a:ln w="12700">
-            <a:solidFill>
-              <a:srgbClr val="A0AEB8"/>
-            </a:solidFill>
-          </a:ln>
-        </p:spPr>
-        <p:style>
-          <a:lnRef idx="1">
-            <a:schemeClr val="accent1"/>
-          </a:lnRef>
-          <a:fillRef idx="3">
-            <a:schemeClr val="accent1"/>
-          </a:fillRef>
-          <a:effectRef idx="2">
-            <a:schemeClr val="accent1"/>
-          </a:effectRef>
-          <a:fontRef idx="minor">
-            <a:schemeClr val="lt1"/>
-          </a:fontRef>
-        </p:style>
-        <p:txBody>
-          <a:bodyPr rtlCol="0" anchor="ctr" wrap="square"/>
-          <a:lstStyle/>
-          <a:p>
-            <a:pPr algn="ctr"/>
-            <a:r>
-              <a:rPr sz="1600">
-                <a:solidFill>
-                  <a:srgbClr val="566070"/>
-                </a:solidFill>
-                <a:latin typeface="Malgun Gothic"/>
-              </a:rPr>
-              <a:t>[수동 삽입]</a:t>
-            </a:r>
-          </a:p>
-        </p:txBody>
-      </p:sp>
-      <p:sp>
-        <p:nvSpPr>
-          <p:cNvPr id="5" name="TextBox 4"/>
+          <p:cNvPr id="4" name="TextBox 3"/>
           <p:cNvSpPr txBox="1"/>
           <p:nvPr/>
         </p:nvSpPr>
@@ -16327,7 +17633,7 @@
       </p:sp>
       <p:sp>
         <p:nvSpPr>
-          <p:cNvPr id="6" name="TextBox 5"/>
+          <p:cNvPr id="5" name="TextBox 4"/>
           <p:cNvSpPr txBox="1"/>
           <p:nvPr/>
         </p:nvSpPr>

</xml_diff>

<commit_message>
Add Piti reference layout templates
</commit_message>
<xml_diff>
--- a/outputs/pptx/ai_knowledge_institution_draft.pptx
+++ b/outputs/pptx/ai_knowledge_institution_draft.pptx
@@ -894,17 +894,17 @@
           </a:p>
           <a:p>
             <a:r>
-              <a:t>proof_object_type: none</a:t>
-            </a:r>
-          </a:p>
-          <a:p>
-            <a:r>
-              <a:t>proof_object_required: False</a:t>
-            </a:r>
-          </a:p>
-          <a:p>
-            <a:r>
-              <a:t>proof_object_screen_position: none</a:t>
+              <a:t>proof_object_type: article_quote</a:t>
+            </a:r>
+          </a:p>
+          <a:p>
+            <a:r>
+              <a:t>proof_object_required: True</a:t>
+            </a:r>
+          </a:p>
+          <a:p>
+            <a:r>
+              <a:t>proof_object_screen_position: left_half</a:t>
             </a:r>
           </a:p>
           <a:p>
@@ -930,7 +930,22 @@
           </a:p>
           <a:p>
             <a:r>
-              <a:t>  "AI 역량 교육은 답을 받는 법보다 질문하고 평가하고 책임 있게 쓰는 법으로 확장될 필요가 있다",</a:t>
+              <a:t>  "AI 역량 교육은 답을 받는 법보다 질문하고 평가하고 책임 있게 쓰는 법으로 확장될 필요가 있다"</a:t>
+            </a:r>
+          </a:p>
+          <a:p>
+            <a:r>
+              <a:t>]</a:t>
+            </a:r>
+          </a:p>
+          <a:p>
+            <a:r>
+              <a:t>overflow_body_lines:</a:t>
+            </a:r>
+          </a:p>
+          <a:p>
+            <a:r>
+              <a:t>[</a:t>
             </a:r>
           </a:p>
           <a:p>
@@ -943,16 +958,6 @@
               <a:t>]</a:t>
             </a:r>
           </a:p>
-          <a:p>
-            <a:r>
-              <a:t>overflow_body_lines:</a:t>
-            </a:r>
-          </a:p>
-          <a:p>
-            <a:r>
-              <a:t>[]</a:t>
-            </a:r>
-          </a:p>
           <a:p/>
           <a:p>
             <a:r>
@@ -1059,22 +1064,22 @@
           </a:p>
           <a:p>
             <a:r>
-              <a:t>  "type": "none",</a:t>
-            </a:r>
-          </a:p>
-          <a:p>
-            <a:r>
-              <a:t>  "required": false,</a:t>
-            </a:r>
-          </a:p>
-          <a:p>
-            <a:r>
-              <a:t>  "screen_position": "none",</a:t>
-            </a:r>
-          </a:p>
-          <a:p>
-            <a:r>
-              <a:t>  "display_label": "",</a:t>
+              <a:t>  "type": "article_quote",</a:t>
+            </a:r>
+          </a:p>
+          <a:p>
+            <a:r>
+              <a:t>  "required": true,</a:t>
+            </a:r>
+          </a:p>
+          <a:p>
+            <a:r>
+              <a:t>  "screen_position": "left_half",</a:t>
+            </a:r>
+          </a:p>
+          <a:p>
+            <a:r>
+              <a:t>  "display_label": "[기사 인용]",</a:t>
             </a:r>
           </a:p>
           <a:p>
@@ -1094,7 +1099,7 @@
           </a:p>
           <a:p>
             <a:r>
-              <a:t>  "manual_insert_required": false</a:t>
+              <a:t>  "manual_insert_required": true</a:t>
             </a:r>
           </a:p>
           <a:p>
@@ -2232,17 +2237,17 @@
           </a:p>
           <a:p>
             <a:r>
-              <a:t>proof_object_type: none</a:t>
-            </a:r>
-          </a:p>
-          <a:p>
-            <a:r>
-              <a:t>proof_object_required: False</a:t>
-            </a:r>
-          </a:p>
-          <a:p>
-            <a:r>
-              <a:t>proof_object_screen_position: none</a:t>
+              <a:t>proof_object_type: article_quote</a:t>
+            </a:r>
+          </a:p>
+          <a:p>
+            <a:r>
+              <a:t>proof_object_required: True</a:t>
+            </a:r>
+          </a:p>
+          <a:p>
+            <a:r>
+              <a:t>proof_object_screen_position: left_half</a:t>
             </a:r>
           </a:p>
           <a:p>
@@ -2268,7 +2273,22 @@
           </a:p>
           <a:p>
             <a:r>
-              <a:t>  "OECD와 UNESCO 자료는 AI 교육을 교수 원칙과 학생 역량의 문제로 다룬다",</a:t>
+              <a:t>  "OECD와 UNESCO 자료는 AI 교육을 교수 원칙과 학생 역량의 문제로 다룬다"</a:t>
+            </a:r>
+          </a:p>
+          <a:p>
+            <a:r>
+              <a:t>]</a:t>
+            </a:r>
+          </a:p>
+          <a:p>
+            <a:r>
+              <a:t>overflow_body_lines:</a:t>
+            </a:r>
+          </a:p>
+          <a:p>
+            <a:r>
+              <a:t>[</a:t>
             </a:r>
           </a:p>
           <a:p>
@@ -2281,16 +2301,6 @@
               <a:t>]</a:t>
             </a:r>
           </a:p>
-          <a:p>
-            <a:r>
-              <a:t>overflow_body_lines:</a:t>
-            </a:r>
-          </a:p>
-          <a:p>
-            <a:r>
-              <a:t>[]</a:t>
-            </a:r>
-          </a:p>
           <a:p/>
           <a:p>
             <a:r>
@@ -2397,22 +2407,22 @@
           </a:p>
           <a:p>
             <a:r>
-              <a:t>  "type": "none",</a:t>
-            </a:r>
-          </a:p>
-          <a:p>
-            <a:r>
-              <a:t>  "required": false,</a:t>
-            </a:r>
-          </a:p>
-          <a:p>
-            <a:r>
-              <a:t>  "screen_position": "none",</a:t>
-            </a:r>
-          </a:p>
-          <a:p>
-            <a:r>
-              <a:t>  "display_label": "",</a:t>
+              <a:t>  "type": "article_quote",</a:t>
+            </a:r>
+          </a:p>
+          <a:p>
+            <a:r>
+              <a:t>  "required": true,</a:t>
+            </a:r>
+          </a:p>
+          <a:p>
+            <a:r>
+              <a:t>  "screen_position": "left_half",</a:t>
+            </a:r>
+          </a:p>
+          <a:p>
+            <a:r>
+              <a:t>  "display_label": "[기사 인용]",</a:t>
             </a:r>
           </a:p>
           <a:p>
@@ -2432,7 +2442,7 @@
           </a:p>
           <a:p>
             <a:r>
-              <a:t>  "manual_insert_required": false</a:t>
+              <a:t>  "manual_insert_required": true</a:t>
             </a:r>
           </a:p>
           <a:p>
@@ -2584,17 +2594,17 @@
           </a:p>
           <a:p>
             <a:r>
-              <a:t>proof_object_type: none</a:t>
-            </a:r>
-          </a:p>
-          <a:p>
-            <a:r>
-              <a:t>proof_object_required: False</a:t>
-            </a:r>
-          </a:p>
-          <a:p>
-            <a:r>
-              <a:t>proof_object_screen_position: none</a:t>
+              <a:t>proof_object_type: article_quote</a:t>
+            </a:r>
+          </a:p>
+          <a:p>
+            <a:r>
+              <a:t>proof_object_required: True</a:t>
+            </a:r>
+          </a:p>
+          <a:p>
+            <a:r>
+              <a:t>proof_object_screen_position: left_half</a:t>
             </a:r>
           </a:p>
           <a:p>
@@ -2620,7 +2630,22 @@
           </a:p>
           <a:p>
             <a:r>
-              <a:t>  "그렇다면 박물관·과학관은 맥락, 경험, 질문, 토론을 더 강조해야 할 수 있다",</a:t>
+              <a:t>  "그렇다면 박물관·과학관은 맥락, 경험, 질문, 토론을 더 강조해야 할 수 있다"</a:t>
+            </a:r>
+          </a:p>
+          <a:p>
+            <a:r>
+              <a:t>]</a:t>
+            </a:r>
+          </a:p>
+          <a:p>
+            <a:r>
+              <a:t>overflow_body_lines:</a:t>
+            </a:r>
+          </a:p>
+          <a:p>
+            <a:r>
+              <a:t>[</a:t>
             </a:r>
           </a:p>
           <a:p>
@@ -2633,16 +2658,6 @@
               <a:t>]</a:t>
             </a:r>
           </a:p>
-          <a:p>
-            <a:r>
-              <a:t>overflow_body_lines:</a:t>
-            </a:r>
-          </a:p>
-          <a:p>
-            <a:r>
-              <a:t>[]</a:t>
-            </a:r>
-          </a:p>
           <a:p/>
           <a:p>
             <a:r>
@@ -2749,22 +2764,22 @@
           </a:p>
           <a:p>
             <a:r>
-              <a:t>  "type": "none",</a:t>
-            </a:r>
-          </a:p>
-          <a:p>
-            <a:r>
-              <a:t>  "required": false,</a:t>
-            </a:r>
-          </a:p>
-          <a:p>
-            <a:r>
-              <a:t>  "screen_position": "none",</a:t>
-            </a:r>
-          </a:p>
-          <a:p>
-            <a:r>
-              <a:t>  "display_label": "",</a:t>
+              <a:t>  "type": "article_quote",</a:t>
+            </a:r>
+          </a:p>
+          <a:p>
+            <a:r>
+              <a:t>  "required": true,</a:t>
+            </a:r>
+          </a:p>
+          <a:p>
+            <a:r>
+              <a:t>  "screen_position": "left_half",</a:t>
+            </a:r>
+          </a:p>
+          <a:p>
+            <a:r>
+              <a:t>  "display_label": "[기사 인용]",</a:t>
             </a:r>
           </a:p>
           <a:p>
@@ -2784,7 +2799,7 @@
           </a:p>
           <a:p>
             <a:r>
-              <a:t>  "manual_insert_required": false</a:t>
+              <a:t>  "manual_insert_required": true</a:t>
             </a:r>
           </a:p>
           <a:p>
@@ -2942,17 +2957,17 @@
           </a:p>
           <a:p>
             <a:r>
-              <a:t>proof_object_type: none</a:t>
-            </a:r>
-          </a:p>
-          <a:p>
-            <a:r>
-              <a:t>proof_object_required: False</a:t>
-            </a:r>
-          </a:p>
-          <a:p>
-            <a:r>
-              <a:t>proof_object_screen_position: none</a:t>
+              <a:t>proof_object_type: article_quote</a:t>
+            </a:r>
+          </a:p>
+          <a:p>
+            <a:r>
+              <a:t>proof_object_required: True</a:t>
+            </a:r>
+          </a:p>
+          <a:p>
+            <a:r>
+              <a:t>proof_object_screen_position: left_half</a:t>
             </a:r>
           </a:p>
           <a:p>
@@ -2978,7 +2993,22 @@
           </a:p>
           <a:p>
             <a:r>
-              <a:t>  "하지만 밤하늘을 관찰하고, 위치를 추정하고, 계절과 시간을 연결하는 경험은 다르다",</a:t>
+              <a:t>  "하지만 밤하늘을 관찰하고, 위치를 추정하고, 계절과 시간을 연결하는 경험은 다르다"</a:t>
+            </a:r>
+          </a:p>
+          <a:p>
+            <a:r>
+              <a:t>]</a:t>
+            </a:r>
+          </a:p>
+          <a:p>
+            <a:r>
+              <a:t>overflow_body_lines:</a:t>
+            </a:r>
+          </a:p>
+          <a:p>
+            <a:r>
+              <a:t>[</a:t>
             </a:r>
           </a:p>
           <a:p>
@@ -2991,16 +3021,6 @@
               <a:t>]</a:t>
             </a:r>
           </a:p>
-          <a:p>
-            <a:r>
-              <a:t>overflow_body_lines:</a:t>
-            </a:r>
-          </a:p>
-          <a:p>
-            <a:r>
-              <a:t>[]</a:t>
-            </a:r>
-          </a:p>
           <a:p/>
           <a:p>
             <a:r>
@@ -3107,22 +3127,22 @@
           </a:p>
           <a:p>
             <a:r>
-              <a:t>  "type": "none",</a:t>
-            </a:r>
-          </a:p>
-          <a:p>
-            <a:r>
-              <a:t>  "required": false,</a:t>
-            </a:r>
-          </a:p>
-          <a:p>
-            <a:r>
-              <a:t>  "screen_position": "none",</a:t>
-            </a:r>
-          </a:p>
-          <a:p>
-            <a:r>
-              <a:t>  "display_label": "",</a:t>
+              <a:t>  "type": "article_quote",</a:t>
+            </a:r>
+          </a:p>
+          <a:p>
+            <a:r>
+              <a:t>  "required": true,</a:t>
+            </a:r>
+          </a:p>
+          <a:p>
+            <a:r>
+              <a:t>  "screen_position": "left_half",</a:t>
+            </a:r>
+          </a:p>
+          <a:p>
+            <a:r>
+              <a:t>  "display_label": "[기사 인용]",</a:t>
             </a:r>
           </a:p>
           <a:p>
@@ -3142,7 +3162,7 @@
           </a:p>
           <a:p>
             <a:r>
-              <a:t>  "manual_insert_required": false</a:t>
+              <a:t>  "manual_insert_required": true</a:t>
             </a:r>
           </a:p>
           <a:p>
@@ -3692,7 +3712,22 @@
           </a:p>
           <a:p>
             <a:r>
-              <a:t>  "다만 한국 사례는 메인 논지의 증명이 아니라 후반 보조 연결로 사용한다",</a:t>
+              <a:t>  "다만 한국 사례는 메인 논지의 증명이 아니라 후반 보조 연결로 사용한다"</a:t>
+            </a:r>
+          </a:p>
+          <a:p>
+            <a:r>
+              <a:t>]</a:t>
+            </a:r>
+          </a:p>
+          <a:p>
+            <a:r>
+              <a:t>overflow_body_lines:</a:t>
+            </a:r>
+          </a:p>
+          <a:p>
+            <a:r>
+              <a:t>[</a:t>
             </a:r>
           </a:p>
           <a:p>
@@ -3703,16 +3738,6 @@
           <a:p>
             <a:r>
               <a:t>]</a:t>
-            </a:r>
-          </a:p>
-          <a:p>
-            <a:r>
-              <a:t>overflow_body_lines:</a:t>
-            </a:r>
-          </a:p>
-          <a:p>
-            <a:r>
-              <a:t>[]</a:t>
             </a:r>
           </a:p>
           <a:p/>
@@ -4008,17 +4033,17 @@
           </a:p>
           <a:p>
             <a:r>
-              <a:t>proof_object_type: none</a:t>
-            </a:r>
-          </a:p>
-          <a:p>
-            <a:r>
-              <a:t>proof_object_required: False</a:t>
-            </a:r>
-          </a:p>
-          <a:p>
-            <a:r>
-              <a:t>proof_object_screen_position: none</a:t>
+              <a:t>proof_object_type: article_quote</a:t>
+            </a:r>
+          </a:p>
+          <a:p>
+            <a:r>
+              <a:t>proof_object_required: True</a:t>
+            </a:r>
+          </a:p>
+          <a:p>
+            <a:r>
+              <a:t>proof_object_screen_position: left_half</a:t>
             </a:r>
           </a:p>
           <a:p>
@@ -4044,7 +4069,22 @@
           </a:p>
           <a:p>
             <a:r>
-              <a:t>  "그렇다면 사람에게 남겨야 할 것은 답이 아니라 과정일 수 있다",</a:t>
+              <a:t>  "그렇다면 사람에게 남겨야 할 것은 답이 아니라 과정일 수 있다"</a:t>
+            </a:r>
+          </a:p>
+          <a:p>
+            <a:r>
+              <a:t>]</a:t>
+            </a:r>
+          </a:p>
+          <a:p>
+            <a:r>
+              <a:t>overflow_body_lines:</a:t>
+            </a:r>
+          </a:p>
+          <a:p>
+            <a:r>
+              <a:t>[</a:t>
             </a:r>
           </a:p>
           <a:p>
@@ -4057,16 +4097,6 @@
               <a:t>]</a:t>
             </a:r>
           </a:p>
-          <a:p>
-            <a:r>
-              <a:t>overflow_body_lines:</a:t>
-            </a:r>
-          </a:p>
-          <a:p>
-            <a:r>
-              <a:t>[]</a:t>
-            </a:r>
-          </a:p>
           <a:p/>
           <a:p>
             <a:r>
@@ -4168,22 +4198,22 @@
           </a:p>
           <a:p>
             <a:r>
-              <a:t>  "type": "none",</a:t>
-            </a:r>
-          </a:p>
-          <a:p>
-            <a:r>
-              <a:t>  "required": false,</a:t>
-            </a:r>
-          </a:p>
-          <a:p>
-            <a:r>
-              <a:t>  "screen_position": "none",</a:t>
-            </a:r>
-          </a:p>
-          <a:p>
-            <a:r>
-              <a:t>  "display_label": "",</a:t>
+              <a:t>  "type": "article_quote",</a:t>
+            </a:r>
+          </a:p>
+          <a:p>
+            <a:r>
+              <a:t>  "required": true,</a:t>
+            </a:r>
+          </a:p>
+          <a:p>
+            <a:r>
+              <a:t>  "screen_position": "left_half",</a:t>
+            </a:r>
+          </a:p>
+          <a:p>
+            <a:r>
+              <a:t>  "display_label": "[기사 인용]",</a:t>
             </a:r>
           </a:p>
           <a:p>
@@ -4203,7 +4233,7 @@
           </a:p>
           <a:p>
             <a:r>
-              <a:t>  "manual_insert_required": false</a:t>
+              <a:t>  "manual_insert_required": true</a:t>
             </a:r>
           </a:p>
           <a:p>
@@ -4345,17 +4375,17 @@
           </a:p>
           <a:p>
             <a:r>
-              <a:t>proof_object_type: none</a:t>
-            </a:r>
-          </a:p>
-          <a:p>
-            <a:r>
-              <a:t>proof_object_required: False</a:t>
-            </a:r>
-          </a:p>
-          <a:p>
-            <a:r>
-              <a:t>proof_object_screen_position: none</a:t>
+              <a:t>proof_object_type: article_quote</a:t>
+            </a:r>
+          </a:p>
+          <a:p>
+            <a:r>
+              <a:t>proof_object_required: True</a:t>
+            </a:r>
+          </a:p>
+          <a:p>
+            <a:r>
+              <a:t>proof_object_screen_position: left_half</a:t>
             </a:r>
           </a:p>
           <a:p>
@@ -4381,7 +4411,22 @@
           </a:p>
           <a:p>
             <a:r>
-              <a:t>  "AI는 접근성과 개인화 가능성도 넓힐 수 있다",</a:t>
+              <a:t>  "AI는 접근성과 개인화 가능성도 넓힐 수 있다"</a:t>
+            </a:r>
+          </a:p>
+          <a:p>
+            <a:r>
+              <a:t>]</a:t>
+            </a:r>
+          </a:p>
+          <a:p>
+            <a:r>
+              <a:t>overflow_body_lines:</a:t>
+            </a:r>
+          </a:p>
+          <a:p>
+            <a:r>
+              <a:t>[</a:t>
             </a:r>
           </a:p>
           <a:p>
@@ -4394,16 +4439,6 @@
               <a:t>]</a:t>
             </a:r>
           </a:p>
-          <a:p>
-            <a:r>
-              <a:t>overflow_body_lines:</a:t>
-            </a:r>
-          </a:p>
-          <a:p>
-            <a:r>
-              <a:t>[]</a:t>
-            </a:r>
-          </a:p>
           <a:p/>
           <a:p>
             <a:r>
@@ -4510,22 +4545,22 @@
           </a:p>
           <a:p>
             <a:r>
-              <a:t>  "type": "none",</a:t>
-            </a:r>
-          </a:p>
-          <a:p>
-            <a:r>
-              <a:t>  "required": false,</a:t>
-            </a:r>
-          </a:p>
-          <a:p>
-            <a:r>
-              <a:t>  "screen_position": "none",</a:t>
-            </a:r>
-          </a:p>
-          <a:p>
-            <a:r>
-              <a:t>  "display_label": "",</a:t>
+              <a:t>  "type": "article_quote",</a:t>
+            </a:r>
+          </a:p>
+          <a:p>
+            <a:r>
+              <a:t>  "required": true,</a:t>
+            </a:r>
+          </a:p>
+          <a:p>
+            <a:r>
+              <a:t>  "screen_position": "left_half",</a:t>
+            </a:r>
+          </a:p>
+          <a:p>
+            <a:r>
+              <a:t>  "display_label": "[기사 인용]",</a:t>
             </a:r>
           </a:p>
           <a:p>
@@ -4545,7 +4580,7 @@
           </a:p>
           <a:p>
             <a:r>
-              <a:t>  "manual_insert_required": false</a:t>
+              <a:t>  "manual_insert_required": true</a:t>
             </a:r>
           </a:p>
           <a:p>
@@ -5050,7 +5085,22 @@
           </a:p>
           <a:p>
             <a:r>
-              <a:t>  "반대로 AI는 학습 접근성과 개인화 가능성을 높일 수 있다는 주장도 있다",</a:t>
+              <a:t>  "반대로 AI는 학습 접근성과 개인화 가능성을 높일 수 있다는 주장도 있다"</a:t>
+            </a:r>
+          </a:p>
+          <a:p>
+            <a:r>
+              <a:t>]</a:t>
+            </a:r>
+          </a:p>
+          <a:p>
+            <a:r>
+              <a:t>overflow_body_lines:</a:t>
+            </a:r>
+          </a:p>
+          <a:p>
+            <a:r>
+              <a:t>[</a:t>
             </a:r>
           </a:p>
           <a:p>
@@ -5061,16 +5111,6 @@
           <a:p>
             <a:r>
               <a:t>]</a:t>
-            </a:r>
-          </a:p>
-          <a:p>
-            <a:r>
-              <a:t>overflow_body_lines:</a:t>
-            </a:r>
-          </a:p>
-          <a:p>
-            <a:r>
-              <a:t>[]</a:t>
             </a:r>
           </a:p>
           <a:p/>
@@ -5366,17 +5406,17 @@
           </a:p>
           <a:p>
             <a:r>
-              <a:t>proof_object_type: none</a:t>
-            </a:r>
-          </a:p>
-          <a:p>
-            <a:r>
-              <a:t>proof_object_required: False</a:t>
-            </a:r>
-          </a:p>
-          <a:p>
-            <a:r>
-              <a:t>proof_object_screen_position: none</a:t>
+              <a:t>proof_object_type: article_quote</a:t>
+            </a:r>
+          </a:p>
+          <a:p>
+            <a:r>
+              <a:t>proof_object_required: True</a:t>
+            </a:r>
+          </a:p>
+          <a:p>
+            <a:r>
+              <a:t>proof_object_screen_position: left_half</a:t>
             </a:r>
           </a:p>
           <a:p>
@@ -5402,12 +5442,7 @@
           </a:p>
           <a:p>
             <a:r>
-              <a:t>  "AI 답변의 빈틈을 찾는 법",</a:t>
-            </a:r>
-          </a:p>
-          <a:p>
-            <a:r>
-              <a:t>  "다른 자료와 비교하는 법"</a:t>
+              <a:t>  "AI 답변의 빈틈을 찾는 법"</a:t>
             </a:r>
           </a:p>
           <a:p>
@@ -5427,6 +5462,11 @@
           </a:p>
           <a:p>
             <a:r>
+              <a:t>  "다른 자료와 비교하는 법",</a:t>
+            </a:r>
+          </a:p>
+          <a:p>
+            <a:r>
               <a:t>  "모르는 것을 모른다고 남기는 법"</a:t>
             </a:r>
           </a:p>
@@ -5541,22 +5581,22 @@
           </a:p>
           <a:p>
             <a:r>
-              <a:t>  "type": "none",</a:t>
-            </a:r>
-          </a:p>
-          <a:p>
-            <a:r>
-              <a:t>  "required": false,</a:t>
-            </a:r>
-          </a:p>
-          <a:p>
-            <a:r>
-              <a:t>  "screen_position": "none",</a:t>
-            </a:r>
-          </a:p>
-          <a:p>
-            <a:r>
-              <a:t>  "display_label": "",</a:t>
+              <a:t>  "type": "article_quote",</a:t>
+            </a:r>
+          </a:p>
+          <a:p>
+            <a:r>
+              <a:t>  "required": true,</a:t>
+            </a:r>
+          </a:p>
+          <a:p>
+            <a:r>
+              <a:t>  "screen_position": "left_half",</a:t>
+            </a:r>
+          </a:p>
+          <a:p>
+            <a:r>
+              <a:t>  "display_label": "[기사 인용]",</a:t>
             </a:r>
           </a:p>
           <a:p>
@@ -5576,7 +5616,7 @@
           </a:p>
           <a:p>
             <a:r>
-              <a:t>  "manual_insert_required": false</a:t>
+              <a:t>  "manual_insert_required": true</a:t>
             </a:r>
           </a:p>
           <a:p>
@@ -5774,7 +5814,22 @@
           </a:p>
           <a:p>
             <a:r>
-              <a:t>  "더 멀리 보게 해줄 뿐, 어디를 볼지는 사람이 정한다",</a:t>
+              <a:t>  "더 멀리 보게 해줄 뿐, 어디를 볼지는 사람이 정한다"</a:t>
+            </a:r>
+          </a:p>
+          <a:p>
+            <a:r>
+              <a:t>]</a:t>
+            </a:r>
+          </a:p>
+          <a:p>
+            <a:r>
+              <a:t>overflow_body_lines:</a:t>
+            </a:r>
+          </a:p>
+          <a:p>
+            <a:r>
+              <a:t>[</a:t>
             </a:r>
           </a:p>
           <a:p>
@@ -5785,16 +5840,6 @@
           <a:p>
             <a:r>
               <a:t>]</a:t>
-            </a:r>
-          </a:p>
-          <a:p>
-            <a:r>
-              <a:t>overflow_body_lines:</a:t>
-            </a:r>
-          </a:p>
-          <a:p>
-            <a:r>
-              <a:t>[]</a:t>
             </a:r>
           </a:p>
           <a:p/>
@@ -7493,17 +7538,17 @@
           </a:p>
           <a:p>
             <a:r>
-              <a:t>proof_object_type: none</a:t>
-            </a:r>
-          </a:p>
-          <a:p>
-            <a:r>
-              <a:t>proof_object_required: False</a:t>
-            </a:r>
-          </a:p>
-          <a:p>
-            <a:r>
-              <a:t>proof_object_screen_position: none</a:t>
+              <a:t>proof_object_type: article_quote</a:t>
+            </a:r>
+          </a:p>
+          <a:p>
+            <a:r>
+              <a:t>proof_object_required: True</a:t>
+            </a:r>
+          </a:p>
+          <a:p>
+            <a:r>
+              <a:t>proof_object_screen_position: left_half</a:t>
             </a:r>
           </a:p>
           <a:p>
@@ -7529,7 +7574,22 @@
           </a:p>
           <a:p>
             <a:r>
-              <a:t>  "AI 즉답은 그 과정을 도와줄 수도, 일부 건너뛰게 만들 수도 있다",</a:t>
+              <a:t>  "AI 즉답은 그 과정을 도와줄 수도, 일부 건너뛰게 만들 수도 있다"</a:t>
+            </a:r>
+          </a:p>
+          <a:p>
+            <a:r>
+              <a:t>]</a:t>
+            </a:r>
+          </a:p>
+          <a:p>
+            <a:r>
+              <a:t>overflow_body_lines:</a:t>
+            </a:r>
+          </a:p>
+          <a:p>
+            <a:r>
+              <a:t>[</a:t>
             </a:r>
           </a:p>
           <a:p>
@@ -7542,16 +7602,6 @@
               <a:t>]</a:t>
             </a:r>
           </a:p>
-          <a:p>
-            <a:r>
-              <a:t>overflow_body_lines:</a:t>
-            </a:r>
-          </a:p>
-          <a:p>
-            <a:r>
-              <a:t>[]</a:t>
-            </a:r>
-          </a:p>
           <a:p/>
           <a:p>
             <a:r>
@@ -7658,22 +7708,22 @@
           </a:p>
           <a:p>
             <a:r>
-              <a:t>  "type": "none",</a:t>
-            </a:r>
-          </a:p>
-          <a:p>
-            <a:r>
-              <a:t>  "required": false,</a:t>
-            </a:r>
-          </a:p>
-          <a:p>
-            <a:r>
-              <a:t>  "screen_position": "none",</a:t>
-            </a:r>
-          </a:p>
-          <a:p>
-            <a:r>
-              <a:t>  "display_label": "",</a:t>
+              <a:t>  "type": "article_quote",</a:t>
+            </a:r>
+          </a:p>
+          <a:p>
+            <a:r>
+              <a:t>  "required": true,</a:t>
+            </a:r>
+          </a:p>
+          <a:p>
+            <a:r>
+              <a:t>  "screen_position": "left_half",</a:t>
+            </a:r>
+          </a:p>
+          <a:p>
+            <a:r>
+              <a:t>  "display_label": "[기사 인용]",</a:t>
             </a:r>
           </a:p>
           <a:p>
@@ -7693,7 +7743,7 @@
           </a:p>
           <a:p>
             <a:r>
-              <a:t>  "manual_insert_required": false</a:t>
+              <a:t>  "manual_insert_required": true</a:t>
             </a:r>
           </a:p>
           <a:p>
@@ -7881,7 +7931,22 @@
           </a:p>
           <a:p>
             <a:r>
-              <a:t>  "UNESCO와 OECD 자료는 AI 교육을 단순 도구 사용이 아니라 역량·원칙의 문제로 다룬다",</a:t>
+              <a:t>  "UNESCO와 OECD 자료는 AI 교육을 단순 도구 사용이 아니라 역량·원칙의 문제로 다룬다"</a:t>
+            </a:r>
+          </a:p>
+          <a:p>
+            <a:r>
+              <a:t>]</a:t>
+            </a:r>
+          </a:p>
+          <a:p>
+            <a:r>
+              <a:t>overflow_body_lines:</a:t>
+            </a:r>
+          </a:p>
+          <a:p>
+            <a:r>
+              <a:t>[</a:t>
             </a:r>
           </a:p>
           <a:p>
@@ -7892,16 +7957,6 @@
           <a:p>
             <a:r>
               <a:t>]</a:t>
-            </a:r>
-          </a:p>
-          <a:p>
-            <a:r>
-              <a:t>overflow_body_lines:</a:t>
-            </a:r>
-          </a:p>
-          <a:p>
-            <a:r>
-              <a:t>[]</a:t>
             </a:r>
           </a:p>
           <a:p/>
@@ -8841,17 +8896,17 @@
           </a:p>
           <a:p>
             <a:r>
-              <a:t>proof_object_type: none</a:t>
-            </a:r>
-          </a:p>
-          <a:p>
-            <a:r>
-              <a:t>proof_object_required: False</a:t>
-            </a:r>
-          </a:p>
-          <a:p>
-            <a:r>
-              <a:t>proof_object_screen_position: none</a:t>
+              <a:t>proof_object_type: article_quote</a:t>
+            </a:r>
+          </a:p>
+          <a:p>
+            <a:r>
+              <a:t>proof_object_required: True</a:t>
+            </a:r>
+          </a:p>
+          <a:p>
+            <a:r>
+              <a:t>proof_object_screen_position: left_half</a:t>
             </a:r>
           </a:p>
           <a:p>
@@ -8877,7 +8932,22 @@
           </a:p>
           <a:p>
             <a:r>
-              <a:t>  "이 과정은 느리지만 정보 탐색의 다양성과 판단 훈련을 남긴다",</a:t>
+              <a:t>  "이 과정은 느리지만 정보 탐색의 다양성과 판단 훈련을 남긴다"</a:t>
+            </a:r>
+          </a:p>
+          <a:p>
+            <a:r>
+              <a:t>]</a:t>
+            </a:r>
+          </a:p>
+          <a:p>
+            <a:r>
+              <a:t>overflow_body_lines:</a:t>
+            </a:r>
+          </a:p>
+          <a:p>
+            <a:r>
+              <a:t>[</a:t>
             </a:r>
           </a:p>
           <a:p>
@@ -8890,16 +8960,6 @@
               <a:t>]</a:t>
             </a:r>
           </a:p>
-          <a:p>
-            <a:r>
-              <a:t>overflow_body_lines:</a:t>
-            </a:r>
-          </a:p>
-          <a:p>
-            <a:r>
-              <a:t>[]</a:t>
-            </a:r>
-          </a:p>
           <a:p/>
           <a:p>
             <a:r>
@@ -9001,22 +9061,22 @@
           </a:p>
           <a:p>
             <a:r>
-              <a:t>  "type": "none",</a:t>
-            </a:r>
-          </a:p>
-          <a:p>
-            <a:r>
-              <a:t>  "required": false,</a:t>
-            </a:r>
-          </a:p>
-          <a:p>
-            <a:r>
-              <a:t>  "screen_position": "none",</a:t>
-            </a:r>
-          </a:p>
-          <a:p>
-            <a:r>
-              <a:t>  "display_label": "",</a:t>
+              <a:t>  "type": "article_quote",</a:t>
+            </a:r>
+          </a:p>
+          <a:p>
+            <a:r>
+              <a:t>  "required": true,</a:t>
+            </a:r>
+          </a:p>
+          <a:p>
+            <a:r>
+              <a:t>  "screen_position": "left_half",</a:t>
+            </a:r>
+          </a:p>
+          <a:p>
+            <a:r>
+              <a:t>  "display_label": "[기사 인용]",</a:t>
             </a:r>
           </a:p>
           <a:p>
@@ -9036,7 +9096,7 @@
           </a:p>
           <a:p>
             <a:r>
-              <a:t>  "manual_insert_required": false</a:t>
+              <a:t>  "manual_insert_required": true</a:t>
             </a:r>
           </a:p>
           <a:p>
@@ -9219,7 +9279,22 @@
           </a:p>
           <a:p>
             <a:r>
-              <a:t>  "걱정되는 점: 비교·검증·실패의 경험이 줄어들 가능성이 있다",</a:t>
+              <a:t>  "걱정되는 점: 비교·검증·실패의 경험이 줄어들 가능성이 있다"</a:t>
+            </a:r>
+          </a:p>
+          <a:p>
+            <a:r>
+              <a:t>]</a:t>
+            </a:r>
+          </a:p>
+          <a:p>
+            <a:r>
+              <a:t>overflow_body_lines:</a:t>
+            </a:r>
+          </a:p>
+          <a:p>
+            <a:r>
+              <a:t>[</a:t>
             </a:r>
           </a:p>
           <a:p>
@@ -9230,16 +9305,6 @@
           <a:p>
             <a:r>
               <a:t>]</a:t>
-            </a:r>
-          </a:p>
-          <a:p>
-            <a:r>
-              <a:t>overflow_body_lines:</a:t>
-            </a:r>
-          </a:p>
-          <a:p>
-            <a:r>
-              <a:t>[]</a:t>
             </a:r>
           </a:p>
           <a:p/>
@@ -12705,27 +12770,97 @@
               <a:t>AI 역량 교육은 답을 받는 법보다 질문하고 평가하고 책임 있게 쓰는 법으로 확장될 필요가 있다</a:t>
             </a:r>
           </a:p>
-          <a:p>
-            <a:pPr>
-              <a:spcAft>
-                <a:spcPts val="800"/>
-              </a:spcAft>
-            </a:pPr>
-            <a:r>
-              <a:rPr sz="2000" b="0" u="none">
+        </p:txBody>
+      </p:sp>
+      <p:sp>
+        <p:nvSpPr>
+          <p:cNvPr id="4" name="Rectangle 3"/>
+          <p:cNvSpPr/>
+          <p:nvPr/>
+        </p:nvSpPr>
+        <p:spPr>
+          <a:xfrm>
+            <a:off x="7818120" y="1417320"/>
+            <a:ext cx="3703320" cy="4251960"/>
+          </a:xfrm>
+          <a:prstGeom prst="rect">
+            <a:avLst/>
+          </a:prstGeom>
+          <a:solidFill>
+            <a:srgbClr val="EBF1F4"/>
+          </a:solidFill>
+          <a:ln w="12700">
+            <a:solidFill>
+              <a:srgbClr val="A0AEB8"/>
+            </a:solidFill>
+          </a:ln>
+        </p:spPr>
+        <p:style>
+          <a:lnRef idx="1">
+            <a:schemeClr val="accent1"/>
+          </a:lnRef>
+          <a:fillRef idx="3">
+            <a:schemeClr val="accent1"/>
+          </a:fillRef>
+          <a:effectRef idx="2">
+            <a:schemeClr val="accent1"/>
+          </a:effectRef>
+          <a:fontRef idx="minor">
+            <a:schemeClr val="lt1"/>
+          </a:fontRef>
+        </p:style>
+        <p:txBody>
+          <a:bodyPr rtlCol="0" anchor="ctr" wrap="square"/>
+          <a:lstStyle/>
+          <a:p>
+            <a:pPr algn="ctr"/>
+            <a:r>
+              <a:rPr sz="1600" b="1">
                 <a:solidFill>
-                  <a:srgbClr val="181C23"/>
+                  <a:srgbClr val="566070"/>
                 </a:solidFill>
                 <a:latin typeface="Malgun Gothic"/>
               </a:rPr>
-              <a:t>이 주장은 연구·프레임워크에 기대되, 인지 효과를 확정적으로 말하지 않는다</a:t>
-            </a:r>
-          </a:p>
-        </p:txBody>
-      </p:sp>
-      <p:sp>
-        <p:nvSpPr>
-          <p:cNvPr id="4" name="TextBox 3"/>
+              <a:t>[기사 인용]</a:t>
+            </a:r>
+          </a:p>
+          <a:p>
+            <a:pPr algn="ctr">
+              <a:spcBef>
+                <a:spcPts val="800"/>
+              </a:spcBef>
+            </a:pPr>
+            <a:r>
+              <a:rPr sz="1800" b="1">
+                <a:solidFill>
+                  <a:srgbClr val="000000"/>
+                </a:solidFill>
+                <a:latin typeface="Malgun Gothic"/>
+              </a:rPr>
+              <a:t>Microsoft</a:t>
+            </a:r>
+          </a:p>
+          <a:p>
+            <a:pPr algn="ctr">
+              <a:spcBef>
+                <a:spcPts val="400"/>
+              </a:spcBef>
+            </a:pPr>
+            <a:r>
+              <a:rPr sz="1400" b="0">
+                <a:solidFill>
+                  <a:srgbClr val="566070"/>
+                </a:solidFill>
+                <a:latin typeface="Malgun Gothic"/>
+              </a:rPr>
+              <a:t>생각은 결과가 아니라 중간 과정에 숨어 있다</a:t>
+            </a:r>
+          </a:p>
+        </p:txBody>
+      </p:sp>
+      <p:sp>
+        <p:nvSpPr>
+          <p:cNvPr id="5" name="TextBox 4"/>
           <p:cNvSpPr txBox="1"/>
           <p:nvPr/>
         </p:nvSpPr>
@@ -12759,7 +12894,7 @@
       </p:sp>
       <p:sp>
         <p:nvSpPr>
-          <p:cNvPr id="5" name="TextBox 4"/>
+          <p:cNvPr id="6" name="TextBox 5"/>
           <p:cNvSpPr txBox="1"/>
           <p:nvPr/>
         </p:nvSpPr>
@@ -13561,27 +13696,97 @@
               <a:t>OECD와 UNESCO 자료는 AI 교육을 교수 원칙과 학생 역량의 문제로 다룬다</a:t>
             </a:r>
           </a:p>
-          <a:p>
-            <a:pPr>
-              <a:spcAft>
-                <a:spcPts val="800"/>
-              </a:spcAft>
-            </a:pPr>
-            <a:r>
-              <a:rPr sz="2000" b="0" u="none">
+        </p:txBody>
+      </p:sp>
+      <p:sp>
+        <p:nvSpPr>
+          <p:cNvPr id="4" name="Rectangle 3"/>
+          <p:cNvSpPr/>
+          <p:nvPr/>
+        </p:nvSpPr>
+        <p:spPr>
+          <a:xfrm>
+            <a:off x="7818120" y="1417320"/>
+            <a:ext cx="3703320" cy="4251960"/>
+          </a:xfrm>
+          <a:prstGeom prst="rect">
+            <a:avLst/>
+          </a:prstGeom>
+          <a:solidFill>
+            <a:srgbClr val="EBF1F4"/>
+          </a:solidFill>
+          <a:ln w="12700">
+            <a:solidFill>
+              <a:srgbClr val="A0AEB8"/>
+            </a:solidFill>
+          </a:ln>
+        </p:spPr>
+        <p:style>
+          <a:lnRef idx="1">
+            <a:schemeClr val="accent1"/>
+          </a:lnRef>
+          <a:fillRef idx="3">
+            <a:schemeClr val="accent1"/>
+          </a:fillRef>
+          <a:effectRef idx="2">
+            <a:schemeClr val="accent1"/>
+          </a:effectRef>
+          <a:fontRef idx="minor">
+            <a:schemeClr val="lt1"/>
+          </a:fontRef>
+        </p:style>
+        <p:txBody>
+          <a:bodyPr rtlCol="0" anchor="ctr" wrap="square"/>
+          <a:lstStyle/>
+          <a:p>
+            <a:pPr algn="ctr"/>
+            <a:r>
+              <a:rPr sz="1600" b="1">
                 <a:solidFill>
-                  <a:srgbClr val="181C23"/>
+                  <a:srgbClr val="566070"/>
                 </a:solidFill>
                 <a:latin typeface="Malgun Gothic"/>
               </a:rPr>
-              <a:t>다만 교육 효과는 아직 단정하지 않고, 수업 설계의 과제로 남긴다</a:t>
-            </a:r>
-          </a:p>
-        </p:txBody>
-      </p:sp>
-      <p:sp>
-        <p:nvSpPr>
-          <p:cNvPr id="4" name="TextBox 3"/>
+              <a:t>[기사 인용]</a:t>
+            </a:r>
+          </a:p>
+          <a:p>
+            <a:pPr algn="ctr">
+              <a:spcBef>
+                <a:spcPts val="800"/>
+              </a:spcBef>
+            </a:pPr>
+            <a:r>
+              <a:rPr sz="1800" b="1">
+                <a:solidFill>
+                  <a:srgbClr val="000000"/>
+                </a:solidFill>
+                <a:latin typeface="Malgun Gothic"/>
+              </a:rPr>
+              <a:t>OECD</a:t>
+            </a:r>
+          </a:p>
+          <a:p>
+            <a:pPr algn="ctr">
+              <a:spcBef>
+                <a:spcPts val="400"/>
+              </a:spcBef>
+            </a:pPr>
+            <a:r>
+              <a:rPr sz="1400" b="0">
+                <a:solidFill>
+                  <a:srgbClr val="566070"/>
+                </a:solidFill>
+                <a:latin typeface="Malgun Gothic"/>
+              </a:rPr>
+              <a:t>학교는 이제 정답 암기만으로 버티기 어렵다</a:t>
+            </a:r>
+          </a:p>
+        </p:txBody>
+      </p:sp>
+      <p:sp>
+        <p:nvSpPr>
+          <p:cNvPr id="5" name="TextBox 4"/>
           <p:cNvSpPr txBox="1"/>
           <p:nvPr/>
         </p:nvSpPr>
@@ -13615,7 +13820,7 @@
       </p:sp>
       <p:sp>
         <p:nvSpPr>
-          <p:cNvPr id="5" name="TextBox 4"/>
+          <p:cNvPr id="6" name="TextBox 5"/>
           <p:cNvSpPr txBox="1"/>
           <p:nvPr/>
         </p:nvSpPr>
@@ -13761,27 +13966,97 @@
               <a:t>그렇다면 박물관·과학관은 맥락, 경험, 질문, 토론을 더 강조해야 할 수 있다</a:t>
             </a:r>
           </a:p>
-          <a:p>
-            <a:pPr>
-              <a:spcAft>
-                <a:spcPts val="800"/>
-              </a:spcAft>
-            </a:pPr>
-            <a:r>
-              <a:rPr sz="2000" b="0" u="none">
+        </p:txBody>
+      </p:sp>
+      <p:sp>
+        <p:nvSpPr>
+          <p:cNvPr id="4" name="Rectangle 3"/>
+          <p:cNvSpPr/>
+          <p:nvPr/>
+        </p:nvSpPr>
+        <p:spPr>
+          <a:xfrm>
+            <a:off x="7818120" y="1417320"/>
+            <a:ext cx="3703320" cy="4251960"/>
+          </a:xfrm>
+          <a:prstGeom prst="rect">
+            <a:avLst/>
+          </a:prstGeom>
+          <a:solidFill>
+            <a:srgbClr val="EBF1F4"/>
+          </a:solidFill>
+          <a:ln w="12700">
+            <a:solidFill>
+              <a:srgbClr val="A0AEB8"/>
+            </a:solidFill>
+          </a:ln>
+        </p:spPr>
+        <p:style>
+          <a:lnRef idx="1">
+            <a:schemeClr val="accent1"/>
+          </a:lnRef>
+          <a:fillRef idx="3">
+            <a:schemeClr val="accent1"/>
+          </a:fillRef>
+          <a:effectRef idx="2">
+            <a:schemeClr val="accent1"/>
+          </a:effectRef>
+          <a:fontRef idx="minor">
+            <a:schemeClr val="lt1"/>
+          </a:fontRef>
+        </p:style>
+        <p:txBody>
+          <a:bodyPr rtlCol="0" anchor="ctr" wrap="square"/>
+          <a:lstStyle/>
+          <a:p>
+            <a:pPr algn="ctr"/>
+            <a:r>
+              <a:rPr sz="1600" b="1">
                 <a:solidFill>
-                  <a:srgbClr val="181C23"/>
+                  <a:srgbClr val="566070"/>
                 </a:solidFill>
                 <a:latin typeface="Malgun Gothic"/>
               </a:rPr>
-              <a:t>국립과학관 AI 전시 사례는 기술을 체험형 맥락으로 보여주는 보조 사례로만 사용한다</a:t>
-            </a:r>
-          </a:p>
-        </p:txBody>
-      </p:sp>
-      <p:sp>
-        <p:nvSpPr>
-          <p:cNvPr id="4" name="TextBox 3"/>
+              <a:t>[기사 인용]</a:t>
+            </a:r>
+          </a:p>
+          <a:p>
+            <a:pPr algn="ctr">
+              <a:spcBef>
+                <a:spcPts val="800"/>
+              </a:spcBef>
+            </a:pPr>
+            <a:r>
+              <a:rPr sz="1800" b="1">
+                <a:solidFill>
+                  <a:srgbClr val="000000"/>
+                </a:solidFill>
+                <a:latin typeface="Malgun Gothic"/>
+              </a:rPr>
+              <a:t>UNESCO</a:t>
+            </a:r>
+          </a:p>
+          <a:p>
+            <a:pPr algn="ctr">
+              <a:spcBef>
+                <a:spcPts val="400"/>
+              </a:spcBef>
+            </a:pPr>
+            <a:r>
+              <a:rPr sz="1400" b="0">
+                <a:solidFill>
+                  <a:srgbClr val="566070"/>
+                </a:solidFill>
+                <a:latin typeface="Malgun Gothic"/>
+              </a:rPr>
+              <a:t>박물관은 전시품 옆 설명문 이상의 것이 필요해진다</a:t>
+            </a:r>
+          </a:p>
+        </p:txBody>
+      </p:sp>
+      <p:sp>
+        <p:nvSpPr>
+          <p:cNvPr id="5" name="TextBox 4"/>
           <p:cNvSpPr txBox="1"/>
           <p:nvPr/>
         </p:nvSpPr>
@@ -13815,7 +14090,7 @@
       </p:sp>
       <p:sp>
         <p:nvSpPr>
-          <p:cNvPr id="5" name="TextBox 4"/>
+          <p:cNvPr id="6" name="TextBox 5"/>
           <p:cNvSpPr txBox="1"/>
           <p:nvPr/>
         </p:nvSpPr>
@@ -13961,27 +14236,97 @@
               <a:t>하지만 밤하늘을 관찰하고, 위치를 추정하고, 계절과 시간을 연결하는 경험은 다르다</a:t>
             </a:r>
           </a:p>
-          <a:p>
-            <a:pPr>
-              <a:spcAft>
-                <a:spcPts val="800"/>
-              </a:spcAft>
-            </a:pPr>
-            <a:r>
-              <a:rPr sz="2000" b="0" u="none">
+        </p:txBody>
+      </p:sp>
+      <p:sp>
+        <p:nvSpPr>
+          <p:cNvPr id="4" name="Rectangle 3"/>
+          <p:cNvSpPr/>
+          <p:nvPr/>
+        </p:nvSpPr>
+        <p:spPr>
+          <a:xfrm>
+            <a:off x="7818120" y="1417320"/>
+            <a:ext cx="3703320" cy="4251960"/>
+          </a:xfrm>
+          <a:prstGeom prst="rect">
+            <a:avLst/>
+          </a:prstGeom>
+          <a:solidFill>
+            <a:srgbClr val="EBF1F4"/>
+          </a:solidFill>
+          <a:ln w="12700">
+            <a:solidFill>
+              <a:srgbClr val="A0AEB8"/>
+            </a:solidFill>
+          </a:ln>
+        </p:spPr>
+        <p:style>
+          <a:lnRef idx="1">
+            <a:schemeClr val="accent1"/>
+          </a:lnRef>
+          <a:fillRef idx="3">
+            <a:schemeClr val="accent1"/>
+          </a:fillRef>
+          <a:effectRef idx="2">
+            <a:schemeClr val="accent1"/>
+          </a:effectRef>
+          <a:fontRef idx="minor">
+            <a:schemeClr val="lt1"/>
+          </a:fontRef>
+        </p:style>
+        <p:txBody>
+          <a:bodyPr rtlCol="0" anchor="ctr" wrap="square"/>
+          <a:lstStyle/>
+          <a:p>
+            <a:pPr algn="ctr"/>
+            <a:r>
+              <a:rPr sz="1600" b="1">
                 <a:solidFill>
-                  <a:srgbClr val="181C23"/>
+                  <a:srgbClr val="566070"/>
                 </a:solidFill>
                 <a:latin typeface="Malgun Gothic"/>
               </a:rPr>
-              <a:t>천문관 비유는 정보 전달보다 보는 법과 질문하는 법을 강조하기 위한 방송용 구조다</a:t>
-            </a:r>
-          </a:p>
-        </p:txBody>
-      </p:sp>
-      <p:sp>
-        <p:nvSpPr>
-          <p:cNvPr id="4" name="TextBox 3"/>
+              <a:t>[기사 인용]</a:t>
+            </a:r>
+          </a:p>
+          <a:p>
+            <a:pPr algn="ctr">
+              <a:spcBef>
+                <a:spcPts val="800"/>
+              </a:spcBef>
+            </a:pPr>
+            <a:r>
+              <a:rPr sz="1800" b="1">
+                <a:solidFill>
+                  <a:srgbClr val="000000"/>
+                </a:solidFill>
+                <a:latin typeface="Malgun Gothic"/>
+              </a:rPr>
+              <a:t>BBC</a:t>
+            </a:r>
+          </a:p>
+          <a:p>
+            <a:pPr algn="ctr">
+              <a:spcBef>
+                <a:spcPts val="400"/>
+              </a:spcBef>
+            </a:pPr>
+            <a:r>
+              <a:rPr sz="1400" b="0">
+                <a:solidFill>
+                  <a:srgbClr val="566070"/>
+                </a:solidFill>
+                <a:latin typeface="Malgun Gothic"/>
+              </a:rPr>
+              <a:t>천문관은 ‘별 이름’보다 ‘보는 법’을 가르치는 곳</a:t>
+            </a:r>
+          </a:p>
+        </p:txBody>
+      </p:sp>
+      <p:sp>
+        <p:nvSpPr>
+          <p:cNvPr id="5" name="TextBox 4"/>
           <p:cNvSpPr txBox="1"/>
           <p:nvPr/>
         </p:nvSpPr>
@@ -14015,7 +14360,7 @@
       </p:sp>
       <p:sp>
         <p:nvSpPr>
-          <p:cNvPr id="5" name="TextBox 4"/>
+          <p:cNvPr id="6" name="TextBox 5"/>
           <p:cNvSpPr txBox="1"/>
           <p:nvPr/>
         </p:nvSpPr>
@@ -14151,7 +14496,7 @@
           <a:p>
             <a:pPr algn="ctr"/>
             <a:r>
-              <a:rPr sz="1600">
+              <a:rPr sz="1600" b="0">
                 <a:solidFill>
                   <a:srgbClr val="566070"/>
                 </a:solidFill>
@@ -14415,22 +14760,6 @@
               <a:t>다만 한국 사례는 메인 논지의 증명이 아니라 후반 보조 연결로 사용한다</a:t>
             </a:r>
           </a:p>
-          <a:p>
-            <a:pPr>
-              <a:spcAft>
-                <a:spcPts val="800"/>
-              </a:spcAft>
-            </a:pPr>
-            <a:r>
-              <a:rPr sz="2300" b="0" u="none">
-                <a:solidFill>
-                  <a:srgbClr val="181C23"/>
-                </a:solidFill>
-                <a:latin typeface="Malgun Gothic"/>
-              </a:rPr>
-              <a:t>핵심 질문은 한국도 결국 AI를 금지할지보다 어떻게 다룰지라는 쪽으로 옮겨갈 수 있다는 점이다</a:t>
-            </a:r>
-          </a:p>
         </p:txBody>
       </p:sp>
       <p:sp>
@@ -14615,22 +14944,6 @@
               <a:t>그렇다면 사람에게 남겨야 할 것은 답이 아니라 과정일 수 있다</a:t>
             </a:r>
           </a:p>
-          <a:p>
-            <a:pPr>
-              <a:spcAft>
-                <a:spcPts val="800"/>
-              </a:spcAft>
-            </a:pPr>
-            <a:r>
-              <a:rPr sz="2300" b="0" u="none">
-                <a:solidFill>
-                  <a:srgbClr val="181C23"/>
-                </a:solidFill>
-                <a:latin typeface="Malgun Gothic"/>
-              </a:rPr>
-              <a:t>보고, 의심하고, 질문하고, 다시 확인하는 습관이 지식기관의 교육 목표가 될 수 있다</a:t>
-            </a:r>
-          </a:p>
         </p:txBody>
       </p:sp>
       <p:sp>
@@ -14771,7 +15084,7 @@
         <p:spPr>
           <a:xfrm>
             <a:off x="713232" y="2560320"/>
-            <a:ext cx="9875520" cy="2651760"/>
+            <a:ext cx="6766560" cy="2651760"/>
           </a:xfrm>
           <a:prstGeom prst="rect">
             <a:avLst/>
@@ -14815,27 +15128,97 @@
               <a:t>AI는 접근성과 개인화 가능성도 넓힐 수 있다</a:t>
             </a:r>
           </a:p>
-          <a:p>
-            <a:pPr>
-              <a:spcAft>
-                <a:spcPts val="800"/>
-              </a:spcAft>
-            </a:pPr>
-            <a:r>
-              <a:rPr sz="2400" b="0" u="none">
+        </p:txBody>
+      </p:sp>
+      <p:sp>
+        <p:nvSpPr>
+          <p:cNvPr id="4" name="Rectangle 3"/>
+          <p:cNvSpPr/>
+          <p:nvPr/>
+        </p:nvSpPr>
+        <p:spPr>
+          <a:xfrm>
+            <a:off x="8458200" y="4389120"/>
+            <a:ext cx="2560320" cy="1097280"/>
+          </a:xfrm>
+          <a:prstGeom prst="rect">
+            <a:avLst/>
+          </a:prstGeom>
+          <a:solidFill>
+            <a:srgbClr val="EBF1F4"/>
+          </a:solidFill>
+          <a:ln w="12700">
+            <a:solidFill>
+              <a:srgbClr val="A0AEB8"/>
+            </a:solidFill>
+          </a:ln>
+        </p:spPr>
+        <p:style>
+          <a:lnRef idx="1">
+            <a:schemeClr val="accent1"/>
+          </a:lnRef>
+          <a:fillRef idx="3">
+            <a:schemeClr val="accent1"/>
+          </a:fillRef>
+          <a:effectRef idx="2">
+            <a:schemeClr val="accent1"/>
+          </a:effectRef>
+          <a:fontRef idx="minor">
+            <a:schemeClr val="lt1"/>
+          </a:fontRef>
+        </p:style>
+        <p:txBody>
+          <a:bodyPr rtlCol="0" anchor="ctr" wrap="square"/>
+          <a:lstStyle/>
+          <a:p>
+            <a:pPr algn="ctr"/>
+            <a:r>
+              <a:rPr sz="1600" b="1">
                 <a:solidFill>
-                  <a:srgbClr val="181C23"/>
+                  <a:srgbClr val="566070"/>
                 </a:solidFill>
                 <a:latin typeface="Malgun Gothic"/>
               </a:rPr>
-              <a:t>다만 편리함이 곧 배움이라는 뜻은 아니므로, 정보 탐색 과정의 변화로 조심스럽게 다룬다</a:t>
-            </a:r>
-          </a:p>
-        </p:txBody>
-      </p:sp>
-      <p:sp>
-        <p:nvSpPr>
-          <p:cNvPr id="4" name="TextBox 3"/>
+              <a:t>[기사 인용]</a:t>
+            </a:r>
+          </a:p>
+          <a:p>
+            <a:pPr algn="ctr">
+              <a:spcBef>
+                <a:spcPts val="800"/>
+              </a:spcBef>
+            </a:pPr>
+            <a:r>
+              <a:rPr sz="1800" b="1">
+                <a:solidFill>
+                  <a:srgbClr val="000000"/>
+                </a:solidFill>
+                <a:latin typeface="Malgun Gothic"/>
+              </a:rPr>
+              <a:t>Microsoft</a:t>
+            </a:r>
+          </a:p>
+          <a:p>
+            <a:pPr algn="ctr">
+              <a:spcBef>
+                <a:spcPts val="400"/>
+              </a:spcBef>
+            </a:pPr>
+            <a:r>
+              <a:rPr sz="1400" b="0">
+                <a:solidFill>
+                  <a:srgbClr val="566070"/>
+                </a:solidFill>
+                <a:latin typeface="Malgun Gothic"/>
+              </a:rPr>
+              <a:t>AI가 답을 바로 주는 건 정말 편리하다</a:t>
+            </a:r>
+          </a:p>
+        </p:txBody>
+      </p:sp>
+      <p:sp>
+        <p:nvSpPr>
+          <p:cNvPr id="5" name="TextBox 4"/>
           <p:cNvSpPr txBox="1"/>
           <p:nvPr/>
         </p:nvSpPr>
@@ -14869,7 +15252,7 @@
       </p:sp>
       <p:sp>
         <p:nvSpPr>
-          <p:cNvPr id="5" name="TextBox 4"/>
+          <p:cNvPr id="6" name="TextBox 5"/>
           <p:cNvSpPr txBox="1"/>
           <p:nvPr/>
         </p:nvSpPr>
@@ -15300,22 +15683,6 @@
               <a:t>학생도, 직장인도, 관람객도 이미 AI와 함께 정보를 찾는다</a:t>
             </a:r>
           </a:p>
-          <a:p>
-            <a:pPr>
-              <a:spcAft>
-                <a:spcPts val="800"/>
-              </a:spcAft>
-            </a:pPr>
-            <a:r>
-              <a:rPr sz="1900" b="0" u="none">
-                <a:solidFill>
-                  <a:srgbClr val="181C23"/>
-                </a:solidFill>
-                <a:latin typeface="Malgun Gothic"/>
-              </a:rPr>
-              <a:t>반대로 AI는 학습 접근성과 개인화 가능성을 높일 수 있다는 주장도 있다</a:t>
-            </a:r>
-          </a:p>
         </p:txBody>
       </p:sp>
       <p:sp>
@@ -15352,7 +15719,7 @@
                 </a:solidFill>
                 <a:latin typeface="Malgun Gothic"/>
               </a:rPr>
-              <a:t>그래서 문제는 사용 여부가 아니라, 어떤 질문을 던지고 어떤 답을 의심할지에 가깝다</a:t>
+              <a:t>반대로 AI는 학습 접근성과 개인화 가능성을 높일 수 있다는 주장도 있다</a:t>
             </a:r>
           </a:p>
         </p:txBody>
@@ -15539,27 +15906,97 @@
               <a:t>AI 답변의 빈틈을 찾는 법</a:t>
             </a:r>
           </a:p>
-          <a:p>
-            <a:pPr>
-              <a:spcAft>
-                <a:spcPts val="800"/>
-              </a:spcAft>
-            </a:pPr>
-            <a:r>
-              <a:rPr sz="2000" b="0" u="none">
+        </p:txBody>
+      </p:sp>
+      <p:sp>
+        <p:nvSpPr>
+          <p:cNvPr id="4" name="Rectangle 3"/>
+          <p:cNvSpPr/>
+          <p:nvPr/>
+        </p:nvSpPr>
+        <p:spPr>
+          <a:xfrm>
+            <a:off x="7818120" y="1417320"/>
+            <a:ext cx="3703320" cy="4251960"/>
+          </a:xfrm>
+          <a:prstGeom prst="rect">
+            <a:avLst/>
+          </a:prstGeom>
+          <a:solidFill>
+            <a:srgbClr val="EBF1F4"/>
+          </a:solidFill>
+          <a:ln w="12700">
+            <a:solidFill>
+              <a:srgbClr val="A0AEB8"/>
+            </a:solidFill>
+          </a:ln>
+        </p:spPr>
+        <p:style>
+          <a:lnRef idx="1">
+            <a:schemeClr val="accent1"/>
+          </a:lnRef>
+          <a:fillRef idx="3">
+            <a:schemeClr val="accent1"/>
+          </a:fillRef>
+          <a:effectRef idx="2">
+            <a:schemeClr val="accent1"/>
+          </a:effectRef>
+          <a:fontRef idx="minor">
+            <a:schemeClr val="lt1"/>
+          </a:fontRef>
+        </p:style>
+        <p:txBody>
+          <a:bodyPr rtlCol="0" anchor="ctr" wrap="square"/>
+          <a:lstStyle/>
+          <a:p>
+            <a:pPr algn="ctr"/>
+            <a:r>
+              <a:rPr sz="1600" b="1">
                 <a:solidFill>
-                  <a:srgbClr val="181C23"/>
+                  <a:srgbClr val="566070"/>
                 </a:solidFill>
                 <a:latin typeface="Malgun Gothic"/>
               </a:rPr>
-              <a:t>다른 자료와 비교하는 법</a:t>
-            </a:r>
-          </a:p>
-        </p:txBody>
-      </p:sp>
-      <p:sp>
-        <p:nvSpPr>
-          <p:cNvPr id="4" name="TextBox 3"/>
+              <a:t>[기사 인용]</a:t>
+            </a:r>
+          </a:p>
+          <a:p>
+            <a:pPr algn="ctr">
+              <a:spcBef>
+                <a:spcPts val="800"/>
+              </a:spcBef>
+            </a:pPr>
+            <a:r>
+              <a:rPr sz="1800" b="1">
+                <a:solidFill>
+                  <a:srgbClr val="000000"/>
+                </a:solidFill>
+                <a:latin typeface="Malgun Gothic"/>
+              </a:rPr>
+              <a:t>UNESCO</a:t>
+            </a:r>
+          </a:p>
+          <a:p>
+            <a:pPr algn="ctr">
+              <a:spcBef>
+                <a:spcPts val="400"/>
+              </a:spcBef>
+            </a:pPr>
+            <a:r>
+              <a:rPr sz="1400" b="0">
+                <a:solidFill>
+                  <a:srgbClr val="566070"/>
+                </a:solidFill>
+                <a:latin typeface="Malgun Gothic"/>
+              </a:rPr>
+              <a:t>그래서 가르쳐야 할 것은 ‘AI 정답’이 아니라 ‘AI 검산’</a:t>
+            </a:r>
+          </a:p>
+        </p:txBody>
+      </p:sp>
+      <p:sp>
+        <p:nvSpPr>
+          <p:cNvPr id="5" name="TextBox 4"/>
           <p:cNvSpPr txBox="1"/>
           <p:nvPr/>
         </p:nvSpPr>
@@ -15593,7 +16030,7 @@
       </p:sp>
       <p:sp>
         <p:nvSpPr>
-          <p:cNvPr id="5" name="TextBox 4"/>
+          <p:cNvPr id="6" name="TextBox 5"/>
           <p:cNvSpPr txBox="1"/>
           <p:nvPr/>
         </p:nvSpPr>
@@ -15737,22 +16174,6 @@
                 <a:latin typeface="Malgun Gothic"/>
               </a:rPr>
               <a:t>더 멀리 보게 해줄 뿐, 어디를 볼지는 사람이 정한다</a:t>
-            </a:r>
-          </a:p>
-          <a:p>
-            <a:pPr>
-              <a:spcAft>
-                <a:spcPts val="800"/>
-              </a:spcAft>
-            </a:pPr>
-            <a:r>
-              <a:rPr sz="2300" b="0" u="none">
-                <a:solidFill>
-                  <a:srgbClr val="181C23"/>
-                </a:solidFill>
-                <a:latin typeface="Malgun Gothic"/>
-              </a:rPr>
-              <a:t>AI도 답을 대신 주는 도구로만 쓰기보다, 더 좋은 질문을 돕는 도구가 될 수 있는지 묻는다</a:t>
             </a:r>
           </a:p>
         </p:txBody>
@@ -16768,27 +17189,97 @@
               <a:t>AI 즉답은 그 과정을 도와줄 수도, 일부 건너뛰게 만들 수도 있다</a:t>
             </a:r>
           </a:p>
-          <a:p>
-            <a:pPr>
-              <a:spcAft>
-                <a:spcPts val="800"/>
-              </a:spcAft>
-            </a:pPr>
-            <a:r>
-              <a:rPr sz="2000" b="0" u="none">
+        </p:txBody>
+      </p:sp>
+      <p:sp>
+        <p:nvSpPr>
+          <p:cNvPr id="4" name="Rectangle 3"/>
+          <p:cNvSpPr/>
+          <p:nvPr/>
+        </p:nvSpPr>
+        <p:spPr>
+          <a:xfrm>
+            <a:off x="7818120" y="1417320"/>
+            <a:ext cx="3703320" cy="4251960"/>
+          </a:xfrm>
+          <a:prstGeom prst="rect">
+            <a:avLst/>
+          </a:prstGeom>
+          <a:solidFill>
+            <a:srgbClr val="EBF1F4"/>
+          </a:solidFill>
+          <a:ln w="12700">
+            <a:solidFill>
+              <a:srgbClr val="A0AEB8"/>
+            </a:solidFill>
+          </a:ln>
+        </p:spPr>
+        <p:style>
+          <a:lnRef idx="1">
+            <a:schemeClr val="accent1"/>
+          </a:lnRef>
+          <a:fillRef idx="3">
+            <a:schemeClr val="accent1"/>
+          </a:fillRef>
+          <a:effectRef idx="2">
+            <a:schemeClr val="accent1"/>
+          </a:effectRef>
+          <a:fontRef idx="minor">
+            <a:schemeClr val="lt1"/>
+          </a:fontRef>
+        </p:style>
+        <p:txBody>
+          <a:bodyPr rtlCol="0" anchor="ctr" wrap="square"/>
+          <a:lstStyle/>
+          <a:p>
+            <a:pPr algn="ctr"/>
+            <a:r>
+              <a:rPr sz="1600" b="1">
                 <a:solidFill>
-                  <a:srgbClr val="181C23"/>
+                  <a:srgbClr val="566070"/>
                 </a:solidFill>
                 <a:latin typeface="Malgun Gothic"/>
               </a:rPr>
-              <a:t>여기서는 사실 증명보다 방송용 문제 제기: 도구가 답을 줄 때 사람의 관찰은 어디에 남는가</a:t>
-            </a:r>
-          </a:p>
-        </p:txBody>
-      </p:sp>
-      <p:sp>
-        <p:nvSpPr>
-          <p:cNvPr id="4" name="TextBox 3"/>
+              <a:t>[기사 인용]</a:t>
+            </a:r>
+          </a:p>
+          <a:p>
+            <a:pPr algn="ctr">
+              <a:spcBef>
+                <a:spcPts val="800"/>
+              </a:spcBef>
+            </a:pPr>
+            <a:r>
+              <a:rPr sz="1800" b="1">
+                <a:solidFill>
+                  <a:srgbClr val="000000"/>
+                </a:solidFill>
+                <a:latin typeface="Malgun Gothic"/>
+              </a:rPr>
+              <a:t>BBC</a:t>
+            </a:r>
+          </a:p>
+          <a:p>
+            <a:pPr algn="ctr">
+              <a:spcBef>
+                <a:spcPts val="400"/>
+              </a:spcBef>
+            </a:pPr>
+            <a:r>
+              <a:rPr sz="1400" b="0">
+                <a:solidFill>
+                  <a:srgbClr val="566070"/>
+                </a:solidFill>
+                <a:latin typeface="Malgun Gothic"/>
+              </a:rPr>
+              <a:t>천문대가 왜 이런 말을 했을까</a:t>
+            </a:r>
+          </a:p>
+        </p:txBody>
+      </p:sp>
+      <p:sp>
+        <p:nvSpPr>
+          <p:cNvPr id="5" name="TextBox 4"/>
           <p:cNvSpPr txBox="1"/>
           <p:nvPr/>
         </p:nvSpPr>
@@ -16822,7 +17313,7 @@
       </p:sp>
       <p:sp>
         <p:nvSpPr>
-          <p:cNvPr id="5" name="TextBox 4"/>
+          <p:cNvPr id="6" name="TextBox 5"/>
           <p:cNvSpPr txBox="1"/>
           <p:nvPr/>
         </p:nvSpPr>
@@ -16966,22 +17457,6 @@
                 <a:latin typeface="Malgun Gothic"/>
               </a:rPr>
               <a:t>UNESCO와 OECD 자료는 AI 교육을 단순 도구 사용이 아니라 역량·원칙의 문제로 다룬다</a:t>
-            </a:r>
-          </a:p>
-          <a:p>
-            <a:pPr>
-              <a:spcAft>
-                <a:spcPts val="800"/>
-              </a:spcAft>
-            </a:pPr>
-            <a:r>
-              <a:rPr sz="2300" b="0" u="none">
-                <a:solidFill>
-                  <a:srgbClr val="181C23"/>
-                </a:solidFill>
-                <a:latin typeface="Malgun Gothic"/>
-              </a:rPr>
-              <a:t>따라서 핵심은 답 제공 경쟁이 아니라 질문·검증·맥락을 가르치는 역할 변화다</a:t>
             </a:r>
           </a:p>
         </p:txBody>
@@ -17579,27 +18054,97 @@
               <a:t>이 과정은 느리지만 정보 탐색의 다양성과 판단 훈련을 남긴다</a:t>
             </a:r>
           </a:p>
-          <a:p>
-            <a:pPr>
-              <a:spcAft>
-                <a:spcPts val="800"/>
-              </a:spcAft>
-            </a:pPr>
-            <a:r>
-              <a:rPr sz="2000" b="0" u="none">
+        </p:txBody>
+      </p:sp>
+      <p:sp>
+        <p:nvSpPr>
+          <p:cNvPr id="4" name="Rectangle 3"/>
+          <p:cNvSpPr/>
+          <p:nvPr/>
+        </p:nvSpPr>
+        <p:spPr>
+          <a:xfrm>
+            <a:off x="7818120" y="1417320"/>
+            <a:ext cx="3703320" cy="4251960"/>
+          </a:xfrm>
+          <a:prstGeom prst="rect">
+            <a:avLst/>
+          </a:prstGeom>
+          <a:solidFill>
+            <a:srgbClr val="EBF1F4"/>
+          </a:solidFill>
+          <a:ln w="12700">
+            <a:solidFill>
+              <a:srgbClr val="A0AEB8"/>
+            </a:solidFill>
+          </a:ln>
+        </p:spPr>
+        <p:style>
+          <a:lnRef idx="1">
+            <a:schemeClr val="accent1"/>
+          </a:lnRef>
+          <a:fillRef idx="3">
+            <a:schemeClr val="accent1"/>
+          </a:fillRef>
+          <a:effectRef idx="2">
+            <a:schemeClr val="accent1"/>
+          </a:effectRef>
+          <a:fontRef idx="minor">
+            <a:schemeClr val="lt1"/>
+          </a:fontRef>
+        </p:style>
+        <p:txBody>
+          <a:bodyPr rtlCol="0" anchor="ctr" wrap="square"/>
+          <a:lstStyle/>
+          <a:p>
+            <a:pPr algn="ctr"/>
+            <a:r>
+              <a:rPr sz="1600" b="1">
                 <a:solidFill>
-                  <a:srgbClr val="181C23"/>
+                  <a:srgbClr val="566070"/>
                 </a:solidFill>
                 <a:latin typeface="Malgun Gothic"/>
               </a:rPr>
-              <a:t>Microsoft Research 자료는 generative AI가 정보 탐색 다양성에 어떤 영향을 줄 수 있는지 문제를 제기한다</a:t>
-            </a:r>
-          </a:p>
-        </p:txBody>
-      </p:sp>
-      <p:sp>
-        <p:nvSpPr>
-          <p:cNvPr id="4" name="TextBox 3"/>
+              <a:t>[기사 인용]</a:t>
+            </a:r>
+          </a:p>
+          <a:p>
+            <a:pPr algn="ctr">
+              <a:spcBef>
+                <a:spcPts val="800"/>
+              </a:spcBef>
+            </a:pPr>
+            <a:r>
+              <a:rPr sz="1800" b="1">
+                <a:solidFill>
+                  <a:srgbClr val="000000"/>
+                </a:solidFill>
+                <a:latin typeface="Malgun Gothic"/>
+              </a:rPr>
+              <a:t>Microsoft</a:t>
+            </a:r>
+          </a:p>
+          <a:p>
+            <a:pPr algn="ctr">
+              <a:spcBef>
+                <a:spcPts val="400"/>
+              </a:spcBef>
+            </a:pPr>
+            <a:r>
+              <a:rPr sz="1400" b="0">
+                <a:solidFill>
+                  <a:srgbClr val="566070"/>
+                </a:solidFill>
+                <a:latin typeface="Malgun Gothic"/>
+              </a:rPr>
+              <a:t>예전 검색은 귀찮았지만 흔적이 남았다</a:t>
+            </a:r>
+          </a:p>
+        </p:txBody>
+      </p:sp>
+      <p:sp>
+        <p:nvSpPr>
+          <p:cNvPr id="5" name="TextBox 4"/>
           <p:cNvSpPr txBox="1"/>
           <p:nvPr/>
         </p:nvSpPr>
@@ -17633,7 +18178,7 @@
       </p:sp>
       <p:sp>
         <p:nvSpPr>
-          <p:cNvPr id="5" name="TextBox 4"/>
+          <p:cNvPr id="6" name="TextBox 5"/>
           <p:cNvSpPr txBox="1"/>
           <p:nvPr/>
         </p:nvSpPr>
@@ -17853,22 +18398,6 @@
               <a:t>좋은 점: 빠르고, 친절하고, 맥락을 이어준다</a:t>
             </a:r>
           </a:p>
-          <a:p>
-            <a:pPr>
-              <a:spcAft>
-                <a:spcPts val="800"/>
-              </a:spcAft>
-            </a:pPr>
-            <a:r>
-              <a:rPr sz="1900" b="0" u="none">
-                <a:solidFill>
-                  <a:srgbClr val="181C23"/>
-                </a:solidFill>
-                <a:latin typeface="Malgun Gothic"/>
-              </a:rPr>
-              <a:t>걱정되는 점: 비교·검증·실패의 경험이 줄어들 가능성이 있다</a:t>
-            </a:r>
-          </a:p>
         </p:txBody>
       </p:sp>
       <p:sp>
@@ -17905,7 +18434,7 @@
                 </a:solidFill>
                 <a:latin typeface="Malgun Gothic"/>
               </a:rPr>
-              <a:t>중요: 이것이 곧 학습 저하라는 단정은 아니며, 설계와 교육 원칙에 따라 달라질 수 있다</a:t>
+              <a:t>걱정되는 점: 비교·검증·실패의 경험이 줄어들 가능성이 있다</a:t>
             </a:r>
           </a:p>
         </p:txBody>

</xml_diff>

<commit_message>
Apply Piti body line spacing rules
</commit_message>
<xml_diff>
--- a/outputs/pptx/ai_knowledge_institution_draft.pptx
+++ b/outputs/pptx/ai_knowledge_institution_draft.pptx
@@ -12556,6 +12556,9 @@
           <a:lstStyle/>
           <a:p>
             <a:pPr>
+              <a:lnSpc>
+                <a:spcPct val="150000"/>
+              </a:lnSpc>
               <a:spcAft>
                 <a:spcPts val="800"/>
               </a:spcAft>
@@ -12572,6 +12575,9 @@
           </a:p>
           <a:p>
             <a:pPr>
+              <a:lnSpc>
+                <a:spcPct val="150000"/>
+              </a:lnSpc>
               <a:spcAft>
                 <a:spcPts val="800"/>
               </a:spcAft>
@@ -12740,6 +12746,9 @@
           <a:lstStyle/>
           <a:p>
             <a:pPr>
+              <a:lnSpc>
+                <a:spcPct val="150000"/>
+              </a:lnSpc>
               <a:spcAft>
                 <a:spcPts val="800"/>
               </a:spcAft>
@@ -12756,6 +12765,9 @@
           </a:p>
           <a:p>
             <a:pPr>
+              <a:lnSpc>
+                <a:spcPct val="150000"/>
+              </a:lnSpc>
               <a:spcAft>
                 <a:spcPts val="800"/>
               </a:spcAft>
@@ -13055,6 +13067,9 @@
           <a:lstStyle/>
           <a:p>
             <a:pPr>
+              <a:lnSpc>
+                <a:spcPct val="150000"/>
+              </a:lnSpc>
               <a:spcAft>
                 <a:spcPts val="800"/>
               </a:spcAft>
@@ -13071,6 +13086,9 @@
           </a:p>
           <a:p>
             <a:pPr>
+              <a:lnSpc>
+                <a:spcPct val="150000"/>
+              </a:lnSpc>
               <a:spcAft>
                 <a:spcPts val="800"/>
               </a:spcAft>
@@ -13087,6 +13105,9 @@
           </a:p>
           <a:p>
             <a:pPr>
+              <a:lnSpc>
+                <a:spcPct val="150000"/>
+              </a:lnSpc>
               <a:spcAft>
                 <a:spcPts val="800"/>
               </a:spcAft>
@@ -13255,6 +13276,9 @@
           <a:lstStyle/>
           <a:p>
             <a:pPr>
+              <a:lnSpc>
+                <a:spcPct val="150000"/>
+              </a:lnSpc>
               <a:spcAft>
                 <a:spcPts val="800"/>
               </a:spcAft>
@@ -13271,6 +13295,9 @@
           </a:p>
           <a:p>
             <a:pPr>
+              <a:lnSpc>
+                <a:spcPct val="150000"/>
+              </a:lnSpc>
               <a:spcAft>
                 <a:spcPts val="800"/>
               </a:spcAft>
@@ -13287,6 +13314,9 @@
           </a:p>
           <a:p>
             <a:pPr>
+              <a:lnSpc>
+                <a:spcPct val="150000"/>
+              </a:lnSpc>
               <a:spcAft>
                 <a:spcPts val="800"/>
               </a:spcAft>
@@ -13498,6 +13528,9 @@
           <a:lstStyle/>
           <a:p>
             <a:pPr>
+              <a:lnSpc>
+                <a:spcPct val="150000"/>
+              </a:lnSpc>
               <a:spcAft>
                 <a:spcPts val="800"/>
               </a:spcAft>
@@ -13666,6 +13699,9 @@
           <a:lstStyle/>
           <a:p>
             <a:pPr>
+              <a:lnSpc>
+                <a:spcPct val="150000"/>
+              </a:lnSpc>
               <a:spcAft>
                 <a:spcPts val="800"/>
               </a:spcAft>
@@ -13682,6 +13718,9 @@
           </a:p>
           <a:p>
             <a:pPr>
+              <a:lnSpc>
+                <a:spcPct val="150000"/>
+              </a:lnSpc>
               <a:spcAft>
                 <a:spcPts val="800"/>
               </a:spcAft>
@@ -13936,6 +13975,9 @@
           <a:lstStyle/>
           <a:p>
             <a:pPr>
+              <a:lnSpc>
+                <a:spcPct val="150000"/>
+              </a:lnSpc>
               <a:spcAft>
                 <a:spcPts val="800"/>
               </a:spcAft>
@@ -13952,6 +13994,9 @@
           </a:p>
           <a:p>
             <a:pPr>
+              <a:lnSpc>
+                <a:spcPct val="150000"/>
+              </a:lnSpc>
               <a:spcAft>
                 <a:spcPts val="800"/>
               </a:spcAft>
@@ -14206,6 +14251,9 @@
           <a:lstStyle/>
           <a:p>
             <a:pPr>
+              <a:lnSpc>
+                <a:spcPct val="150000"/>
+              </a:lnSpc>
               <a:spcAft>
                 <a:spcPts val="800"/>
               </a:spcAft>
@@ -14222,6 +14270,9 @@
           </a:p>
           <a:p>
             <a:pPr>
+              <a:lnSpc>
+                <a:spcPct val="150000"/>
+              </a:lnSpc>
               <a:spcAft>
                 <a:spcPts val="800"/>
               </a:spcAft>
@@ -14530,6 +14581,9 @@
           <a:lstStyle/>
           <a:p>
             <a:pPr>
+              <a:lnSpc>
+                <a:spcPct val="150000"/>
+              </a:lnSpc>
               <a:spcAft>
                 <a:spcPts val="800"/>
               </a:spcAft>
@@ -14546,6 +14600,9 @@
           </a:p>
           <a:p>
             <a:pPr>
+              <a:lnSpc>
+                <a:spcPct val="150000"/>
+              </a:lnSpc>
               <a:spcAft>
                 <a:spcPts val="800"/>
               </a:spcAft>
@@ -14562,6 +14619,9 @@
           </a:p>
           <a:p>
             <a:pPr>
+              <a:lnSpc>
+                <a:spcPct val="150000"/>
+              </a:lnSpc>
               <a:spcAft>
                 <a:spcPts val="800"/>
               </a:spcAft>
@@ -14730,6 +14790,9 @@
           <a:lstStyle/>
           <a:p>
             <a:pPr>
+              <a:lnSpc>
+                <a:spcPct val="150000"/>
+              </a:lnSpc>
               <a:spcAft>
                 <a:spcPts val="800"/>
               </a:spcAft>
@@ -14746,6 +14809,9 @@
           </a:p>
           <a:p>
             <a:pPr>
+              <a:lnSpc>
+                <a:spcPct val="150000"/>
+              </a:lnSpc>
               <a:spcAft>
                 <a:spcPts val="800"/>
               </a:spcAft>
@@ -14914,6 +14980,9 @@
           <a:lstStyle/>
           <a:p>
             <a:pPr>
+              <a:lnSpc>
+                <a:spcPct val="150000"/>
+              </a:lnSpc>
               <a:spcAft>
                 <a:spcPts val="800"/>
               </a:spcAft>
@@ -14930,6 +14999,9 @@
           </a:p>
           <a:p>
             <a:pPr>
+              <a:lnSpc>
+                <a:spcPct val="150000"/>
+              </a:lnSpc>
               <a:spcAft>
                 <a:spcPts val="800"/>
               </a:spcAft>
@@ -15098,6 +15170,9 @@
           <a:lstStyle/>
           <a:p>
             <a:pPr>
+              <a:lnSpc>
+                <a:spcPct val="150000"/>
+              </a:lnSpc>
               <a:spcAft>
                 <a:spcPts val="800"/>
               </a:spcAft>
@@ -15114,6 +15189,9 @@
           </a:p>
           <a:p>
             <a:pPr>
+              <a:lnSpc>
+                <a:spcPct val="150000"/>
+              </a:lnSpc>
               <a:spcAft>
                 <a:spcPts val="800"/>
               </a:spcAft>
@@ -15411,6 +15489,9 @@
           <a:lstStyle/>
           <a:p>
             <a:pPr>
+              <a:lnSpc>
+                <a:spcPct val="150000"/>
+              </a:lnSpc>
               <a:spcAft>
                 <a:spcPts val="800"/>
               </a:spcAft>
@@ -15669,6 +15750,9 @@
           <a:lstStyle/>
           <a:p>
             <a:pPr>
+              <a:lnSpc>
+                <a:spcPct val="150000"/>
+              </a:lnSpc>
               <a:spcAft>
                 <a:spcPts val="800"/>
               </a:spcAft>
@@ -15708,6 +15792,9 @@
           <a:lstStyle/>
           <a:p>
             <a:pPr>
+              <a:lnSpc>
+                <a:spcPct val="150000"/>
+              </a:lnSpc>
               <a:spcAft>
                 <a:spcPts val="800"/>
               </a:spcAft>
@@ -15876,6 +15963,9 @@
           <a:lstStyle/>
           <a:p>
             <a:pPr>
+              <a:lnSpc>
+                <a:spcPct val="150000"/>
+              </a:lnSpc>
               <a:spcAft>
                 <a:spcPts val="800"/>
               </a:spcAft>
@@ -15892,6 +15982,9 @@
           </a:p>
           <a:p>
             <a:pPr>
+              <a:lnSpc>
+                <a:spcPct val="150000"/>
+              </a:lnSpc>
               <a:spcAft>
                 <a:spcPts val="800"/>
               </a:spcAft>
@@ -16146,6 +16239,9 @@
           <a:lstStyle/>
           <a:p>
             <a:pPr>
+              <a:lnSpc>
+                <a:spcPct val="150000"/>
+              </a:lnSpc>
               <a:spcAft>
                 <a:spcPts val="800"/>
               </a:spcAft>
@@ -16162,6 +16258,9 @@
           </a:p>
           <a:p>
             <a:pPr>
+              <a:lnSpc>
+                <a:spcPct val="150000"/>
+              </a:lnSpc>
               <a:spcAft>
                 <a:spcPts val="800"/>
               </a:spcAft>
@@ -16330,6 +16429,9 @@
           <a:lstStyle/>
           <a:p>
             <a:pPr>
+              <a:lnSpc>
+                <a:spcPct val="150000"/>
+              </a:lnSpc>
               <a:spcAft>
                 <a:spcPts val="800"/>
               </a:spcAft>
@@ -16346,6 +16448,9 @@
           </a:p>
           <a:p>
             <a:pPr>
+              <a:lnSpc>
+                <a:spcPct val="150000"/>
+              </a:lnSpc>
               <a:spcAft>
                 <a:spcPts val="800"/>
               </a:spcAft>
@@ -16362,6 +16467,9 @@
           </a:p>
           <a:p>
             <a:pPr>
+              <a:lnSpc>
+                <a:spcPct val="150000"/>
+              </a:lnSpc>
               <a:spcAft>
                 <a:spcPts val="800"/>
               </a:spcAft>
@@ -16530,6 +16638,9 @@
           <a:lstStyle/>
           <a:p>
             <a:pPr>
+              <a:lnSpc>
+                <a:spcPct val="150000"/>
+              </a:lnSpc>
               <a:spcAft>
                 <a:spcPts val="800"/>
               </a:spcAft>
@@ -16546,6 +16657,9 @@
           </a:p>
           <a:p>
             <a:pPr>
+              <a:lnSpc>
+                <a:spcPct val="150000"/>
+              </a:lnSpc>
               <a:spcAft>
                 <a:spcPts val="800"/>
               </a:spcAft>
@@ -16562,6 +16676,9 @@
           </a:p>
           <a:p>
             <a:pPr>
+              <a:lnSpc>
+                <a:spcPct val="150000"/>
+              </a:lnSpc>
               <a:spcAft>
                 <a:spcPts val="800"/>
               </a:spcAft>
@@ -16730,6 +16847,9 @@
           <a:lstStyle/>
           <a:p>
             <a:pPr>
+              <a:lnSpc>
+                <a:spcPct val="150000"/>
+              </a:lnSpc>
               <a:spcAft>
                 <a:spcPts val="800"/>
               </a:spcAft>
@@ -16746,6 +16866,9 @@
           </a:p>
           <a:p>
             <a:pPr>
+              <a:lnSpc>
+                <a:spcPct val="150000"/>
+              </a:lnSpc>
               <a:spcAft>
                 <a:spcPts val="800"/>
               </a:spcAft>
@@ -16959,6 +17082,9 @@
           <a:lstStyle/>
           <a:p>
             <a:pPr>
+              <a:lnSpc>
+                <a:spcPct val="150000"/>
+              </a:lnSpc>
               <a:spcAft>
                 <a:spcPts val="800"/>
               </a:spcAft>
@@ -16975,6 +17101,9 @@
           </a:p>
           <a:p>
             <a:pPr>
+              <a:lnSpc>
+                <a:spcPct val="150000"/>
+              </a:lnSpc>
               <a:spcAft>
                 <a:spcPts val="800"/>
               </a:spcAft>
@@ -16991,6 +17120,9 @@
           </a:p>
           <a:p>
             <a:pPr>
+              <a:lnSpc>
+                <a:spcPct val="150000"/>
+              </a:lnSpc>
               <a:spcAft>
                 <a:spcPts val="800"/>
               </a:spcAft>
@@ -17159,6 +17291,9 @@
           <a:lstStyle/>
           <a:p>
             <a:pPr>
+              <a:lnSpc>
+                <a:spcPct val="150000"/>
+              </a:lnSpc>
               <a:spcAft>
                 <a:spcPts val="800"/>
               </a:spcAft>
@@ -17175,6 +17310,9 @@
           </a:p>
           <a:p>
             <a:pPr>
+              <a:lnSpc>
+                <a:spcPct val="150000"/>
+              </a:lnSpc>
               <a:spcAft>
                 <a:spcPts val="800"/>
               </a:spcAft>
@@ -17429,6 +17567,9 @@
           <a:lstStyle/>
           <a:p>
             <a:pPr>
+              <a:lnSpc>
+                <a:spcPct val="150000"/>
+              </a:lnSpc>
               <a:spcAft>
                 <a:spcPts val="800"/>
               </a:spcAft>
@@ -17445,6 +17586,9 @@
           </a:p>
           <a:p>
             <a:pPr>
+              <a:lnSpc>
+                <a:spcPct val="150000"/>
+              </a:lnSpc>
               <a:spcAft>
                 <a:spcPts val="800"/>
               </a:spcAft>
@@ -17613,6 +17757,9 @@
           <a:lstStyle/>
           <a:p>
             <a:pPr>
+              <a:lnSpc>
+                <a:spcPct val="150000"/>
+              </a:lnSpc>
               <a:spcAft>
                 <a:spcPts val="800"/>
               </a:spcAft>
@@ -17629,6 +17776,9 @@
           </a:p>
           <a:p>
             <a:pPr>
+              <a:lnSpc>
+                <a:spcPct val="150000"/>
+              </a:lnSpc>
               <a:spcAft>
                 <a:spcPts val="800"/>
               </a:spcAft>
@@ -17645,6 +17795,9 @@
           </a:p>
           <a:p>
             <a:pPr>
+              <a:lnSpc>
+                <a:spcPct val="150000"/>
+              </a:lnSpc>
               <a:spcAft>
                 <a:spcPts val="800"/>
               </a:spcAft>
@@ -17856,6 +18009,9 @@
           <a:lstStyle/>
           <a:p>
             <a:pPr>
+              <a:lnSpc>
+                <a:spcPct val="150000"/>
+              </a:lnSpc>
               <a:spcAft>
                 <a:spcPts val="800"/>
               </a:spcAft>
@@ -18024,6 +18180,9 @@
           <a:lstStyle/>
           <a:p>
             <a:pPr>
+              <a:lnSpc>
+                <a:spcPct val="150000"/>
+              </a:lnSpc>
               <a:spcAft>
                 <a:spcPts val="800"/>
               </a:spcAft>
@@ -18040,6 +18199,9 @@
           </a:p>
           <a:p>
             <a:pPr>
+              <a:lnSpc>
+                <a:spcPct val="150000"/>
+              </a:lnSpc>
               <a:spcAft>
                 <a:spcPts val="800"/>
               </a:spcAft>
@@ -18384,6 +18546,9 @@
           <a:lstStyle/>
           <a:p>
             <a:pPr>
+              <a:lnSpc>
+                <a:spcPct val="150000"/>
+              </a:lnSpc>
               <a:spcAft>
                 <a:spcPts val="800"/>
               </a:spcAft>
@@ -18423,6 +18588,9 @@
           <a:lstStyle/>
           <a:p>
             <a:pPr>
+              <a:lnSpc>
+                <a:spcPct val="150000"/>
+              </a:lnSpc>
               <a:spcAft>
                 <a:spcPts val="800"/>
               </a:spcAft>

</xml_diff>

<commit_message>
Apply Piti screen role styling
</commit_message>
<xml_diff>
--- a/outputs/pptx/ai_knowledge_institution_draft.pptx
+++ b/outputs/pptx/ai_knowledge_institution_draft.pptx
@@ -12550,7 +12550,7 @@
           <a:noFill/>
         </p:spPr>
         <p:txBody>
-          <a:bodyPr wrap="square">
+          <a:bodyPr wrap="square" anchor="ctr">
             <a:spAutoFit/>
           </a:bodyPr>
           <a:lstStyle/>
@@ -12740,7 +12740,7 @@
           <a:noFill/>
         </p:spPr>
         <p:txBody>
-          <a:bodyPr wrap="square">
+          <a:bodyPr wrap="square" anchor="ctr">
             <a:spAutoFit/>
           </a:bodyPr>
           <a:lstStyle/>
@@ -12827,7 +12827,7 @@
           <a:p>
             <a:pPr algn="ctr"/>
             <a:r>
-              <a:rPr sz="1600" b="1">
+              <a:rPr sz="1600" b="0">
                 <a:solidFill>
                   <a:srgbClr val="566070"/>
                 </a:solidFill>
@@ -13061,7 +13061,7 @@
           <a:noFill/>
         </p:spPr>
         <p:txBody>
-          <a:bodyPr wrap="square">
+          <a:bodyPr wrap="square" anchor="ctr">
             <a:spAutoFit/>
           </a:bodyPr>
           <a:lstStyle/>
@@ -13270,7 +13270,7 @@
           <a:noFill/>
         </p:spPr>
         <p:txBody>
-          <a:bodyPr wrap="square">
+          <a:bodyPr wrap="square" anchor="ctr">
             <a:spAutoFit/>
           </a:bodyPr>
           <a:lstStyle/>
@@ -13522,7 +13522,7 @@
           <a:noFill/>
         </p:spPr>
         <p:txBody>
-          <a:bodyPr wrap="square">
+          <a:bodyPr wrap="square" anchor="ctr">
             <a:spAutoFit/>
           </a:bodyPr>
           <a:lstStyle/>
@@ -13693,7 +13693,7 @@
           <a:noFill/>
         </p:spPr>
         <p:txBody>
-          <a:bodyPr wrap="square">
+          <a:bodyPr wrap="square" anchor="ctr">
             <a:spAutoFit/>
           </a:bodyPr>
           <a:lstStyle/>
@@ -13780,7 +13780,7 @@
           <a:p>
             <a:pPr algn="ctr"/>
             <a:r>
-              <a:rPr sz="1600" b="1">
+              <a:rPr sz="1600" b="0">
                 <a:solidFill>
                   <a:srgbClr val="566070"/>
                 </a:solidFill>
@@ -13969,7 +13969,7 @@
           <a:noFill/>
         </p:spPr>
         <p:txBody>
-          <a:bodyPr wrap="square">
+          <a:bodyPr wrap="square" anchor="ctr">
             <a:spAutoFit/>
           </a:bodyPr>
           <a:lstStyle/>
@@ -14056,7 +14056,7 @@
           <a:p>
             <a:pPr algn="ctr"/>
             <a:r>
-              <a:rPr sz="1600" b="1">
+              <a:rPr sz="1600" b="0">
                 <a:solidFill>
                   <a:srgbClr val="566070"/>
                 </a:solidFill>
@@ -14245,7 +14245,7 @@
           <a:noFill/>
         </p:spPr>
         <p:txBody>
-          <a:bodyPr wrap="square">
+          <a:bodyPr wrap="square" anchor="ctr">
             <a:spAutoFit/>
           </a:bodyPr>
           <a:lstStyle/>
@@ -14332,7 +14332,7 @@
           <a:p>
             <a:pPr algn="ctr"/>
             <a:r>
-              <a:rPr sz="1600" b="1">
+              <a:rPr sz="1600" b="0">
                 <a:solidFill>
                   <a:srgbClr val="566070"/>
                 </a:solidFill>
@@ -14575,7 +14575,7 @@
           <a:noFill/>
         </p:spPr>
         <p:txBody>
-          <a:bodyPr wrap="square">
+          <a:bodyPr wrap="square" anchor="ctr">
             <a:spAutoFit/>
           </a:bodyPr>
           <a:lstStyle/>
@@ -14784,7 +14784,7 @@
           <a:noFill/>
         </p:spPr>
         <p:txBody>
-          <a:bodyPr wrap="square">
+          <a:bodyPr wrap="square" anchor="ctr">
             <a:spAutoFit/>
           </a:bodyPr>
           <a:lstStyle/>
@@ -14974,7 +14974,7 @@
           <a:noFill/>
         </p:spPr>
         <p:txBody>
-          <a:bodyPr wrap="square">
+          <a:bodyPr wrap="square" anchor="ctr">
             <a:spAutoFit/>
           </a:bodyPr>
           <a:lstStyle/>
@@ -15164,7 +15164,7 @@
           <a:noFill/>
         </p:spPr>
         <p:txBody>
-          <a:bodyPr wrap="square">
+          <a:bodyPr wrap="square" anchor="ctr">
             <a:spAutoFit/>
           </a:bodyPr>
           <a:lstStyle/>
@@ -15251,7 +15251,7 @@
           <a:p>
             <a:pPr algn="ctr"/>
             <a:r>
-              <a:rPr sz="1600" b="1">
+              <a:rPr sz="1600" b="0">
                 <a:solidFill>
                   <a:srgbClr val="566070"/>
                 </a:solidFill>
@@ -15483,7 +15483,7 @@
           <a:noFill/>
         </p:spPr>
         <p:txBody>
-          <a:bodyPr wrap="square">
+          <a:bodyPr wrap="square" anchor="ctr">
             <a:spAutoFit/>
           </a:bodyPr>
           <a:lstStyle/>
@@ -15744,7 +15744,7 @@
           <a:noFill/>
         </p:spPr>
         <p:txBody>
-          <a:bodyPr wrap="square">
+          <a:bodyPr wrap="square" anchor="ctr">
             <a:spAutoFit/>
           </a:bodyPr>
           <a:lstStyle/>
@@ -15786,7 +15786,7 @@
           <a:noFill/>
         </p:spPr>
         <p:txBody>
-          <a:bodyPr wrap="square">
+          <a:bodyPr wrap="square" anchor="ctr">
             <a:spAutoFit/>
           </a:bodyPr>
           <a:lstStyle/>
@@ -15957,7 +15957,7 @@
           <a:noFill/>
         </p:spPr>
         <p:txBody>
-          <a:bodyPr wrap="square">
+          <a:bodyPr wrap="square" anchor="ctr">
             <a:spAutoFit/>
           </a:bodyPr>
           <a:lstStyle/>
@@ -16044,7 +16044,7 @@
           <a:p>
             <a:pPr algn="ctr"/>
             <a:r>
-              <a:rPr sz="1600" b="1">
+              <a:rPr sz="1600" b="0">
                 <a:solidFill>
                   <a:srgbClr val="566070"/>
                 </a:solidFill>
@@ -16233,7 +16233,7 @@
           <a:noFill/>
         </p:spPr>
         <p:txBody>
-          <a:bodyPr wrap="square">
+          <a:bodyPr wrap="square" anchor="ctr">
             <a:spAutoFit/>
           </a:bodyPr>
           <a:lstStyle/>
@@ -16423,7 +16423,7 @@
           <a:noFill/>
         </p:spPr>
         <p:txBody>
-          <a:bodyPr wrap="square">
+          <a:bodyPr wrap="square" anchor="ctr">
             <a:spAutoFit/>
           </a:bodyPr>
           <a:lstStyle/>
@@ -16632,7 +16632,7 @@
           <a:noFill/>
         </p:spPr>
         <p:txBody>
-          <a:bodyPr wrap="square">
+          <a:bodyPr wrap="square" anchor="ctr">
             <a:spAutoFit/>
           </a:bodyPr>
           <a:lstStyle/>
@@ -16841,7 +16841,7 @@
           <a:noFill/>
         </p:spPr>
         <p:txBody>
-          <a:bodyPr wrap="square">
+          <a:bodyPr wrap="square" anchor="ctr">
             <a:spAutoFit/>
           </a:bodyPr>
           <a:lstStyle/>
@@ -17076,7 +17076,7 @@
           <a:noFill/>
         </p:spPr>
         <p:txBody>
-          <a:bodyPr wrap="square">
+          <a:bodyPr wrap="square" anchor="ctr">
             <a:spAutoFit/>
           </a:bodyPr>
           <a:lstStyle/>
@@ -17285,7 +17285,7 @@
           <a:noFill/>
         </p:spPr>
         <p:txBody>
-          <a:bodyPr wrap="square">
+          <a:bodyPr wrap="square" anchor="ctr">
             <a:spAutoFit/>
           </a:bodyPr>
           <a:lstStyle/>
@@ -17372,7 +17372,7 @@
           <a:p>
             <a:pPr algn="ctr"/>
             <a:r>
-              <a:rPr sz="1600" b="1">
+              <a:rPr sz="1600" b="0">
                 <a:solidFill>
                   <a:srgbClr val="566070"/>
                 </a:solidFill>
@@ -17561,7 +17561,7 @@
           <a:noFill/>
         </p:spPr>
         <p:txBody>
-          <a:bodyPr wrap="square">
+          <a:bodyPr wrap="square" anchor="ctr">
             <a:spAutoFit/>
           </a:bodyPr>
           <a:lstStyle/>
@@ -17751,7 +17751,7 @@
           <a:noFill/>
         </p:spPr>
         <p:txBody>
-          <a:bodyPr wrap="square">
+          <a:bodyPr wrap="square" anchor="ctr">
             <a:spAutoFit/>
           </a:bodyPr>
           <a:lstStyle/>
@@ -18003,7 +18003,7 @@
           <a:noFill/>
         </p:spPr>
         <p:txBody>
-          <a:bodyPr wrap="square">
+          <a:bodyPr wrap="square" anchor="ctr">
             <a:spAutoFit/>
           </a:bodyPr>
           <a:lstStyle/>
@@ -18174,7 +18174,7 @@
           <a:noFill/>
         </p:spPr>
         <p:txBody>
-          <a:bodyPr wrap="square">
+          <a:bodyPr wrap="square" anchor="ctr">
             <a:spAutoFit/>
           </a:bodyPr>
           <a:lstStyle/>
@@ -18261,7 +18261,7 @@
           <a:p>
             <a:pPr algn="ctr"/>
             <a:r>
-              <a:rPr sz="1600" b="1">
+              <a:rPr sz="1600" b="0">
                 <a:solidFill>
                   <a:srgbClr val="566070"/>
                 </a:solidFill>
@@ -18540,7 +18540,7 @@
           <a:noFill/>
         </p:spPr>
         <p:txBody>
-          <a:bodyPr wrap="square">
+          <a:bodyPr wrap="square" anchor="ctr">
             <a:spAutoFit/>
           </a:bodyPr>
           <a:lstStyle/>
@@ -18582,7 +18582,7 @@
           <a:noFill/>
         </p:spPr>
         <p:txBody>
-          <a:bodyPr wrap="square">
+          <a:bodyPr wrap="square" anchor="ctr">
             <a:spAutoFit/>
           </a:bodyPr>
           <a:lstStyle/>

</xml_diff>

<commit_message>
Clean up Piti proof object surface copy
</commit_message>
<xml_diff>
--- a/outputs/pptx/ai_knowledge_institution_draft.pptx
+++ b/outputs/pptx/ai_knowledge_institution_draft.pptx
@@ -894,7 +894,7 @@
           </a:p>
           <a:p>
             <a:r>
-              <a:t>proof_object_type: article_quote</a:t>
+              <a:t>proof_object_type: source_card</a:t>
             </a:r>
           </a:p>
           <a:p>
@@ -925,12 +925,12 @@
           </a:p>
           <a:p>
             <a:r>
-              <a:t>  "틀린 가설을 세워보고, 다른 자료와 부딪히고, 왜 틀렸는지 고치는 시간이 사고를 만든다",</a:t>
-            </a:r>
-          </a:p>
-          <a:p>
-            <a:r>
-              <a:t>  "AI 역량 교육은 답을 받는 법보다 질문하고 평가하고 책임 있게 쓰는 법으로 확장될 필요가 있다"</a:t>
+              <a:t>  "틀린 가설을 세워보고",</a:t>
+            </a:r>
+          </a:p>
+          <a:p>
+            <a:r>
+              <a:t>  "AI 역량 교육은 답을 받는 법보다 질문하고 평가하고 책임 있게…"</a:t>
             </a:r>
           </a:p>
           <a:p>
@@ -1064,7 +1064,7 @@
           </a:p>
           <a:p>
             <a:r>
-              <a:t>  "type": "article_quote",</a:t>
+              <a:t>  "type": "source_card",</a:t>
             </a:r>
           </a:p>
           <a:p>
@@ -1079,7 +1079,7 @@
           </a:p>
           <a:p>
             <a:r>
-              <a:t>  "display_label": "[기사 인용]",</a:t>
+              <a:t>  "display_label": "[출처]",</a:t>
             </a:r>
           </a:p>
           <a:p>
@@ -1251,7 +1251,7 @@
           </a:p>
           <a:p>
             <a:r>
-              <a:t>proof_object_type: article_quote</a:t>
+              <a:t>proof_object_type: source_card</a:t>
             </a:r>
           </a:p>
           <a:p>
@@ -1282,12 +1282,7 @@
           </a:p>
           <a:p>
             <a:r>
-              <a:t>  "Royal Observatory 관련 보도는 AI 의존 경고를 인간 지식과 배움의 가치라는 맥락에 둔다",</a:t>
-            </a:r>
-          </a:p>
-          <a:p>
-            <a:r>
-              <a:t>  "이를 AI 반대가 아니라 질문과 검증의 필요성을 상기시키는 장면으로 사용한다",</a:t>
+              <a:t>  "이를 AI 반대가 아니라 질문과 검증의 필요성을 상기시키는 장면…",</a:t>
             </a:r>
           </a:p>
           <a:p>
@@ -1307,7 +1302,17 @@
           </a:p>
           <a:p>
             <a:r>
-              <a:t>[]</a:t>
+              <a:t>[</a:t>
+            </a:r>
+          </a:p>
+          <a:p>
+            <a:r>
+              <a:t>  "단일 기사 기반 맥락이므로 표현은 보수적으로 유지한다"</a:t>
+            </a:r>
+          </a:p>
+          <a:p>
+            <a:r>
+              <a:t>]</a:t>
             </a:r>
           </a:p>
           <a:p/>
@@ -1411,7 +1416,7 @@
           </a:p>
           <a:p>
             <a:r>
-              <a:t>  "type": "article_quote",</a:t>
+              <a:t>  "type": "source_card",</a:t>
             </a:r>
           </a:p>
           <a:p>
@@ -1426,7 +1431,7 @@
           </a:p>
           <a:p>
             <a:r>
-              <a:t>  "display_label": "[기사 인용]",</a:t>
+              <a:t>  "display_label": "[출처]",</a:t>
             </a:r>
           </a:p>
           <a:p>
@@ -2237,7 +2242,7 @@
           </a:p>
           <a:p>
             <a:r>
-              <a:t>proof_object_type: article_quote</a:t>
+              <a:t>proof_object_type: source_card</a:t>
             </a:r>
           </a:p>
           <a:p>
@@ -2268,12 +2273,7 @@
           </a:p>
           <a:p>
             <a:r>
-              <a:t>  "AI가 많은 정보를 설명할 수 있다면, 수업은 무엇을 외웠나보다 어떻게 확인했나를 더 물어야 할 수 있다",</a:t>
-            </a:r>
-          </a:p>
-          <a:p>
-            <a:r>
-              <a:t>  "OECD와 UNESCO 자료는 AI 교육을 교수 원칙과 학생 역량의 문제로 다룬다"</a:t>
+              <a:t>  "AI가 많은 정보를 설명할 수 있다면"</a:t>
             </a:r>
           </a:p>
           <a:p>
@@ -2293,6 +2293,11 @@
           </a:p>
           <a:p>
             <a:r>
+              <a:t>  "OECD와 UNESCO 자료는 AI 교육을 교수 원칙과 학생 역량의 문제로 다룬다",</a:t>
+            </a:r>
+          </a:p>
+          <a:p>
+            <a:r>
               <a:t>  "다만 교육 효과는 아직 단정하지 않고, 수업 설계의 과제로 남긴다"</a:t>
             </a:r>
           </a:p>
@@ -2407,7 +2412,7 @@
           </a:p>
           <a:p>
             <a:r>
-              <a:t>  "type": "article_quote",</a:t>
+              <a:t>  "type": "source_card",</a:t>
             </a:r>
           </a:p>
           <a:p>
@@ -2422,7 +2427,7 @@
           </a:p>
           <a:p>
             <a:r>
-              <a:t>  "display_label": "[기사 인용]",</a:t>
+              <a:t>  "display_label": "[출처]",</a:t>
             </a:r>
           </a:p>
           <a:p>
@@ -2594,7 +2599,7 @@
           </a:p>
           <a:p>
             <a:r>
-              <a:t>proof_object_type: article_quote</a:t>
+              <a:t>proof_object_type: source_card</a:t>
             </a:r>
           </a:p>
           <a:p>
@@ -2630,7 +2635,7 @@
           </a:p>
           <a:p>
             <a:r>
-              <a:t>  "그렇다면 박물관·과학관은 맥락, 경험, 질문, 토론을 더 강조해야 할 수 있다"</a:t>
+              <a:t>  "그렇다면 박물관·과학관은 맥락"</a:t>
             </a:r>
           </a:p>
           <a:p>
@@ -2764,7 +2769,7 @@
           </a:p>
           <a:p>
             <a:r>
-              <a:t>  "type": "article_quote",</a:t>
+              <a:t>  "type": "source_card",</a:t>
             </a:r>
           </a:p>
           <a:p>
@@ -2779,7 +2784,7 @@
           </a:p>
           <a:p>
             <a:r>
-              <a:t>  "display_label": "[기사 인용]",</a:t>
+              <a:t>  "display_label": "[출처]",</a:t>
             </a:r>
           </a:p>
           <a:p>
@@ -2957,7 +2962,7 @@
           </a:p>
           <a:p>
             <a:r>
-              <a:t>proof_object_type: article_quote</a:t>
+              <a:t>proof_object_type: source_card</a:t>
             </a:r>
           </a:p>
           <a:p>
@@ -2993,7 +2998,7 @@
           </a:p>
           <a:p>
             <a:r>
-              <a:t>  "하지만 밤하늘을 관찰하고, 위치를 추정하고, 계절과 시간을 연결하는 경험은 다르다"</a:t>
+              <a:t>  ""</a:t>
             </a:r>
           </a:p>
           <a:p>
@@ -3127,7 +3132,7 @@
           </a:p>
           <a:p>
             <a:r>
-              <a:t>  "type": "article_quote",</a:t>
+              <a:t>  "type": "source_card",</a:t>
             </a:r>
           </a:p>
           <a:p>
@@ -3142,7 +3147,7 @@
           </a:p>
           <a:p>
             <a:r>
-              <a:t>  "display_label": "[기사 인용]",</a:t>
+              <a:t>  "display_label": "[출처]",</a:t>
             </a:r>
           </a:p>
           <a:p>
@@ -3340,6 +3345,16 @@
           </a:p>
           <a:p>
             <a:r>
+              <a:t>[]</a:t>
+            </a:r>
+          </a:p>
+          <a:p>
+            <a:r>
+              <a:t>overflow_body_lines:</a:t>
+            </a:r>
+          </a:p>
+          <a:p>
+            <a:r>
               <a:t>[</a:t>
             </a:r>
           </a:p>
@@ -3361,16 +3376,6 @@
           <a:p>
             <a:r>
               <a:t>]</a:t>
-            </a:r>
-          </a:p>
-          <a:p>
-            <a:r>
-              <a:t>overflow_body_lines:</a:t>
-            </a:r>
-          </a:p>
-          <a:p>
-            <a:r>
-              <a:t>[]</a:t>
             </a:r>
           </a:p>
           <a:p/>
@@ -3707,12 +3712,12 @@
           </a:p>
           <a:p>
             <a:r>
-              <a:t>  "한국에서도 AI 디지털교과서와 AI 체험 전시가 이미 정책·기관 사례로 등장한다",</a:t>
-            </a:r>
-          </a:p>
-          <a:p>
-            <a:r>
-              <a:t>  "다만 한국 사례는 메인 논지의 증명이 아니라 후반 보조 연결로 사용한다"</a:t>
+              <a:t>  "한국에서도 AI 디지털교과서와 AI 체험 전시가 이미 정책·기관…",</a:t>
+            </a:r>
+          </a:p>
+          <a:p>
+            <a:r>
+              <a:t>  "핵심 질문은 한국도 결국 AI를 금지할지보다 어떻게 다룰지라는…"</a:t>
             </a:r>
           </a:p>
           <a:p>
@@ -4033,7 +4038,7 @@
           </a:p>
           <a:p>
             <a:r>
-              <a:t>proof_object_type: article_quote</a:t>
+              <a:t>proof_object_type: source_card</a:t>
             </a:r>
           </a:p>
           <a:p>
@@ -4198,7 +4203,7 @@
           </a:p>
           <a:p>
             <a:r>
-              <a:t>  "type": "article_quote",</a:t>
+              <a:t>  "type": "source_card",</a:t>
             </a:r>
           </a:p>
           <a:p>
@@ -4213,7 +4218,7 @@
           </a:p>
           <a:p>
             <a:r>
-              <a:t>  "display_label": "[기사 인용]",</a:t>
+              <a:t>  "display_label": "[출처]",</a:t>
             </a:r>
           </a:p>
           <a:p>
@@ -4375,7 +4380,7 @@
           </a:p>
           <a:p>
             <a:r>
-              <a:t>proof_object_type: article_quote</a:t>
+              <a:t>proof_object_type: source_card</a:t>
             </a:r>
           </a:p>
           <a:p>
@@ -4406,7 +4411,7 @@
           </a:p>
           <a:p>
             <a:r>
-              <a:t>  "모르는 것을 물으면 바로 답이 나오고, 검색 결과를 여러 개 열어보던 시간이 줄어든다",</a:t>
+              <a:t>  "모르는 것을 물으면 바로 답이 나오고",</a:t>
             </a:r>
           </a:p>
           <a:p>
@@ -4545,7 +4550,7 @@
           </a:p>
           <a:p>
             <a:r>
-              <a:t>  "type": "article_quote",</a:t>
+              <a:t>  "type": "source_card",</a:t>
             </a:r>
           </a:p>
           <a:p>
@@ -4560,7 +4565,7 @@
           </a:p>
           <a:p>
             <a:r>
-              <a:t>  "display_label": "[기사 인용]",</a:t>
+              <a:t>  "display_label": "[출처]",</a:t>
             </a:r>
           </a:p>
           <a:p>
@@ -5085,7 +5090,7 @@
           </a:p>
           <a:p>
             <a:r>
-              <a:t>  "반대로 AI는 학습 접근성과 개인화 가능성을 높일 수 있다는 주장도 있다"</a:t>
+              <a:t>  "반대로 AI는 학습 접근성과 개인화 가능성을 높일 수 있다는 주…"</a:t>
             </a:r>
           </a:p>
           <a:p>
@@ -5406,7 +5411,7 @@
           </a:p>
           <a:p>
             <a:r>
-              <a:t>proof_object_type: article_quote</a:t>
+              <a:t>proof_object_type: source_card</a:t>
             </a:r>
           </a:p>
           <a:p>
@@ -5437,12 +5442,12 @@
           </a:p>
           <a:p>
             <a:r>
-              <a:t>  "출처를 확인하는 법",</a:t>
-            </a:r>
-          </a:p>
-          <a:p>
-            <a:r>
-              <a:t>  "AI 답변의 빈틈을 찾는 법"</a:t>
+              <a:t>  "AI 답변의 빈틈을 찾는 법",</a:t>
+            </a:r>
+          </a:p>
+          <a:p>
+            <a:r>
+              <a:t>  "다른 자료와 비교하는 법"</a:t>
             </a:r>
           </a:p>
           <a:p>
@@ -5581,7 +5586,7 @@
           </a:p>
           <a:p>
             <a:r>
-              <a:t>  "type": "article_quote",</a:t>
+              <a:t>  "type": "source_card",</a:t>
             </a:r>
           </a:p>
           <a:p>
@@ -5596,7 +5601,7 @@
           </a:p>
           <a:p>
             <a:r>
-              <a:t>  "display_label": "[기사 인용]",</a:t>
+              <a:t>  "display_label": "[출처]",</a:t>
             </a:r>
           </a:p>
           <a:p>
@@ -6583,11 +6588,6 @@
           </a:p>
           <a:p>
             <a:r>
-              <a:t>  "답의 출처를 확인하고",</a:t>
-            </a:r>
-          </a:p>
-          <a:p>
-            <a:r>
               <a:t>  "모르는 것을 남겨두는 법을 배우는 일일지도 모른다"</a:t>
             </a:r>
           </a:p>
@@ -6603,7 +6603,17 @@
           </a:p>
           <a:p>
             <a:r>
-              <a:t>[]</a:t>
+              <a:t>[</a:t>
+            </a:r>
+          </a:p>
+          <a:p>
+            <a:r>
+              <a:t>  "모르는 것을 남겨두는 법을 배우는 일일지도 모른다"</a:t>
+            </a:r>
+          </a:p>
+          <a:p>
+            <a:r>
+              <a:t>]</a:t>
             </a:r>
           </a:p>
           <a:p/>
@@ -7196,7 +7206,7 @@
           </a:p>
           <a:p>
             <a:r>
-              <a:t>proof_object_type: article_quote</a:t>
+              <a:t>proof_object_type: source_card</a:t>
             </a:r>
           </a:p>
           <a:p>
@@ -7227,12 +7237,27 @@
           </a:p>
           <a:p>
             <a:r>
-              <a:t>  "BBC 보도는 Royal Observatory 쪽 경고를 AI 의존과 인간 지식의 역할이라는 맥락에서 소개한다",</a:t>
-            </a:r>
-          </a:p>
-          <a:p>
-            <a:r>
-              <a:t>  "이 메시지는 AI 금지가 아니라, 답을 받는 사람이 무엇을 배워야 하느냐는 질문으로 읽는다",</a:t>
+              <a:t>  "이 메시지는 AI 금지가 아니라",</a:t>
+            </a:r>
+          </a:p>
+          <a:p>
+            <a:r>
+              <a:t>  "단일 기관 사례이므로 모든 지식기관의 공식 입장처럼 일반화하지…"</a:t>
+            </a:r>
+          </a:p>
+          <a:p>
+            <a:r>
+              <a:t>]</a:t>
+            </a:r>
+          </a:p>
+          <a:p>
+            <a:r>
+              <a:t>overflow_body_lines:</a:t>
+            </a:r>
+          </a:p>
+          <a:p>
+            <a:r>
+              <a:t>[</a:t>
             </a:r>
           </a:p>
           <a:p>
@@ -7245,16 +7270,6 @@
               <a:t>]</a:t>
             </a:r>
           </a:p>
-          <a:p>
-            <a:r>
-              <a:t>overflow_body_lines:</a:t>
-            </a:r>
-          </a:p>
-          <a:p>
-            <a:r>
-              <a:t>[]</a:t>
-            </a:r>
-          </a:p>
           <a:p/>
           <a:p>
             <a:r>
@@ -7356,7 +7371,7 @@
           </a:p>
           <a:p>
             <a:r>
-              <a:t>  "type": "article_quote",</a:t>
+              <a:t>  "type": "source_card",</a:t>
             </a:r>
           </a:p>
           <a:p>
@@ -7371,7 +7386,7 @@
           </a:p>
           <a:p>
             <a:r>
-              <a:t>  "display_label": "[기사 인용]",</a:t>
+              <a:t>  "display_label": "[출처]",</a:t>
             </a:r>
           </a:p>
           <a:p>
@@ -7538,7 +7553,7 @@
           </a:p>
           <a:p>
             <a:r>
-              <a:t>proof_object_type: article_quote</a:t>
+              <a:t>proof_object_type: source_card</a:t>
             </a:r>
           </a:p>
           <a:p>
@@ -7574,7 +7589,7 @@
           </a:p>
           <a:p>
             <a:r>
-              <a:t>  "AI 즉답은 그 과정을 도와줄 수도, 일부 건너뛰게 만들 수도 있다"</a:t>
+              <a:t>  "AI 즉답은 그 과정을 도와줄 수도"</a:t>
             </a:r>
           </a:p>
           <a:p>
@@ -7708,7 +7723,7 @@
           </a:p>
           <a:p>
             <a:r>
-              <a:t>  "type": "article_quote",</a:t>
+              <a:t>  "type": "source_card",</a:t>
             </a:r>
           </a:p>
           <a:p>
@@ -7723,7 +7738,7 @@
           </a:p>
           <a:p>
             <a:r>
-              <a:t>  "display_label": "[기사 인용]",</a:t>
+              <a:t>  "display_label": "[출처]",</a:t>
             </a:r>
           </a:p>
           <a:p>
@@ -7926,12 +7941,12 @@
           </a:p>
           <a:p>
             <a:r>
-              <a:t>  "학교, 박물관, 도서관, 과학관도 AI가 설명을 대신하는 시대의 질문을 마주한다",</a:t>
-            </a:r>
-          </a:p>
-          <a:p>
-            <a:r>
-              <a:t>  "UNESCO와 OECD 자료는 AI 교육을 단순 도구 사용이 아니라 역량·원칙의 문제로 다룬다"</a:t>
+              <a:t>  "학교",</a:t>
+            </a:r>
+          </a:p>
+          <a:p>
+            <a:r>
+              <a:t>  "따라서 핵심은 답 제공 경쟁이 아니라 질문·검증·맥락을 가르치는…"</a:t>
             </a:r>
           </a:p>
           <a:p>
@@ -8288,11 +8303,6 @@
           </a:p>
           <a:p>
             <a:r>
-              <a:t>  "답을 의심하고 확인하는 능력인가",</a:t>
-            </a:r>
-          </a:p>
-          <a:p>
-            <a:r>
               <a:t>  "혹은 더 좋은 질문을 만드는 능력인가"</a:t>
             </a:r>
           </a:p>
@@ -8308,7 +8318,17 @@
           </a:p>
           <a:p>
             <a:r>
-              <a:t>[]</a:t>
+              <a:t>[</a:t>
+            </a:r>
+          </a:p>
+          <a:p>
+            <a:r>
+              <a:t>  "혹은 더 좋은 질문을 만드는 능력인가"</a:t>
+            </a:r>
+          </a:p>
+          <a:p>
+            <a:r>
+              <a:t>]</a:t>
             </a:r>
           </a:p>
           <a:p/>
@@ -8896,7 +8916,7 @@
           </a:p>
           <a:p>
             <a:r>
-              <a:t>proof_object_type: article_quote</a:t>
+              <a:t>proof_object_type: source_card</a:t>
             </a:r>
           </a:p>
           <a:p>
@@ -8927,11 +8947,6 @@
           </a:p>
           <a:p>
             <a:r>
-              <a:t>  "검색어를 바꿔보고, 여러 결과를 비교하고, 출처를 고르는 과정이 있었다",</a:t>
-            </a:r>
-          </a:p>
-          <a:p>
-            <a:r>
               <a:t>  "이 과정은 느리지만 정보 탐색의 다양성과 판단 훈련을 남긴다"</a:t>
             </a:r>
           </a:p>
@@ -8952,6 +8967,11 @@
           </a:p>
           <a:p>
             <a:r>
+              <a:t>  "이 과정은 느리지만 정보 탐색의 다양성과 판단 훈련을 남긴다",</a:t>
+            </a:r>
+          </a:p>
+          <a:p>
+            <a:r>
               <a:t>  "Microsoft Research 자료는 generative AI가 정보 탐색 다양성에 어떤 영향을 줄 수 있는지 문제를 제기한다"</a:t>
             </a:r>
           </a:p>
@@ -9061,7 +9081,7 @@
           </a:p>
           <a:p>
             <a:r>
-              <a:t>  "type": "article_quote",</a:t>
+              <a:t>  "type": "source_card",</a:t>
             </a:r>
           </a:p>
           <a:p>
@@ -9076,7 +9096,7 @@
           </a:p>
           <a:p>
             <a:r>
-              <a:t>  "display_label": "[기사 인용]",</a:t>
+              <a:t>  "display_label": "[출처]",</a:t>
             </a:r>
           </a:p>
           <a:p>
@@ -12760,7 +12780,7 @@
                 </a:solidFill>
                 <a:latin typeface="Malgun Gothic"/>
               </a:rPr>
-              <a:t>틀린 가설을 세워보고, 다른 자료와 부딪히고, 왜 틀렸는지 고치는 시간이 사고를 만든다</a:t>
+              <a:t>틀린 가설을 세워보고</a:t>
             </a:r>
           </a:p>
           <a:p>
@@ -12779,7 +12799,7 @@
                 </a:solidFill>
                 <a:latin typeface="Malgun Gothic"/>
               </a:rPr>
-              <a:t>AI 역량 교육은 답을 받는 법보다 질문하고 평가하고 책임 있게 쓰는 법으로 확장될 필요가 있다</a:t>
+              <a:t>AI 역량 교육은 답을 받는 법보다 질문하고 평가하고 책임 있게…</a:t>
             </a:r>
           </a:p>
         </p:txBody>
@@ -12833,7 +12853,7 @@
                 </a:solidFill>
                 <a:latin typeface="Malgun Gothic"/>
               </a:rPr>
-              <a:t>[기사 인용]</a:t>
+              <a:t>[출처]</a:t>
             </a:r>
           </a:p>
           <a:p>
@@ -12843,7 +12863,7 @@
               </a:spcBef>
             </a:pPr>
             <a:r>
-              <a:rPr sz="1800" b="1">
+              <a:rPr sz="2100" b="1">
                 <a:solidFill>
                   <a:srgbClr val="000000"/>
                 </a:solidFill>
@@ -12861,11 +12881,11 @@
             <a:r>
               <a:rPr sz="1400" b="0">
                 <a:solidFill>
-                  <a:srgbClr val="566070"/>
+                  <a:srgbClr val="373737"/>
                 </a:solidFill>
                 <a:latin typeface="Malgun Gothic"/>
               </a:rPr>
-              <a:t>생각은 결과가 아니라 중간 과정에 숨어 있다</a:t>
+              <a:t>Research, UNESCO AI Competency Framework.…</a:t>
             </a:r>
           </a:p>
         </p:txBody>
@@ -13081,26 +13101,7 @@
                 </a:solidFill>
                 <a:latin typeface="Malgun Gothic"/>
               </a:rPr>
-              <a:t>Royal Observatory 관련 보도는 AI 의존 경고를 인간 지식과 배움의 가치라는 맥락에 둔다</a:t>
-            </a:r>
-          </a:p>
-          <a:p>
-            <a:pPr>
-              <a:lnSpc>
-                <a:spcPct val="150000"/>
-              </a:lnSpc>
-              <a:spcAft>
-                <a:spcPts val="800"/>
-              </a:spcAft>
-            </a:pPr>
-            <a:r>
-              <a:rPr sz="2000" b="0" u="none">
-                <a:solidFill>
-                  <a:srgbClr val="181C23"/>
-                </a:solidFill>
-                <a:latin typeface="Malgun Gothic"/>
-              </a:rPr>
-              <a:t>이를 AI 반대가 아니라 질문과 검증의 필요성을 상기시키는 장면으로 사용한다</a:t>
+              <a:t>이를 AI 반대가 아니라 질문과 검증의 필요성을 상기시키는 장면…</a:t>
             </a:r>
           </a:p>
           <a:p>
@@ -13713,26 +13714,7 @@
                 </a:solidFill>
                 <a:latin typeface="Malgun Gothic"/>
               </a:rPr>
-              <a:t>AI가 많은 정보를 설명할 수 있다면, 수업은 무엇을 외웠나보다 어떻게 확인했나를 더 물어야 할 수 있다</a:t>
-            </a:r>
-          </a:p>
-          <a:p>
-            <a:pPr>
-              <a:lnSpc>
-                <a:spcPct val="150000"/>
-              </a:lnSpc>
-              <a:spcAft>
-                <a:spcPts val="800"/>
-              </a:spcAft>
-            </a:pPr>
-            <a:r>
-              <a:rPr sz="2000" b="0" u="none">
-                <a:solidFill>
-                  <a:srgbClr val="181C23"/>
-                </a:solidFill>
-                <a:latin typeface="Malgun Gothic"/>
-              </a:rPr>
-              <a:t>OECD와 UNESCO 자료는 AI 교육을 교수 원칙과 학생 역량의 문제로 다룬다</a:t>
+              <a:t>AI가 많은 정보를 설명할 수 있다면</a:t>
             </a:r>
           </a:p>
         </p:txBody>
@@ -13786,7 +13768,7 @@
                 </a:solidFill>
                 <a:latin typeface="Malgun Gothic"/>
               </a:rPr>
-              <a:t>[기사 인용]</a:t>
+              <a:t>[출처]</a:t>
             </a:r>
           </a:p>
           <a:p>
@@ -13796,7 +13778,7 @@
               </a:spcBef>
             </a:pPr>
             <a:r>
-              <a:rPr sz="1800" b="1">
+              <a:rPr sz="2100" b="1">
                 <a:solidFill>
                   <a:srgbClr val="000000"/>
                 </a:solidFill>
@@ -13814,11 +13796,11 @@
             <a:r>
               <a:rPr sz="1400" b="0">
                 <a:solidFill>
-                  <a:srgbClr val="566070"/>
+                  <a:srgbClr val="373737"/>
                 </a:solidFill>
                 <a:latin typeface="Malgun Gothic"/>
               </a:rPr>
-              <a:t>학교는 이제 정답 암기만으로 버티기 어렵다</a:t>
+              <a:t>Digital Education Outlook, UNESCO AI Comp…</a:t>
             </a:r>
           </a:p>
         </p:txBody>
@@ -14008,7 +13990,7 @@
                 </a:solidFill>
                 <a:latin typeface="Malgun Gothic"/>
               </a:rPr>
-              <a:t>그렇다면 박물관·과학관은 맥락, 경험, 질문, 토론을 더 강조해야 할 수 있다</a:t>
+              <a:t>그렇다면 박물관·과학관은 맥락</a:t>
             </a:r>
           </a:p>
         </p:txBody>
@@ -14062,7 +14044,7 @@
                 </a:solidFill>
                 <a:latin typeface="Malgun Gothic"/>
               </a:rPr>
-              <a:t>[기사 인용]</a:t>
+              <a:t>[출처]</a:t>
             </a:r>
           </a:p>
           <a:p>
@@ -14072,7 +14054,7 @@
               </a:spcBef>
             </a:pPr>
             <a:r>
-              <a:rPr sz="1800" b="1">
+              <a:rPr sz="2100" b="1">
                 <a:solidFill>
                   <a:srgbClr val="000000"/>
                 </a:solidFill>
@@ -14090,11 +14072,11 @@
             <a:r>
               <a:rPr sz="1400" b="0">
                 <a:solidFill>
-                  <a:srgbClr val="566070"/>
+                  <a:srgbClr val="373737"/>
                 </a:solidFill>
                 <a:latin typeface="Malgun Gothic"/>
               </a:rPr>
-              <a:t>박물관은 전시품 옆 설명문 이상의 것이 필요해진다</a:t>
+              <a:t>AI Competency Framework. National Science…</a:t>
             </a:r>
           </a:p>
         </p:txBody>
@@ -14277,15 +14259,6 @@
                 <a:spcPts val="800"/>
               </a:spcAft>
             </a:pPr>
-            <a:r>
-              <a:rPr sz="2000" b="0" u="none">
-                <a:solidFill>
-                  <a:srgbClr val="181C23"/>
-                </a:solidFill>
-                <a:latin typeface="Malgun Gothic"/>
-              </a:rPr>
-              <a:t>하지만 밤하늘을 관찰하고, 위치를 추정하고, 계절과 시간을 연결하는 경험은 다르다</a:t>
-            </a:r>
           </a:p>
         </p:txBody>
       </p:sp>
@@ -14338,7 +14311,7 @@
                 </a:solidFill>
                 <a:latin typeface="Malgun Gothic"/>
               </a:rPr>
-              <a:t>[기사 인용]</a:t>
+              <a:t>[출처]</a:t>
             </a:r>
           </a:p>
           <a:p>
@@ -14348,7 +14321,7 @@
               </a:spcBef>
             </a:pPr>
             <a:r>
-              <a:rPr sz="1800" b="1">
+              <a:rPr sz="2100" b="1">
                 <a:solidFill>
                   <a:srgbClr val="000000"/>
                 </a:solidFill>
@@ -14366,11 +14339,11 @@
             <a:r>
               <a:rPr sz="1400" b="0">
                 <a:solidFill>
-                  <a:srgbClr val="566070"/>
+                  <a:srgbClr val="373737"/>
                 </a:solidFill>
                 <a:latin typeface="Malgun Gothic"/>
               </a:rPr>
-              <a:t>천문관은 ‘별 이름’보다 ‘보는 법’을 가르치는 곳</a:t>
+              <a:t>Royal Observatory article. science museum…</a:t>
             </a:r>
           </a:p>
         </p:txBody>
@@ -14584,57 +14557,7 @@
               <a:lnSpc>
                 <a:spcPct val="150000"/>
               </a:lnSpc>
-              <a:spcAft>
-                <a:spcPts val="800"/>
-              </a:spcAft>
             </a:pPr>
-            <a:r>
-              <a:rPr sz="1700" b="0" u="none">
-                <a:solidFill>
-                  <a:srgbClr val="181C23"/>
-                </a:solidFill>
-                <a:latin typeface="Malgun Gothic"/>
-              </a:rPr>
-              <a:t>방송용 완성본에는 AI 검색 사용, 학교 AI 지침, 과학관·박물관 AI 활용 사례가 더 필요하다</a:t>
-            </a:r>
-          </a:p>
-          <a:p>
-            <a:pPr>
-              <a:lnSpc>
-                <a:spcPct val="150000"/>
-              </a:lnSpc>
-              <a:spcAft>
-                <a:spcPts val="800"/>
-              </a:spcAft>
-            </a:pPr>
-            <a:r>
-              <a:rPr sz="1700" b="0" u="none">
-                <a:solidFill>
-                  <a:srgbClr val="181C23"/>
-                </a:solidFill>
-                <a:latin typeface="Malgun Gothic"/>
-              </a:rPr>
-              <a:t>이번 enriched dry run은 OECD·정책브리핑·과학관 사례로 1차 틀만 보강한다</a:t>
-            </a:r>
-          </a:p>
-          <a:p>
-            <a:pPr>
-              <a:lnSpc>
-                <a:spcPct val="150000"/>
-              </a:lnSpc>
-              <a:spcAft>
-                <a:spcPts val="800"/>
-              </a:spcAft>
-            </a:pPr>
-            <a:r>
-              <a:rPr sz="1700" b="0" u="none">
-                <a:solidFill>
-                  <a:srgbClr val="181C23"/>
-                </a:solidFill>
-                <a:latin typeface="Malgun Gothic"/>
-              </a:rPr>
-              <a:t>정량 수치가 필요한 문장은 여전히 fact check 대상으로 남긴다</a:t>
-            </a:r>
           </a:p>
         </p:txBody>
       </p:sp>
@@ -14804,7 +14727,7 @@
                 </a:solidFill>
                 <a:latin typeface="Malgun Gothic"/>
               </a:rPr>
-              <a:t>한국에서도 AI 디지털교과서와 AI 체험 전시가 이미 정책·기관 사례로 등장한다</a:t>
+              <a:t>한국에서도 AI 디지털교과서와 AI 체험 전시가 이미 정책·기관…</a:t>
             </a:r>
           </a:p>
           <a:p>
@@ -14823,7 +14746,7 @@
                 </a:solidFill>
                 <a:latin typeface="Malgun Gothic"/>
               </a:rPr>
-              <a:t>다만 한국 사례는 메인 논지의 증명이 아니라 후반 보조 연결로 사용한다</a:t>
+              <a:t>핵심 질문은 한국도 결국 AI를 금지할지보다 어떻게 다룰지라는…</a:t>
             </a:r>
           </a:p>
         </p:txBody>
@@ -15184,7 +15107,7 @@
                 </a:solidFill>
                 <a:latin typeface="Malgun Gothic"/>
               </a:rPr>
-              <a:t>모르는 것을 물으면 바로 답이 나오고, 검색 결과를 여러 개 열어보던 시간이 줄어든다</a:t>
+              <a:t>모르는 것을 물으면 바로 답이 나오고</a:t>
             </a:r>
           </a:p>
           <a:p>
@@ -15257,7 +15180,7 @@
                 </a:solidFill>
                 <a:latin typeface="Malgun Gothic"/>
               </a:rPr>
-              <a:t>[기사 인용]</a:t>
+              <a:t>[출처]</a:t>
             </a:r>
           </a:p>
           <a:p>
@@ -15267,7 +15190,7 @@
               </a:spcBef>
             </a:pPr>
             <a:r>
-              <a:rPr sz="1800" b="1">
+              <a:rPr sz="2100" b="1">
                 <a:solidFill>
                   <a:srgbClr val="000000"/>
                 </a:solidFill>
@@ -15285,11 +15208,11 @@
             <a:r>
               <a:rPr sz="1400" b="0">
                 <a:solidFill>
-                  <a:srgbClr val="566070"/>
+                  <a:srgbClr val="373737"/>
                 </a:solidFill>
                 <a:latin typeface="Malgun Gothic"/>
               </a:rPr>
-              <a:t>AI가 답을 바로 주는 건 정말 편리하다</a:t>
+              <a:t>Research — generative AI and information…</a:t>
             </a:r>
           </a:p>
         </p:txBody>
@@ -15806,7 +15729,7 @@
                 </a:solidFill>
                 <a:latin typeface="Malgun Gothic"/>
               </a:rPr>
-              <a:t>반대로 AI는 학습 접근성과 개인화 가능성을 높일 수 있다는 주장도 있다</a:t>
+              <a:t>반대로 AI는 학습 접근성과 개인화 가능성을 높일 수 있다는 주…</a:t>
             </a:r>
           </a:p>
         </p:txBody>
@@ -15977,7 +15900,7 @@
                 </a:solidFill>
                 <a:latin typeface="Malgun Gothic"/>
               </a:rPr>
-              <a:t>출처를 확인하는 법</a:t>
+              <a:t>AI 답변의 빈틈을 찾는 법</a:t>
             </a:r>
           </a:p>
           <a:p>
@@ -15996,7 +15919,7 @@
                 </a:solidFill>
                 <a:latin typeface="Malgun Gothic"/>
               </a:rPr>
-              <a:t>AI 답변의 빈틈을 찾는 법</a:t>
+              <a:t>다른 자료와 비교하는 법</a:t>
             </a:r>
           </a:p>
         </p:txBody>
@@ -16050,7 +15973,7 @@
                 </a:solidFill>
                 <a:latin typeface="Malgun Gothic"/>
               </a:rPr>
-              <a:t>[기사 인용]</a:t>
+              <a:t>[출처]</a:t>
             </a:r>
           </a:p>
           <a:p>
@@ -16060,7 +15983,7 @@
               </a:spcBef>
             </a:pPr>
             <a:r>
-              <a:rPr sz="1800" b="1">
+              <a:rPr sz="2100" b="1">
                 <a:solidFill>
                   <a:srgbClr val="000000"/>
                 </a:solidFill>
@@ -16078,11 +16001,11 @@
             <a:r>
               <a:rPr sz="1400" b="0">
                 <a:solidFill>
-                  <a:srgbClr val="566070"/>
+                  <a:srgbClr val="373737"/>
                 </a:solidFill>
                 <a:latin typeface="Malgun Gothic"/>
               </a:rPr>
-              <a:t>그래서 가르쳐야 할 것은 ‘AI 정답’이 아니라 ‘AI 검산’</a:t>
+              <a:t>AI Competency Framework, Microsoft Resear…</a:t>
             </a:r>
           </a:p>
         </p:txBody>
@@ -16653,25 +16576,6 @@
                 <a:latin typeface="Malgun Gothic"/>
               </a:rPr>
               <a:t>좋은 질문을 만들고</a:t>
-            </a:r>
-          </a:p>
-          <a:p>
-            <a:pPr>
-              <a:lnSpc>
-                <a:spcPct val="150000"/>
-              </a:lnSpc>
-              <a:spcAft>
-                <a:spcPts val="800"/>
-              </a:spcAft>
-            </a:pPr>
-            <a:r>
-              <a:rPr sz="2300" b="0" u="none">
-                <a:solidFill>
-                  <a:srgbClr val="181C23"/>
-                </a:solidFill>
-                <a:latin typeface="Malgun Gothic"/>
-              </a:rPr>
-              <a:t>답의 출처를 확인하고</a:t>
             </a:r>
           </a:p>
           <a:p>
@@ -17096,7 +17000,7 @@
                 </a:solidFill>
                 <a:latin typeface="Malgun Gothic"/>
               </a:rPr>
-              <a:t>BBC 보도는 Royal Observatory 쪽 경고를 AI 의존과 인간 지식의 역할이라는 맥락에서 소개한다</a:t>
+              <a:t>이 메시지는 AI 금지가 아니라</a:t>
             </a:r>
           </a:p>
           <a:p>
@@ -17115,26 +17019,7 @@
                 </a:solidFill>
                 <a:latin typeface="Malgun Gothic"/>
               </a:rPr>
-              <a:t>이 메시지는 AI 금지가 아니라, 답을 받는 사람이 무엇을 배워야 하느냐는 질문으로 읽는다</a:t>
-            </a:r>
-          </a:p>
-          <a:p>
-            <a:pPr>
-              <a:lnSpc>
-                <a:spcPct val="150000"/>
-              </a:lnSpc>
-              <a:spcAft>
-                <a:spcPts val="800"/>
-              </a:spcAft>
-            </a:pPr>
-            <a:r>
-              <a:rPr sz="2000" b="0" u="none">
-                <a:solidFill>
-                  <a:srgbClr val="181C23"/>
-                </a:solidFill>
-                <a:latin typeface="Malgun Gothic"/>
-              </a:rPr>
-              <a:t>단일 기관 사례이므로 모든 지식기관의 공식 입장처럼 일반화하지 않는다</a:t>
+              <a:t>단일 기관 사례이므로 모든 지식기관의 공식 입장처럼 일반화하지…</a:t>
             </a:r>
           </a:p>
         </p:txBody>
@@ -17324,7 +17209,7 @@
                 </a:solidFill>
                 <a:latin typeface="Malgun Gothic"/>
               </a:rPr>
-              <a:t>AI 즉답은 그 과정을 도와줄 수도, 일부 건너뛰게 만들 수도 있다</a:t>
+              <a:t>AI 즉답은 그 과정을 도와줄 수도</a:t>
             </a:r>
           </a:p>
         </p:txBody>
@@ -17378,7 +17263,7 @@
                 </a:solidFill>
                 <a:latin typeface="Malgun Gothic"/>
               </a:rPr>
-              <a:t>[기사 인용]</a:t>
+              <a:t>[출처]</a:t>
             </a:r>
           </a:p>
           <a:p>
@@ -17388,7 +17273,7 @@
               </a:spcBef>
             </a:pPr>
             <a:r>
-              <a:rPr sz="1800" b="1">
+              <a:rPr sz="2100" b="1">
                 <a:solidFill>
                   <a:srgbClr val="000000"/>
                 </a:solidFill>
@@ -17406,11 +17291,11 @@
             <a:r>
               <a:rPr sz="1400" b="0">
                 <a:solidFill>
-                  <a:srgbClr val="566070"/>
+                  <a:srgbClr val="373737"/>
                 </a:solidFill>
                 <a:latin typeface="Malgun Gothic"/>
               </a:rPr>
-              <a:t>천문대가 왜 이런 말을 했을까</a:t>
+              <a:t>Royal Observatory article. Microsoft Rese…</a:t>
             </a:r>
           </a:p>
         </p:txBody>
@@ -17581,7 +17466,7 @@
                 </a:solidFill>
                 <a:latin typeface="Malgun Gothic"/>
               </a:rPr>
-              <a:t>학교, 박물관, 도서관, 과학관도 AI가 설명을 대신하는 시대의 질문을 마주한다</a:t>
+              <a:t>학교</a:t>
             </a:r>
           </a:p>
           <a:p>
@@ -17600,7 +17485,7 @@
                 </a:solidFill>
                 <a:latin typeface="Malgun Gothic"/>
               </a:rPr>
-              <a:t>UNESCO와 OECD 자료는 AI 교육을 단순 도구 사용이 아니라 역량·원칙의 문제로 다룬다</a:t>
+              <a:t>따라서 핵심은 답 제공 경쟁이 아니라 질문·검증·맥락을 가르치는…</a:t>
             </a:r>
           </a:p>
         </p:txBody>
@@ -17772,25 +17657,6 @@
                 <a:latin typeface="Malgun Gothic"/>
               </a:rPr>
               <a:t>답을 아는 능력인가</a:t>
-            </a:r>
-          </a:p>
-          <a:p>
-            <a:pPr>
-              <a:lnSpc>
-                <a:spcPct val="150000"/>
-              </a:lnSpc>
-              <a:spcAft>
-                <a:spcPts val="800"/>
-              </a:spcAft>
-            </a:pPr>
-            <a:r>
-              <a:rPr sz="2300" b="0" u="none">
-                <a:solidFill>
-                  <a:srgbClr val="181C23"/>
-                </a:solidFill>
-                <a:latin typeface="Malgun Gothic"/>
-              </a:rPr>
-              <a:t>답을 의심하고 확인하는 능력인가</a:t>
             </a:r>
           </a:p>
           <a:p>
@@ -18178,25 +18044,6 @@
             <a:spAutoFit/>
           </a:bodyPr>
           <a:lstStyle/>
-          <a:p>
-            <a:pPr>
-              <a:lnSpc>
-                <a:spcPct val="150000"/>
-              </a:lnSpc>
-              <a:spcAft>
-                <a:spcPts val="800"/>
-              </a:spcAft>
-            </a:pPr>
-            <a:r>
-              <a:rPr sz="2000" b="0" u="none">
-                <a:solidFill>
-                  <a:srgbClr val="181C23"/>
-                </a:solidFill>
-                <a:latin typeface="Malgun Gothic"/>
-              </a:rPr>
-              <a:t>검색어를 바꿔보고, 여러 결과를 비교하고, 출처를 고르는 과정이 있었다</a:t>
-            </a:r>
-          </a:p>
           <a:p>
             <a:pPr>
               <a:lnSpc>
@@ -18267,7 +18114,7 @@
                 </a:solidFill>
                 <a:latin typeface="Malgun Gothic"/>
               </a:rPr>
-              <a:t>[기사 인용]</a:t>
+              <a:t>[출처]</a:t>
             </a:r>
           </a:p>
           <a:p>
@@ -18277,7 +18124,7 @@
               </a:spcBef>
             </a:pPr>
             <a:r>
-              <a:rPr sz="1800" b="1">
+              <a:rPr sz="2100" b="1">
                 <a:solidFill>
                   <a:srgbClr val="000000"/>
                 </a:solidFill>
@@ -18295,11 +18142,11 @@
             <a:r>
               <a:rPr sz="1400" b="0">
                 <a:solidFill>
-                  <a:srgbClr val="566070"/>
+                  <a:srgbClr val="373737"/>
                 </a:solidFill>
                 <a:latin typeface="Malgun Gothic"/>
               </a:rPr>
-              <a:t>예전 검색은 귀찮았지만 흔적이 남았다</a:t>
+              <a:t>Research — information diversity in onlin…</a:t>
             </a:r>
           </a:p>
         </p:txBody>

</xml_diff>

<commit_message>
Refine Piti proof object semantics and screen copy
</commit_message>
<xml_diff>
--- a/outputs/pptx/ai_knowledge_institution_draft.pptx
+++ b/outputs/pptx/ai_knowledge_institution_draft.pptx
@@ -925,12 +925,7 @@
           </a:p>
           <a:p>
             <a:r>
-              <a:t>  "틀린 가설을 세워보고",</a:t>
-            </a:r>
-          </a:p>
-          <a:p>
-            <a:r>
-              <a:t>  "AI 역량 교육은 답을 받는 법보다 질문하고 평가하고 책임 있게…"</a:t>
+              <a:t>  "틀린 가설을 세워보고"</a:t>
             </a:r>
           </a:p>
           <a:p>
@@ -946,6 +941,11 @@
           <a:p>
             <a:r>
               <a:t>[</a:t>
+            </a:r>
+          </a:p>
+          <a:p>
+            <a:r>
+              <a:t>  "AI 역량 교육은 답을 받는 법보다 질문하고 평가하고 책임 있게 쓰는 법으로 확장될 필요가 있다",</a:t>
             </a:r>
           </a:p>
           <a:p>
@@ -1282,12 +1282,7 @@
           </a:p>
           <a:p>
             <a:r>
-              <a:t>  "이를 AI 반대가 아니라 질문과 검증의 필요성을 상기시키는 장면…",</a:t>
-            </a:r>
-          </a:p>
-          <a:p>
-            <a:r>
-              <a:t>  "단일 기사 기반 맥락이므로 표현은 보수적으로 유지한다"</a:t>
+              <a:t>  "이를 AI 반대가 아니라 질문과 검증의 필요성을 상기시키는 장면…"</a:t>
             </a:r>
           </a:p>
           <a:p>
@@ -1303,6 +1298,11 @@
           <a:p>
             <a:r>
               <a:t>[</a:t>
+            </a:r>
+          </a:p>
+          <a:p>
+            <a:r>
+              <a:t>  "이를 AI 반대가 아니라 질문과 검증의 필요성을 상기시키는 장면으로 사용한다",</a:t>
             </a:r>
           </a:p>
           <a:p>
@@ -2630,12 +2630,7 @@
           </a:p>
           <a:p>
             <a:r>
-              <a:t>  "설명 자체는 AI도 해줄 수 있다",</a:t>
-            </a:r>
-          </a:p>
-          <a:p>
-            <a:r>
-              <a:t>  "그렇다면 박물관·과학관은 맥락"</a:t>
+              <a:t>  "설명 자체는 AI도 해줄 수 있다"</a:t>
             </a:r>
           </a:p>
           <a:p>
@@ -2651,6 +2646,11 @@
           <a:p>
             <a:r>
               <a:t>[</a:t>
+            </a:r>
+          </a:p>
+          <a:p>
+            <a:r>
+              <a:t>  "그렇다면 박물관·과학관은 맥락, 경험, 질문, 토론을 더 강조해야 할 수 있다",</a:t>
             </a:r>
           </a:p>
           <a:p>
@@ -2993,12 +2993,7 @@
           </a:p>
           <a:p>
             <a:r>
-              <a:t>  "AI는 별자리 정보를 바로 줄 수 있다",</a:t>
-            </a:r>
-          </a:p>
-          <a:p>
-            <a:r>
-              <a:t>  ""</a:t>
+              <a:t>  "AI는 별자리 정보를 바로 줄 수 있다"</a:t>
             </a:r>
           </a:p>
           <a:p>
@@ -3014,6 +3009,11 @@
           <a:p>
             <a:r>
               <a:t>[</a:t>
+            </a:r>
+          </a:p>
+          <a:p>
+            <a:r>
+              <a:t>  "하지만 밤하늘을 관찰하고, 위치를 추정하고, 계절과 시간을 연결하는 경험은 다르다",</a:t>
             </a:r>
           </a:p>
           <a:p>
@@ -3707,32 +3707,27 @@
           </a:p>
           <a:p>
             <a:r>
+              <a:t>[]</a:t>
+            </a:r>
+          </a:p>
+          <a:p>
+            <a:r>
+              <a:t>overflow_body_lines:</a:t>
+            </a:r>
+          </a:p>
+          <a:p>
+            <a:r>
               <a:t>[</a:t>
             </a:r>
           </a:p>
           <a:p>
             <a:r>
-              <a:t>  "한국에서도 AI 디지털교과서와 AI 체험 전시가 이미 정책·기관…",</a:t>
-            </a:r>
-          </a:p>
-          <a:p>
-            <a:r>
-              <a:t>  "핵심 질문은 한국도 결국 AI를 금지할지보다 어떻게 다룰지라는…"</a:t>
-            </a:r>
-          </a:p>
-          <a:p>
-            <a:r>
-              <a:t>]</a:t>
-            </a:r>
-          </a:p>
-          <a:p>
-            <a:r>
-              <a:t>overflow_body_lines:</a:t>
-            </a:r>
-          </a:p>
-          <a:p>
-            <a:r>
-              <a:t>[</a:t>
+              <a:t>  "한국에서도 AI 디지털교과서와 AI 체험 전시가 이미 정책·기관 사례로 등장한다",</a:t>
+            </a:r>
+          </a:p>
+          <a:p>
+            <a:r>
+              <a:t>  "다만 한국 사례는 메인 논지의 증명이 아니라 후반 보조 연결로 사용한다",</a:t>
             </a:r>
           </a:p>
           <a:p>
@@ -4069,12 +4064,7 @@
           </a:p>
           <a:p>
             <a:r>
-              <a:t>  "AI가 답을 주는 건 막기 어렵다",</a:t>
-            </a:r>
-          </a:p>
-          <a:p>
-            <a:r>
-              <a:t>  "그렇다면 사람에게 남겨야 할 것은 답이 아니라 과정일 수 있다"</a:t>
+              <a:t>  "AI가 답을 주는 건 막기 어렵다"</a:t>
             </a:r>
           </a:p>
           <a:p>
@@ -4090,6 +4080,11 @@
           <a:p>
             <a:r>
               <a:t>[</a:t>
+            </a:r>
+          </a:p>
+          <a:p>
+            <a:r>
+              <a:t>  "그렇다면 사람에게 남겨야 할 것은 답이 아니라 과정일 수 있다",</a:t>
             </a:r>
           </a:p>
           <a:p>
@@ -4411,12 +4406,12 @@
           </a:p>
           <a:p>
             <a:r>
-              <a:t>  "모르는 것을 물으면 바로 답이 나오고",</a:t>
-            </a:r>
-          </a:p>
-          <a:p>
-            <a:r>
-              <a:t>  "AI는 접근성과 개인화 가능성도 넓힐 수 있다"</a:t>
+              <a:t>  "검색창을 열기도 전에",</a:t>
+            </a:r>
+          </a:p>
+          <a:p>
+            <a:r>
+              <a:t>  "답안지가 먼저 나온다"</a:t>
             </a:r>
           </a:p>
           <a:p>
@@ -5080,6 +5075,16 @@
           </a:p>
           <a:p>
             <a:r>
+              <a:t>[]</a:t>
+            </a:r>
+          </a:p>
+          <a:p>
+            <a:r>
+              <a:t>overflow_body_lines:</a:t>
+            </a:r>
+          </a:p>
+          <a:p>
+            <a:r>
               <a:t>[</a:t>
             </a:r>
           </a:p>
@@ -5090,22 +5095,7 @@
           </a:p>
           <a:p>
             <a:r>
-              <a:t>  "반대로 AI는 학습 접근성과 개인화 가능성을 높일 수 있다는 주…"</a:t>
-            </a:r>
-          </a:p>
-          <a:p>
-            <a:r>
-              <a:t>]</a:t>
-            </a:r>
-          </a:p>
-          <a:p>
-            <a:r>
-              <a:t>overflow_body_lines:</a:t>
-            </a:r>
-          </a:p>
-          <a:p>
-            <a:r>
-              <a:t>[</a:t>
+              <a:t>  "반대로 AI는 학습 접근성과 개인화 가능성을 높일 수 있다는 주장도 있다",</a:t>
             </a:r>
           </a:p>
           <a:p>
@@ -5442,27 +5432,27 @@
           </a:p>
           <a:p>
             <a:r>
+              <a:t>  "AI 답변의 빈틈을 찾는 법"</a:t>
+            </a:r>
+          </a:p>
+          <a:p>
+            <a:r>
+              <a:t>]</a:t>
+            </a:r>
+          </a:p>
+          <a:p>
+            <a:r>
+              <a:t>overflow_body_lines:</a:t>
+            </a:r>
+          </a:p>
+          <a:p>
+            <a:r>
+              <a:t>[</a:t>
+            </a:r>
+          </a:p>
+          <a:p>
+            <a:r>
               <a:t>  "AI 답변의 빈틈을 찾는 법",</a:t>
-            </a:r>
-          </a:p>
-          <a:p>
-            <a:r>
-              <a:t>  "다른 자료와 비교하는 법"</a:t>
-            </a:r>
-          </a:p>
-          <a:p>
-            <a:r>
-              <a:t>]</a:t>
-            </a:r>
-          </a:p>
-          <a:p>
-            <a:r>
-              <a:t>overflow_body_lines:</a:t>
-            </a:r>
-          </a:p>
-          <a:p>
-            <a:r>
-              <a:t>[</a:t>
             </a:r>
           </a:p>
           <a:p>
@@ -5809,6 +5799,16 @@
           </a:p>
           <a:p>
             <a:r>
+              <a:t>[]</a:t>
+            </a:r>
+          </a:p>
+          <a:p>
+            <a:r>
+              <a:t>overflow_body_lines:</a:t>
+            </a:r>
+          </a:p>
+          <a:p>
+            <a:r>
               <a:t>[</a:t>
             </a:r>
           </a:p>
@@ -5819,22 +5819,7 @@
           </a:p>
           <a:p>
             <a:r>
-              <a:t>  "더 멀리 보게 해줄 뿐, 어디를 볼지는 사람이 정한다"</a:t>
-            </a:r>
-          </a:p>
-          <a:p>
-            <a:r>
-              <a:t>]</a:t>
-            </a:r>
-          </a:p>
-          <a:p>
-            <a:r>
-              <a:t>overflow_body_lines:</a:t>
-            </a:r>
-          </a:p>
-          <a:p>
-            <a:r>
-              <a:t>[</a:t>
+              <a:t>  "더 멀리 보게 해줄 뿐, 어디를 볼지는 사람이 정한다",</a:t>
             </a:r>
           </a:p>
           <a:p>
@@ -7237,12 +7222,7 @@
           </a:p>
           <a:p>
             <a:r>
-              <a:t>  "이 메시지는 AI 금지가 아니라",</a:t>
-            </a:r>
-          </a:p>
-          <a:p>
-            <a:r>
-              <a:t>  "단일 기관 사례이므로 모든 지식기관의 공식 입장처럼 일반화하지…"</a:t>
+              <a:t>  "이 메시지는 AI 금지가 아니라"</a:t>
             </a:r>
           </a:p>
           <a:p>
@@ -7258,6 +7238,11 @@
           <a:p>
             <a:r>
               <a:t>[</a:t>
+            </a:r>
+          </a:p>
+          <a:p>
+            <a:r>
+              <a:t>  "이 메시지는 AI 금지가 아니라, 답을 받는 사람이 무엇을 배워야 하느냐는 질문으로 읽는다",</a:t>
             </a:r>
           </a:p>
           <a:p>
@@ -7584,12 +7569,7 @@
           </a:p>
           <a:p>
             <a:r>
-              <a:t>  "천문학은 답 하나보다 관찰·추론·검증의 과정이 중요한 분야다",</a:t>
-            </a:r>
-          </a:p>
-          <a:p>
-            <a:r>
-              <a:t>  "AI 즉답은 그 과정을 도와줄 수도"</a:t>
+              <a:t>  "천문학은 답 하나보다 관찰·추론·검증의 과정이 중요한 분야다"</a:t>
             </a:r>
           </a:p>
           <a:p>
@@ -7605,6 +7585,11 @@
           <a:p>
             <a:r>
               <a:t>[</a:t>
+            </a:r>
+          </a:p>
+          <a:p>
+            <a:r>
+              <a:t>  "AI 즉답은 그 과정을 도와줄 수도, 일부 건너뛰게 만들 수도 있다",</a:t>
             </a:r>
           </a:p>
           <a:p>
@@ -7936,32 +7921,27 @@
           </a:p>
           <a:p>
             <a:r>
+              <a:t>[]</a:t>
+            </a:r>
+          </a:p>
+          <a:p>
+            <a:r>
+              <a:t>overflow_body_lines:</a:t>
+            </a:r>
+          </a:p>
+          <a:p>
+            <a:r>
               <a:t>[</a:t>
             </a:r>
           </a:p>
           <a:p>
             <a:r>
-              <a:t>  "학교",</a:t>
-            </a:r>
-          </a:p>
-          <a:p>
-            <a:r>
-              <a:t>  "따라서 핵심은 답 제공 경쟁이 아니라 질문·검증·맥락을 가르치는…"</a:t>
-            </a:r>
-          </a:p>
-          <a:p>
-            <a:r>
-              <a:t>]</a:t>
-            </a:r>
-          </a:p>
-          <a:p>
-            <a:r>
-              <a:t>overflow_body_lines:</a:t>
-            </a:r>
-          </a:p>
-          <a:p>
-            <a:r>
-              <a:t>[</a:t>
+              <a:t>  "학교, 박물관, 도서관, 과학관도 AI가 설명을 대신하는 시대의 질문을 마주한다",</a:t>
+            </a:r>
+          </a:p>
+          <a:p>
+            <a:r>
+              <a:t>  "UNESCO와 OECD 자료는 AI 교육을 단순 도구 사용이 아니라 역량·원칙의 문제로 다룬다",</a:t>
             </a:r>
           </a:p>
           <a:p>
@@ -8947,7 +8927,12 @@
           </a:p>
           <a:p>
             <a:r>
-              <a:t>  "이 과정은 느리지만 정보 탐색의 다양성과 판단 훈련을 남긴다"</a:t>
+              <a:t>  "예전 검색은 느렸지만",</a:t>
+            </a:r>
+          </a:p>
+          <a:p>
+            <a:r>
+              <a:t>  "비교하는 흔적이 남았다"</a:t>
             </a:r>
           </a:p>
           <a:p>
@@ -8963,11 +8948,6 @@
           <a:p>
             <a:r>
               <a:t>[</a:t>
-            </a:r>
-          </a:p>
-          <a:p>
-            <a:r>
-              <a:t>  "이 과정은 느리지만 정보 탐색의 다양성과 판단 훈련을 남긴다",</a:t>
             </a:r>
           </a:p>
           <a:p>
@@ -9289,6 +9269,16 @@
           </a:p>
           <a:p>
             <a:r>
+              <a:t>[]</a:t>
+            </a:r>
+          </a:p>
+          <a:p>
+            <a:r>
+              <a:t>overflow_body_lines:</a:t>
+            </a:r>
+          </a:p>
+          <a:p>
+            <a:r>
               <a:t>[</a:t>
             </a:r>
           </a:p>
@@ -9299,22 +9289,7 @@
           </a:p>
           <a:p>
             <a:r>
-              <a:t>  "걱정되는 점: 비교·검증·실패의 경험이 줄어들 가능성이 있다"</a:t>
-            </a:r>
-          </a:p>
-          <a:p>
-            <a:r>
-              <a:t>]</a:t>
-            </a:r>
-          </a:p>
-          <a:p>
-            <a:r>
-              <a:t>overflow_body_lines:</a:t>
-            </a:r>
-          </a:p>
-          <a:p>
-            <a:r>
-              <a:t>[</a:t>
+              <a:t>  "걱정되는 점: 비교·검증·실패의 경험이 줄어들 가능성이 있다",</a:t>
             </a:r>
           </a:p>
           <a:p>
@@ -12783,25 +12758,6 @@
               <a:t>틀린 가설을 세워보고</a:t>
             </a:r>
           </a:p>
-          <a:p>
-            <a:pPr>
-              <a:lnSpc>
-                <a:spcPct val="150000"/>
-              </a:lnSpc>
-              <a:spcAft>
-                <a:spcPts val="800"/>
-              </a:spcAft>
-            </a:pPr>
-            <a:r>
-              <a:rPr sz="2000" b="0" u="none">
-                <a:solidFill>
-                  <a:srgbClr val="181C23"/>
-                </a:solidFill>
-                <a:latin typeface="Malgun Gothic"/>
-              </a:rPr>
-              <a:t>AI 역량 교육은 답을 받는 법보다 질문하고 평가하고 책임 있게…</a:t>
-            </a:r>
-          </a:p>
         </p:txBody>
       </p:sp>
       <p:sp>
@@ -12847,29 +12803,13 @@
           <a:p>
             <a:pPr algn="ctr"/>
             <a:r>
-              <a:rPr sz="1600" b="0">
-                <a:solidFill>
-                  <a:srgbClr val="566070"/>
-                </a:solidFill>
-                <a:latin typeface="Malgun Gothic"/>
-              </a:rPr>
-              <a:t>[출처]</a:t>
-            </a:r>
-          </a:p>
-          <a:p>
-            <a:pPr algn="ctr">
-              <a:spcBef>
-                <a:spcPts val="800"/>
-              </a:spcBef>
-            </a:pPr>
-            <a:r>
               <a:rPr sz="2100" b="1">
                 <a:solidFill>
                   <a:srgbClr val="000000"/>
                 </a:solidFill>
                 <a:latin typeface="Malgun Gothic"/>
               </a:rPr>
-              <a:t>Microsoft</a:t>
+              <a:t>Microsoft Research</a:t>
             </a:r>
           </a:p>
           <a:p>
@@ -12885,7 +12825,7 @@
                 </a:solidFill>
                 <a:latin typeface="Malgun Gothic"/>
               </a:rPr>
-              <a:t>Research, UNESCO AI Competency Framework.…</a:t>
+              <a:t>, UNESCO AI Competency Framework. 사고 과정 일…</a:t>
             </a:r>
           </a:p>
         </p:txBody>
@@ -13104,25 +13044,6 @@
               <a:t>이를 AI 반대가 아니라 질문과 검증의 필요성을 상기시키는 장면…</a:t>
             </a:r>
           </a:p>
-          <a:p>
-            <a:pPr>
-              <a:lnSpc>
-                <a:spcPct val="150000"/>
-              </a:lnSpc>
-              <a:spcAft>
-                <a:spcPts val="800"/>
-              </a:spcAft>
-            </a:pPr>
-            <a:r>
-              <a:rPr sz="2000" b="0" u="none">
-                <a:solidFill>
-                  <a:srgbClr val="181C23"/>
-                </a:solidFill>
-                <a:latin typeface="Malgun Gothic"/>
-              </a:rPr>
-              <a:t>단일 기사 기반 맥락이므로 표현은 보수적으로 유지한다</a:t>
-            </a:r>
-          </a:p>
         </p:txBody>
       </p:sp>
       <p:sp>
@@ -13762,22 +13683,6 @@
           <a:p>
             <a:pPr algn="ctr"/>
             <a:r>
-              <a:rPr sz="1600" b="0">
-                <a:solidFill>
-                  <a:srgbClr val="566070"/>
-                </a:solidFill>
-                <a:latin typeface="Malgun Gothic"/>
-              </a:rPr>
-              <a:t>[출처]</a:t>
-            </a:r>
-          </a:p>
-          <a:p>
-            <a:pPr algn="ctr">
-              <a:spcBef>
-                <a:spcPts val="800"/>
-              </a:spcBef>
-            </a:pPr>
-            <a:r>
               <a:rPr sz="2100" b="1">
                 <a:solidFill>
                   <a:srgbClr val="000000"/>
@@ -13972,25 +13877,6 @@
                 <a:latin typeface="Malgun Gothic"/>
               </a:rPr>
               <a:t>설명 자체는 AI도 해줄 수 있다</a:t>
-            </a:r>
-          </a:p>
-          <a:p>
-            <a:pPr>
-              <a:lnSpc>
-                <a:spcPct val="150000"/>
-              </a:lnSpc>
-              <a:spcAft>
-                <a:spcPts val="800"/>
-              </a:spcAft>
-            </a:pPr>
-            <a:r>
-              <a:rPr sz="2000" b="0" u="none">
-                <a:solidFill>
-                  <a:srgbClr val="181C23"/>
-                </a:solidFill>
-                <a:latin typeface="Malgun Gothic"/>
-              </a:rPr>
-              <a:t>그렇다면 박물관·과학관은 맥락</a:t>
             </a:r>
           </a:p>
         </p:txBody>
@@ -14038,22 +13924,6 @@
           <a:p>
             <a:pPr algn="ctr"/>
             <a:r>
-              <a:rPr sz="1600" b="0">
-                <a:solidFill>
-                  <a:srgbClr val="566070"/>
-                </a:solidFill>
-                <a:latin typeface="Malgun Gothic"/>
-              </a:rPr>
-              <a:t>[출처]</a:t>
-            </a:r>
-          </a:p>
-          <a:p>
-            <a:pPr algn="ctr">
-              <a:spcBef>
-                <a:spcPts val="800"/>
-              </a:spcBef>
-            </a:pPr>
-            <a:r>
               <a:rPr sz="2100" b="1">
                 <a:solidFill>
                   <a:srgbClr val="000000"/>
@@ -14249,16 +14119,6 @@
               </a:rPr>
               <a:t>AI는 별자리 정보를 바로 줄 수 있다</a:t>
             </a:r>
-          </a:p>
-          <a:p>
-            <a:pPr>
-              <a:lnSpc>
-                <a:spcPct val="150000"/>
-              </a:lnSpc>
-              <a:spcAft>
-                <a:spcPts val="800"/>
-              </a:spcAft>
-            </a:pPr>
           </a:p>
         </p:txBody>
       </p:sp>
@@ -14305,22 +14165,6 @@
           <a:p>
             <a:pPr algn="ctr"/>
             <a:r>
-              <a:rPr sz="1600" b="0">
-                <a:solidFill>
-                  <a:srgbClr val="566070"/>
-                </a:solidFill>
-                <a:latin typeface="Malgun Gothic"/>
-              </a:rPr>
-              <a:t>[출처]</a:t>
-            </a:r>
-          </a:p>
-          <a:p>
-            <a:pPr algn="ctr">
-              <a:spcBef>
-                <a:spcPts val="800"/>
-              </a:spcBef>
-            </a:pPr>
-            <a:r>
               <a:rPr sz="2100" b="1">
                 <a:solidFill>
                   <a:srgbClr val="000000"/>
@@ -14716,38 +14560,7 @@
               <a:lnSpc>
                 <a:spcPct val="150000"/>
               </a:lnSpc>
-              <a:spcAft>
-                <a:spcPts val="800"/>
-              </a:spcAft>
             </a:pPr>
-            <a:r>
-              <a:rPr sz="2300" b="0" u="none">
-                <a:solidFill>
-                  <a:srgbClr val="181C23"/>
-                </a:solidFill>
-                <a:latin typeface="Malgun Gothic"/>
-              </a:rPr>
-              <a:t>한국에서도 AI 디지털교과서와 AI 체험 전시가 이미 정책·기관…</a:t>
-            </a:r>
-          </a:p>
-          <a:p>
-            <a:pPr>
-              <a:lnSpc>
-                <a:spcPct val="150000"/>
-              </a:lnSpc>
-              <a:spcAft>
-                <a:spcPts val="800"/>
-              </a:spcAft>
-            </a:pPr>
-            <a:r>
-              <a:rPr sz="2300" b="0" u="none">
-                <a:solidFill>
-                  <a:srgbClr val="181C23"/>
-                </a:solidFill>
-                <a:latin typeface="Malgun Gothic"/>
-              </a:rPr>
-              <a:t>핵심 질문은 한국도 결국 AI를 금지할지보다 어떻게 다룰지라는…</a:t>
-            </a:r>
           </a:p>
         </p:txBody>
       </p:sp>
@@ -14920,25 +14733,6 @@
               <a:t>AI가 답을 주는 건 막기 어렵다</a:t>
             </a:r>
           </a:p>
-          <a:p>
-            <a:pPr>
-              <a:lnSpc>
-                <a:spcPct val="150000"/>
-              </a:lnSpc>
-              <a:spcAft>
-                <a:spcPts val="800"/>
-              </a:spcAft>
-            </a:pPr>
-            <a:r>
-              <a:rPr sz="2300" b="0" u="none">
-                <a:solidFill>
-                  <a:srgbClr val="181C23"/>
-                </a:solidFill>
-                <a:latin typeface="Malgun Gothic"/>
-              </a:rPr>
-              <a:t>그렇다면 사람에게 남겨야 할 것은 답이 아니라 과정일 수 있다</a:t>
-            </a:r>
-          </a:p>
         </p:txBody>
       </p:sp>
       <p:sp>
@@ -15107,7 +14901,7 @@
                 </a:solidFill>
                 <a:latin typeface="Malgun Gothic"/>
               </a:rPr>
-              <a:t>모르는 것을 물으면 바로 답이 나오고</a:t>
+              <a:t>검색창을 열기도 전에</a:t>
             </a:r>
           </a:p>
           <a:p>
@@ -15126,7 +14920,7 @@
                 </a:solidFill>
                 <a:latin typeface="Malgun Gothic"/>
               </a:rPr>
-              <a:t>AI는 접근성과 개인화 가능성도 넓힐 수 있다</a:t>
+              <a:t>답안지가 먼저 나온다</a:t>
             </a:r>
           </a:p>
         </p:txBody>
@@ -15174,29 +14968,13 @@
           <a:p>
             <a:pPr algn="ctr"/>
             <a:r>
-              <a:rPr sz="1600" b="0">
-                <a:solidFill>
-                  <a:srgbClr val="566070"/>
-                </a:solidFill>
-                <a:latin typeface="Malgun Gothic"/>
-              </a:rPr>
-              <a:t>[출처]</a:t>
-            </a:r>
-          </a:p>
-          <a:p>
-            <a:pPr algn="ctr">
-              <a:spcBef>
-                <a:spcPts val="800"/>
-              </a:spcBef>
-            </a:pPr>
-            <a:r>
               <a:rPr sz="2100" b="1">
                 <a:solidFill>
                   <a:srgbClr val="000000"/>
                 </a:solidFill>
                 <a:latin typeface="Malgun Gothic"/>
               </a:rPr>
-              <a:t>Microsoft</a:t>
+              <a:t>Microsoft Research</a:t>
             </a:r>
           </a:p>
           <a:p>
@@ -15212,7 +14990,7 @@
                 </a:solidFill>
                 <a:latin typeface="Malgun Gothic"/>
               </a:rPr>
-              <a:t>Research — generative AI and information…</a:t>
+              <a:t>generative AI and information diversity.…</a:t>
             </a:r>
           </a:p>
         </p:txBody>
@@ -15676,19 +15454,7 @@
               <a:lnSpc>
                 <a:spcPct val="150000"/>
               </a:lnSpc>
-              <a:spcAft>
-                <a:spcPts val="800"/>
-              </a:spcAft>
             </a:pPr>
-            <a:r>
-              <a:rPr sz="1900" b="0" u="none">
-                <a:solidFill>
-                  <a:srgbClr val="181C23"/>
-                </a:solidFill>
-                <a:latin typeface="Malgun Gothic"/>
-              </a:rPr>
-              <a:t>학생도, 직장인도, 관람객도 이미 AI와 함께 정보를 찾는다</a:t>
-            </a:r>
           </a:p>
         </p:txBody>
       </p:sp>
@@ -15718,19 +15484,7 @@
               <a:lnSpc>
                 <a:spcPct val="150000"/>
               </a:lnSpc>
-              <a:spcAft>
-                <a:spcPts val="800"/>
-              </a:spcAft>
             </a:pPr>
-            <a:r>
-              <a:rPr sz="1900" b="0" u="none">
-                <a:solidFill>
-                  <a:srgbClr val="181C23"/>
-                </a:solidFill>
-                <a:latin typeface="Malgun Gothic"/>
-              </a:rPr>
-              <a:t>반대로 AI는 학습 접근성과 개인화 가능성을 높일 수 있다는 주…</a:t>
-            </a:r>
           </a:p>
         </p:txBody>
       </p:sp>
@@ -15901,25 +15655,6 @@
                 <a:latin typeface="Malgun Gothic"/>
               </a:rPr>
               <a:t>AI 답변의 빈틈을 찾는 법</a:t>
-            </a:r>
-          </a:p>
-          <a:p>
-            <a:pPr>
-              <a:lnSpc>
-                <a:spcPct val="150000"/>
-              </a:lnSpc>
-              <a:spcAft>
-                <a:spcPts val="800"/>
-              </a:spcAft>
-            </a:pPr>
-            <a:r>
-              <a:rPr sz="2000" b="0" u="none">
-                <a:solidFill>
-                  <a:srgbClr val="181C23"/>
-                </a:solidFill>
-                <a:latin typeface="Malgun Gothic"/>
-              </a:rPr>
-              <a:t>다른 자료와 비교하는 법</a:t>
             </a:r>
           </a:p>
         </p:txBody>
@@ -15967,22 +15702,6 @@
           <a:p>
             <a:pPr algn="ctr"/>
             <a:r>
-              <a:rPr sz="1600" b="0">
-                <a:solidFill>
-                  <a:srgbClr val="566070"/>
-                </a:solidFill>
-                <a:latin typeface="Malgun Gothic"/>
-              </a:rPr>
-              <a:t>[출처]</a:t>
-            </a:r>
-          </a:p>
-          <a:p>
-            <a:pPr algn="ctr">
-              <a:spcBef>
-                <a:spcPts val="800"/>
-              </a:spcBef>
-            </a:pPr>
-            <a:r>
               <a:rPr sz="2100" b="1">
                 <a:solidFill>
                   <a:srgbClr val="000000"/>
@@ -16165,38 +15884,7 @@
               <a:lnSpc>
                 <a:spcPct val="150000"/>
               </a:lnSpc>
-              <a:spcAft>
-                <a:spcPts val="800"/>
-              </a:spcAft>
             </a:pPr>
-            <a:r>
-              <a:rPr sz="2300" b="0" u="none">
-                <a:solidFill>
-                  <a:srgbClr val="181C23"/>
-                </a:solidFill>
-                <a:latin typeface="Malgun Gothic"/>
-              </a:rPr>
-              <a:t>망원경은 하늘을 대신 봐주지 않는다</a:t>
-            </a:r>
-          </a:p>
-          <a:p>
-            <a:pPr>
-              <a:lnSpc>
-                <a:spcPct val="150000"/>
-              </a:lnSpc>
-              <a:spcAft>
-                <a:spcPts val="800"/>
-              </a:spcAft>
-            </a:pPr>
-            <a:r>
-              <a:rPr sz="2300" b="0" u="none">
-                <a:solidFill>
-                  <a:srgbClr val="181C23"/>
-                </a:solidFill>
-                <a:latin typeface="Malgun Gothic"/>
-              </a:rPr>
-              <a:t>더 멀리 보게 해줄 뿐, 어디를 볼지는 사람이 정한다</a:t>
-            </a:r>
           </a:p>
         </p:txBody>
       </p:sp>
@@ -17003,25 +16691,6 @@
               <a:t>이 메시지는 AI 금지가 아니라</a:t>
             </a:r>
           </a:p>
-          <a:p>
-            <a:pPr>
-              <a:lnSpc>
-                <a:spcPct val="150000"/>
-              </a:lnSpc>
-              <a:spcAft>
-                <a:spcPts val="800"/>
-              </a:spcAft>
-            </a:pPr>
-            <a:r>
-              <a:rPr sz="2000" b="0" u="none">
-                <a:solidFill>
-                  <a:srgbClr val="181C23"/>
-                </a:solidFill>
-                <a:latin typeface="Malgun Gothic"/>
-              </a:rPr>
-              <a:t>단일 기관 사례이므로 모든 지식기관의 공식 입장처럼 일반화하지…</a:t>
-            </a:r>
-          </a:p>
         </p:txBody>
       </p:sp>
       <p:sp>
@@ -17191,25 +16860,6 @@
                 <a:latin typeface="Malgun Gothic"/>
               </a:rPr>
               <a:t>천문학은 답 하나보다 관찰·추론·검증의 과정이 중요한 분야다</a:t>
-            </a:r>
-          </a:p>
-          <a:p>
-            <a:pPr>
-              <a:lnSpc>
-                <a:spcPct val="150000"/>
-              </a:lnSpc>
-              <a:spcAft>
-                <a:spcPts val="800"/>
-              </a:spcAft>
-            </a:pPr>
-            <a:r>
-              <a:rPr sz="2000" b="0" u="none">
-                <a:solidFill>
-                  <a:srgbClr val="181C23"/>
-                </a:solidFill>
-                <a:latin typeface="Malgun Gothic"/>
-              </a:rPr>
-              <a:t>AI 즉답은 그 과정을 도와줄 수도</a:t>
             </a:r>
           </a:p>
         </p:txBody>
@@ -17257,22 +16907,6 @@
           <a:p>
             <a:pPr algn="ctr"/>
             <a:r>
-              <a:rPr sz="1600" b="0">
-                <a:solidFill>
-                  <a:srgbClr val="566070"/>
-                </a:solidFill>
-                <a:latin typeface="Malgun Gothic"/>
-              </a:rPr>
-              <a:t>[출처]</a:t>
-            </a:r>
-          </a:p>
-          <a:p>
-            <a:pPr algn="ctr">
-              <a:spcBef>
-                <a:spcPts val="800"/>
-              </a:spcBef>
-            </a:pPr>
-            <a:r>
               <a:rPr sz="2100" b="1">
                 <a:solidFill>
                   <a:srgbClr val="000000"/>
@@ -17455,38 +17089,7 @@
               <a:lnSpc>
                 <a:spcPct val="150000"/>
               </a:lnSpc>
-              <a:spcAft>
-                <a:spcPts val="800"/>
-              </a:spcAft>
             </a:pPr>
-            <a:r>
-              <a:rPr sz="2300" b="0" u="none">
-                <a:solidFill>
-                  <a:srgbClr val="181C23"/>
-                </a:solidFill>
-                <a:latin typeface="Malgun Gothic"/>
-              </a:rPr>
-              <a:t>학교</a:t>
-            </a:r>
-          </a:p>
-          <a:p>
-            <a:pPr>
-              <a:lnSpc>
-                <a:spcPct val="150000"/>
-              </a:lnSpc>
-              <a:spcAft>
-                <a:spcPts val="800"/>
-              </a:spcAft>
-            </a:pPr>
-            <a:r>
-              <a:rPr sz="2300" b="0" u="none">
-                <a:solidFill>
-                  <a:srgbClr val="181C23"/>
-                </a:solidFill>
-                <a:latin typeface="Malgun Gothic"/>
-              </a:rPr>
-              <a:t>따라서 핵심은 답 제공 경쟁이 아니라 질문·검증·맥락을 가르치는…</a:t>
-            </a:r>
           </a:p>
         </p:txBody>
       </p:sp>
@@ -18060,7 +17663,26 @@
                 </a:solidFill>
                 <a:latin typeface="Malgun Gothic"/>
               </a:rPr>
-              <a:t>이 과정은 느리지만 정보 탐색의 다양성과 판단 훈련을 남긴다</a:t>
+              <a:t>예전 검색은 느렸지만</a:t>
+            </a:r>
+          </a:p>
+          <a:p>
+            <a:pPr>
+              <a:lnSpc>
+                <a:spcPct val="150000"/>
+              </a:lnSpc>
+              <a:spcAft>
+                <a:spcPts val="800"/>
+              </a:spcAft>
+            </a:pPr>
+            <a:r>
+              <a:rPr sz="2000" b="0" u="none">
+                <a:solidFill>
+                  <a:srgbClr val="181C23"/>
+                </a:solidFill>
+                <a:latin typeface="Malgun Gothic"/>
+              </a:rPr>
+              <a:t>비교하는 흔적이 남았다</a:t>
             </a:r>
           </a:p>
         </p:txBody>
@@ -18108,29 +17730,13 @@
           <a:p>
             <a:pPr algn="ctr"/>
             <a:r>
-              <a:rPr sz="1600" b="0">
-                <a:solidFill>
-                  <a:srgbClr val="566070"/>
-                </a:solidFill>
-                <a:latin typeface="Malgun Gothic"/>
-              </a:rPr>
-              <a:t>[출처]</a:t>
-            </a:r>
-          </a:p>
-          <a:p>
-            <a:pPr algn="ctr">
-              <a:spcBef>
-                <a:spcPts val="800"/>
-              </a:spcBef>
-            </a:pPr>
-            <a:r>
               <a:rPr sz="2100" b="1">
                 <a:solidFill>
                   <a:srgbClr val="000000"/>
                 </a:solidFill>
                 <a:latin typeface="Malgun Gothic"/>
               </a:rPr>
-              <a:t>Microsoft</a:t>
+              <a:t>Microsoft Research</a:t>
             </a:r>
           </a:p>
           <a:p>
@@ -18146,7 +17752,7 @@
                 </a:solidFill>
                 <a:latin typeface="Malgun Gothic"/>
               </a:rPr>
-              <a:t>Research — information diversity in onlin…</a:t>
+              <a:t>information diversity in online informati…</a:t>
             </a:r>
           </a:p>
         </p:txBody>
@@ -18396,19 +18002,7 @@
               <a:lnSpc>
                 <a:spcPct val="150000"/>
               </a:lnSpc>
-              <a:spcAft>
-                <a:spcPts val="800"/>
-              </a:spcAft>
             </a:pPr>
-            <a:r>
-              <a:rPr sz="1900" b="0" u="none">
-                <a:solidFill>
-                  <a:srgbClr val="181C23"/>
-                </a:solidFill>
-                <a:latin typeface="Malgun Gothic"/>
-              </a:rPr>
-              <a:t>좋은 점: 빠르고, 친절하고, 맥락을 이어준다</a:t>
-            </a:r>
           </a:p>
         </p:txBody>
       </p:sp>
@@ -18438,19 +18032,7 @@
               <a:lnSpc>
                 <a:spcPct val="150000"/>
               </a:lnSpc>
-              <a:spcAft>
-                <a:spcPts val="800"/>
-              </a:spcAft>
             </a:pPr>
-            <a:r>
-              <a:rPr sz="1900" b="0" u="none">
-                <a:solidFill>
-                  <a:srgbClr val="181C23"/>
-                </a:solidFill>
-                <a:latin typeface="Malgun Gothic"/>
-              </a:rPr>
-              <a:t>걱정되는 점: 비교·검증·실패의 경험이 줄어들 가능성이 있다</a:t>
-            </a:r>
           </a:p>
         </p:txBody>
       </p:sp>

</xml_diff>